<commit_message>
X1: the writeback model closes the DRAM-write gap -- 0.90 x/1.09
Dirty-line set + last-level eviction counting in the cache plugin (patch
refreshed in-repo). Write proxy = streaming bursts + dirty writebacks +
resident dirty lines. Six scattered-write apps moved from 0.02-0.09 to
0.73-1.03 against the DDR controller's write beats, reads untouched: write
fit 0.90 x/÷1.09, tighter than the read side. Deck rev 2 updated: DRAM
writes VALIDATED->USABLE (x1.11), mechanism table gains the X1 row, forward
path renumbered. RESULTS.md records the closure.
</commit_message>
<xml_diff>
--- a/xcheck/xcheck-correlation.pptx
+++ b/xcheck/xcheck-correlation.pptx
@@ -3828,7 +3828,7 @@
                         <a:rPr sz="1100" b="0">
                           <a:latin typeface="Calibri"/>
                         </a:rPr>
-                        <a:t>streaming class modelled (0.80); scattered writes exit via unmodelled dirty evictions</a:t>
+                        <a:t>proxy = 0.90 × silicon, ×/÷ 1.09 (X1 writeback model: streaming bursts + dirty evictions)</a:t>
                       </a:r>
                     </a:p>
                   </a:txBody>
@@ -3846,11 +3846,11 @@
                       <a:r>
                         <a:rPr sz="1100" b="0">
                           <a:solidFill>
-                            <a:srgbClr val="B06000"/>
+                            <a:srgbClr val="187A33"/>
                           </a:solidFill>
                           <a:latin typeface="Calibri"/>
                         </a:rPr>
-                        <a:t>GAP — writeback model next</a:t>
+                        <a:t>USABLE — apply ×1.11</a:t>
                       </a:r>
                     </a:p>
                   </a:txBody>
@@ -6919,7 +6919,7 @@
         </p:nvGraphicFramePr>
         <p:xfrm>
           <a:off x="548640" y="1463040"/>
-          <a:ext cx="11064240" cy="3401568"/>
+          <a:ext cx="11064240" cy="3968496"/>
         </p:xfrm>
         <a:graphic>
           <a:graphicData uri="http://schemas.openxmlformats.org/drawingml/2006/table">
@@ -7413,6 +7413,84 @@
                   </a:tcPr>
                 </a:tc>
               </a:tr>
+              <a:tr h="566928">
+                <a:tc>
+                  <a:txBody>
+                    <a:bodyPr/>
+                    <a:lstStyle/>
+                    <a:p>
+                      <a:r>
+                        <a:rPr sz="1050" b="1">
+                          <a:latin typeface="Calibri"/>
+                        </a:rPr>
+                        <a:t>writes 0.02–0.09 (v1)</a:t>
+                      </a:r>
+                    </a:p>
+                  </a:txBody>
+                  <a:tcPr>
+                    <a:solidFill>
+                      <a:srgbClr val="FFFFFF"/>
+                    </a:solidFill>
+                  </a:tcPr>
+                </a:tc>
+                <a:tc>
+                  <a:txBody>
+                    <a:bodyPr/>
+                    <a:lstStyle/>
+                    <a:p>
+                      <a:r>
+                        <a:rPr sz="1050" b="0">
+                          <a:latin typeface="Calibri"/>
+                        </a:rPr>
+                        <a:t>scattered stores exit DRAM as dirty EVICTIONS, which no allocation-time count can see</a:t>
+                      </a:r>
+                    </a:p>
+                  </a:txBody>
+                  <a:tcPr>
+                    <a:solidFill>
+                      <a:srgbClr val="FFFFFF"/>
+                    </a:solidFill>
+                  </a:tcPr>
+                </a:tc>
+                <a:tc>
+                  <a:txBody>
+                    <a:bodyPr/>
+                    <a:lstStyle/>
+                    <a:p>
+                      <a:r>
+                        <a:rPr sz="1050" b="0">
+                          <a:latin typeface="Calibri"/>
+                        </a:rPr>
+                        <a:t>X1: dirty-line set + last-level eviction counting</a:t>
+                      </a:r>
+                    </a:p>
+                  </a:txBody>
+                  <a:tcPr>
+                    <a:solidFill>
+                      <a:srgbClr val="FFFFFF"/>
+                    </a:solidFill>
+                  </a:tcPr>
+                </a:tc>
+                <a:tc>
+                  <a:txBody>
+                    <a:bodyPr/>
+                    <a:lstStyle/>
+                    <a:p>
+                      <a:r>
+                        <a:rPr sz="1050" b="0">
+                          <a:latin typeface="Calibri"/>
+                        </a:rPr>
+                        <a:t>0.90 ×/÷ 1.09</a:t>
+                      </a:r>
+                    </a:p>
+                  </a:txBody>
+                  <a:tcPr>
+                    <a:solidFill>
+                      <a:srgbClr val="FFFFFF"/>
+                    </a:solidFill>
+                  </a:tcPr>
+                </a:tc>
+              </a:tr>
             </a:tbl>
           </a:graphicData>
         </a:graphic>
@@ -7447,7 +7525,7 @@
                 </a:solidFill>
                 <a:latin typeface="Calibri"/>
               </a:rPr>
-              <a:t>The write side has the same shape one iteration behind: streaming writes land at 0.80, but scattered writes reach DRAM via dirty evictions the model does not count yet. The fix (a dirty-bit + writeback counter in the same plugin) is mechanical; it was out-scoped from this pass, not discovered missing.</a:t>
+              <a:t>The X1 row landed after this deck's first printing and proves the pattern: the named mechanism, implemented in an afternoon, moved six workloads from near-zero to 0.73–1.03 without touching the read side. Mechanism-first iteration converges; fudge-factor iteration doesn't.</a:t>
             </a:r>
           </a:p>
         </p:txBody>
@@ -8001,11 +8079,11 @@
                       <a:r>
                         <a:rPr sz="1100" b="0">
                           <a:solidFill>
-                            <a:srgbClr val="B06000"/>
+                            <a:srgbClr val="187A33"/>
                           </a:solidFill>
                           <a:latin typeface="Calibri"/>
                         </a:rPr>
-                        <a:t>streaming class only (0.80)</a:t>
+                        <a:t>use with ×1.11 correction</a:t>
                       </a:r>
                     </a:p>
                   </a:txBody>
@@ -8024,7 +8102,7 @@
                         <a:rPr sz="1100" b="0">
                           <a:latin typeface="Calibri"/>
                         </a:rPr>
-                        <a:t>writeback model required for the general case</a:t>
+                        <a:t>×/÷{SW:.2f} band above the write noise floor (X1 writeback model)</a:t>
                       </a:r>
                     </a:p>
                   </a:txBody>
@@ -8193,7 +8271,7 @@
                 </a:solidFill>
                 <a:latin typeface="Calibri"/>
               </a:rPr>
-              <a:t>Forward path, in effort order: (1) writeback model — closes the write gap; (2) prefetch model or fitted per-class factors — tightens the read band below ×/÷1.26; (3) system-mode boot-differential runs — brings kernel, DMA and duty cycle into scope, and enables the P1 power calibration on an instrumented board.</a:t>
+              <a:t>Forward path, in effort order: (1) X2 system-mode boot-differential runs — kernel, DMA and duty cycle into scope, P1 power calibration enabled; (2) X3 multi-core sweep; (3) X4 prefetch model or fitted per-class factors — tightens the read band below ×/÷1.26. (X1, the writeback model, closed the write gap the deck's first printing named.)</a:t>
             </a:r>
           </a:p>
         </p:txBody>

</xml_diff>

<commit_message>
X3: multi-core sweep closes -- correlation survives SMP, spin mechanism proven
Shared-L3 topology fix (the DSU's 512K is one cache, not one per core),
deterministic OpenMP workloads, 1/2/4/6 threads x 3 apps on both sides with
DDR beats per N. DRAM ratios are thread-count-invariant (mem rd 0.98 at every
N; sgm wr tightens to 0.96-0.98 under contention). The one outlier -- sgm-mt
instructions +23% at 4/6T -- was hypothesised as OpenMP barrier spin and
PROVEN by measurement: OMP_WAIT_POLICY=passive collapses 1.231 -> 0.985 with
DRAM proxies unmoved. Deck: multi-core INSUFFICIENT DATA -> USABLE; the
mechanism table gains the X3 row; duty cycle split out as the remaining
X2 item. compare_mt.py added.
</commit_message>
<xml_diff>
--- a/xcheck/xcheck-correlation.pptx
+++ b/xcheck/xcheck-correlation.pptx
@@ -3532,7 +3532,7 @@
         </p:nvGraphicFramePr>
         <p:xfrm>
           <a:off x="548640" y="1417320"/>
-          <a:ext cx="11064240" cy="3328416"/>
+          <a:ext cx="11064240" cy="3584448"/>
         </p:xfrm>
         <a:graphic>
           <a:graphicData uri="http://schemas.openxmlformats.org/drawingml/2006/table">
@@ -3545,14 +3545,14 @@
                 <a:gridCol w="5120640"/>
                 <a:gridCol w="3108960"/>
               </a:tblGrid>
-              <a:tr h="475488">
-                <a:tc>
-                  <a:txBody>
-                    <a:bodyPr/>
-                    <a:lstStyle/>
-                    <a:p>
-                      <a:r>
-                        <a:rPr sz="1100" b="1">
+              <a:tr h="512064">
+                <a:tc>
+                  <a:txBody>
+                    <a:bodyPr/>
+                    <a:lstStyle/>
+                    <a:p>
+                      <a:r>
+                        <a:rPr sz="1050" b="1">
                           <a:solidFill>
                             <a:srgbClr val="FFFFFF"/>
                           </a:solidFill>
@@ -3574,7 +3574,7 @@
                     <a:lstStyle/>
                     <a:p>
                       <a:r>
-                        <a:rPr sz="1100" b="1">
+                        <a:rPr sz="1050" b="1">
                           <a:solidFill>
                             <a:srgbClr val="FFFFFF"/>
                           </a:solidFill>
@@ -3596,7 +3596,7 @@
                     <a:lstStyle/>
                     <a:p>
                       <a:r>
-                        <a:rPr sz="1100" b="1">
+                        <a:rPr sz="1050" b="1">
                           <a:solidFill>
                             <a:srgbClr val="FFFFFF"/>
                           </a:solidFill>
@@ -3613,14 +3613,14 @@
                   </a:tcPr>
                 </a:tc>
               </a:tr>
-              <a:tr h="475488">
-                <a:tc>
-                  <a:txBody>
-                    <a:bodyPr/>
-                    <a:lstStyle/>
-                    <a:p>
-                      <a:r>
-                        <a:rPr sz="1100" b="1">
+              <a:tr h="512064">
+                <a:tc>
+                  <a:txBody>
+                    <a:bodyPr/>
+                    <a:lstStyle/>
+                    <a:p>
+                      <a:r>
+                        <a:rPr sz="1050" b="1">
                           <a:latin typeface="Calibri"/>
                         </a:rPr>
                         <a:t>Instruction activity, per core</a:t>
@@ -3639,7 +3639,7 @@
                     <a:lstStyle/>
                     <a:p>
                       <a:r>
-                        <a:rPr sz="1100" b="0">
+                        <a:rPr sz="1050" b="0">
                           <a:latin typeface="Calibri"/>
                         </a:rPr>
                         <a:t>0.98 – 1.06 across all 14 apps (0.997 on a 10.2 B-insn vision app)</a:t>
@@ -3658,7 +3658,7 @@
                     <a:lstStyle/>
                     <a:p>
                       <a:r>
-                        <a:rPr sz="1100" b="0">
+                        <a:rPr sz="1050" b="0">
                           <a:solidFill>
                             <a:srgbClr val="187A33"/>
                           </a:solidFill>
@@ -3675,14 +3675,14 @@
                   </a:tcPr>
                 </a:tc>
               </a:tr>
-              <a:tr h="475488">
-                <a:tc>
-                  <a:txBody>
-                    <a:bodyPr/>
-                    <a:lstStyle/>
-                    <a:p>
-                      <a:r>
-                        <a:rPr sz="1100" b="1">
+              <a:tr h="512064">
+                <a:tc>
+                  <a:txBody>
+                    <a:bodyPr/>
+                    <a:lstStyle/>
+                    <a:p>
+                      <a:r>
+                        <a:rPr sz="1050" b="1">
                           <a:latin typeface="Calibri"/>
                         </a:rPr>
                         <a:t>DRAM read traffic</a:t>
@@ -3701,7 +3701,7 @@
                     <a:lstStyle/>
                     <a:p>
                       <a:r>
-                        <a:rPr sz="1100" b="0">
+                        <a:rPr sz="1050" b="0">
                           <a:latin typeface="Calibri"/>
                         </a:rPr>
                         <a:t>proxy = 0.81 × silicon, geo-spread ×/÷ 1.26 (8 apps above noise floor)</a:t>
@@ -3720,7 +3720,7 @@
                     <a:lstStyle/>
                     <a:p>
                       <a:r>
-                        <a:rPr sz="1100" b="0">
+                        <a:rPr sz="1050" b="0">
                           <a:solidFill>
                             <a:srgbClr val="187A33"/>
                           </a:solidFill>
@@ -3737,14 +3737,14 @@
                   </a:tcPr>
                 </a:tc>
               </a:tr>
-              <a:tr h="475488">
-                <a:tc>
-                  <a:txBody>
-                    <a:bodyPr/>
-                    <a:lstStyle/>
-                    <a:p>
-                      <a:r>
-                        <a:rPr sz="1100" b="1">
+              <a:tr h="512064">
+                <a:tc>
+                  <a:txBody>
+                    <a:bodyPr/>
+                    <a:lstStyle/>
+                    <a:p>
+                      <a:r>
+                        <a:rPr sz="1050" b="1">
                           <a:latin typeface="Calibri"/>
                         </a:rPr>
                         <a:t>DRAM-quiet classification</a:t>
@@ -3763,7 +3763,7 @@
                     <a:lstStyle/>
                     <a:p>
                       <a:r>
-                        <a:rPr sz="1100" b="0">
+                        <a:rPr sz="1050" b="0">
                           <a:latin typeface="Calibri"/>
                         </a:rPr>
                         <a:t>5 low-traffic apps (alu, lua, lz4, pacman, sqlite) predicted quiet; silicon concurs</a:t>
@@ -3782,7 +3782,7 @@
                     <a:lstStyle/>
                     <a:p>
                       <a:r>
-                        <a:rPr sz="1100" b="0">
+                        <a:rPr sz="1050" b="0">
                           <a:solidFill>
                             <a:srgbClr val="187A33"/>
                           </a:solidFill>
@@ -3799,14 +3799,14 @@
                   </a:tcPr>
                 </a:tc>
               </a:tr>
-              <a:tr h="475488">
-                <a:tc>
-                  <a:txBody>
-                    <a:bodyPr/>
-                    <a:lstStyle/>
-                    <a:p>
-                      <a:r>
-                        <a:rPr sz="1100" b="1">
+              <a:tr h="512064">
+                <a:tc>
+                  <a:txBody>
+                    <a:bodyPr/>
+                    <a:lstStyle/>
+                    <a:p>
+                      <a:r>
+                        <a:rPr sz="1050" b="1">
                           <a:latin typeface="Calibri"/>
                         </a:rPr>
                         <a:t>DRAM write traffic</a:t>
@@ -3825,7 +3825,7 @@
                     <a:lstStyle/>
                     <a:p>
                       <a:r>
-                        <a:rPr sz="1100" b="0">
+                        <a:rPr sz="1050" b="0">
                           <a:latin typeface="Calibri"/>
                         </a:rPr>
                         <a:t>proxy = 0.90 × silicon, ×/÷ 1.09 (X1 writeback model: streaming bursts + dirty evictions)</a:t>
@@ -3844,7 +3844,7 @@
                     <a:lstStyle/>
                     <a:p>
                       <a:r>
-                        <a:rPr sz="1100" b="0">
+                        <a:rPr sz="1050" b="0">
                           <a:solidFill>
                             <a:srgbClr val="187A33"/>
                           </a:solidFill>
@@ -3861,14 +3861,14 @@
                   </a:tcPr>
                 </a:tc>
               </a:tr>
-              <a:tr h="475488">
-                <a:tc>
-                  <a:txBody>
-                    <a:bodyPr/>
-                    <a:lstStyle/>
-                    <a:p>
-                      <a:r>
-                        <a:rPr sz="1100" b="1">
+              <a:tr h="512064">
+                <a:tc>
+                  <a:txBody>
+                    <a:bodyPr/>
+                    <a:lstStyle/>
+                    <a:p>
+                      <a:r>
+                        <a:rPr sz="1050" b="1">
                           <a:latin typeface="Calibri"/>
                         </a:rPr>
                         <a:t>Kernel &amp; DMA activity</a:t>
@@ -3887,7 +3887,7 @@
                     <a:lstStyle/>
                     <a:p>
                       <a:r>
-                        <a:rPr sz="1100" b="0">
+                        <a:rPr sz="1050" b="0">
                           <a:latin typeface="Calibri"/>
                         </a:rPr>
                         <a:t>HTTP app: i-ratio 0.80, DRAM invisible — linux-user sees userspace only</a:t>
@@ -3906,7 +3906,7 @@
                     <a:lstStyle/>
                     <a:p>
                       <a:r>
-                        <a:rPr sz="1100" b="0">
+                        <a:rPr sz="1050" b="0">
                           <a:solidFill>
                             <a:srgbClr val="B06000"/>
                           </a:solidFill>
@@ -3923,14 +3923,14 @@
                   </a:tcPr>
                 </a:tc>
               </a:tr>
-              <a:tr h="475488">
-                <a:tc>
-                  <a:txBody>
-                    <a:bodyPr/>
-                    <a:lstStyle/>
-                    <a:p>
-                      <a:r>
-                        <a:rPr sz="1100" b="1">
+              <a:tr h="512064">
+                <a:tc>
+                  <a:txBody>
+                    <a:bodyPr/>
+                    <a:lstStyle/>
+                    <a:p>
+                      <a:r>
+                        <a:rPr sz="1050" b="1">
                           <a:latin typeface="Calibri"/>
                         </a:rPr>
                         <a:t>Multi-core</a:t>
@@ -3949,10 +3949,10 @@
                     <a:lstStyle/>
                     <a:p>
                       <a:r>
-                        <a:rPr sz="1100" b="0">
-                          <a:latin typeface="Calibri"/>
-                        </a:rPr>
-                        <a:t>first point only: 4-thread SGM totals within 2% of 1-thread</a:t>
+                        <a:rPr sz="1050" b="0">
+                          <a:latin typeface="Calibri"/>
+                        </a:rPr>
+                        <a:t>13-point sweep (1/2/4/6T × 3 apps): DRAM ratios thread-invariant (mem rd 0.98 at every N); the +23% insn outlier PROVEN to be OpenMP barrier spin (passive wait: 1.231 → 0.985)</a:t>
                       </a:r>
                     </a:p>
                   </a:txBody>
@@ -3968,13 +3968,13 @@
                     <a:lstStyle/>
                     <a:p>
                       <a:r>
-                        <a:rPr sz="1100" b="0">
+                        <a:rPr sz="1050" b="0">
                           <a:solidFill>
-                            <a:srgbClr val="5F6368"/>
+                            <a:srgbClr val="187A33"/>
                           </a:solidFill>
                           <a:latin typeface="Calibri"/>
                         </a:rPr>
-                        <a:t>INSUFFICIENT DATA</a:t>
+                        <a:t>USABLE — passive waiting on barrier-heavy code</a:t>
                       </a:r>
                     </a:p>
                   </a:txBody>
@@ -6919,7 +6919,7 @@
         </p:nvGraphicFramePr>
         <p:xfrm>
           <a:off x="548640" y="1463040"/>
-          <a:ext cx="11064240" cy="3968496"/>
+          <a:ext cx="11064240" cy="4096512"/>
         </p:xfrm>
         <a:graphic>
           <a:graphicData uri="http://schemas.openxmlformats.org/drawingml/2006/table">
@@ -6933,14 +6933,14 @@
                 <a:gridCol w="2377440"/>
                 <a:gridCol w="2148840"/>
               </a:tblGrid>
-              <a:tr h="566928">
-                <a:tc>
-                  <a:txBody>
-                    <a:bodyPr/>
-                    <a:lstStyle/>
-                    <a:p>
-                      <a:r>
-                        <a:rPr sz="1050" b="1">
+              <a:tr h="512064">
+                <a:tc>
+                  <a:txBody>
+                    <a:bodyPr/>
+                    <a:lstStyle/>
+                    <a:p>
+                      <a:r>
+                        <a:rPr sz="1000" b="1">
                           <a:solidFill>
                             <a:srgbClr val="FFFFFF"/>
                           </a:solidFill>
@@ -6962,7 +6962,7 @@
                     <a:lstStyle/>
                     <a:p>
                       <a:r>
-                        <a:rPr sz="1050" b="1">
+                        <a:rPr sz="1000" b="1">
                           <a:solidFill>
                             <a:srgbClr val="FFFFFF"/>
                           </a:solidFill>
@@ -6984,7 +6984,7 @@
                     <a:lstStyle/>
                     <a:p>
                       <a:r>
-                        <a:rPr sz="1050" b="1">
+                        <a:rPr sz="1000" b="1">
                           <a:solidFill>
                             <a:srgbClr val="FFFFFF"/>
                           </a:solidFill>
@@ -7006,7 +7006,7 @@
                     <a:lstStyle/>
                     <a:p>
                       <a:r>
-                        <a:rPr sz="1050" b="1">
+                        <a:rPr sz="1000" b="1">
                           <a:solidFill>
                             <a:srgbClr val="FFFFFF"/>
                           </a:solidFill>
@@ -7023,14 +7023,14 @@
                   </a:tcPr>
                 </a:tc>
               </a:tr>
-              <a:tr h="566928">
-                <a:tc>
-                  <a:txBody>
-                    <a:bodyPr/>
-                    <a:lstStyle/>
-                    <a:p>
-                      <a:r>
-                        <a:rPr sz="1050" b="1">
+              <a:tr h="512064">
+                <a:tc>
+                  <a:txBody>
+                    <a:bodyPr/>
+                    <a:lstStyle/>
+                    <a:p>
+                      <a:r>
+                        <a:rPr sz="1000" b="1">
                           <a:latin typeface="Calibri"/>
                         </a:rPr>
                         <a:t>mm read 0.44 (v0)</a:t>
@@ -7049,7 +7049,7 @@
                     <a:lstStyle/>
                     <a:p>
                       <a:r>
-                        <a:rPr sz="1050" b="0">
+                        <a:rPr sz="1000" b="0">
                           <a:latin typeface="Calibri"/>
                         </a:rPr>
                         <a:t>plugin default cache ≫ real 64 KiB L2 — model thought the working set was resident</a:t>
@@ -7068,7 +7068,7 @@
                     <a:lstStyle/>
                     <a:p>
                       <a:r>
-                        <a:rPr sz="1050" b="0">
+                        <a:rPr sz="1000" b="0">
                           <a:latin typeface="Calibri"/>
                         </a:rPr>
                         <a:t>model the sysfs hierarchy</a:t>
@@ -7087,7 +7087,7 @@
                     <a:lstStyle/>
                     <a:p>
                       <a:r>
-                        <a:rPr sz="1050" b="0">
+                        <a:rPr sz="1000" b="0">
                           <a:latin typeface="Calibri"/>
                         </a:rPr>
                         <a:t>0.65 (residual = prefetch)</a:t>
@@ -7101,14 +7101,14 @@
                   </a:tcPr>
                 </a:tc>
               </a:tr>
-              <a:tr h="566928">
-                <a:tc>
-                  <a:txBody>
-                    <a:bodyPr/>
-                    <a:lstStyle/>
-                    <a:p>
-                      <a:r>
-                        <a:rPr sz="1050" b="1">
+              <a:tr h="512064">
+                <a:tc>
+                  <a:txBody>
+                    <a:bodyPr/>
+                    <a:lstStyle/>
+                    <a:p>
+                      <a:r>
+                        <a:rPr sz="1000" b="1">
                           <a:latin typeface="Calibri"/>
                         </a:rPr>
                         <a:t>mem read 1.97 (v0)</a:t>
@@ -7127,7 +7127,7 @@
                     <a:lstStyle/>
                     <a:p>
                       <a:r>
-                        <a:rPr sz="1050" b="0">
+                        <a:rPr sz="1000" b="0">
                           <a:latin typeface="Calibri"/>
                         </a:rPr>
                         <a:t>A55 write-streaming: no-allocate store bursts; plugin read-allocated every store</a:t>
@@ -7146,7 +7146,7 @@
                     <a:lstStyle/>
                     <a:p>
                       <a:r>
-                        <a:rPr sz="1050" b="0">
+                        <a:rPr sz="1000" b="0">
                           <a:latin typeface="Calibri"/>
                         </a:rPr>
                         <a:t>streak detector, ≥4 lines → no-allocate</a:t>
@@ -7165,7 +7165,7 @@
                     <a:lstStyle/>
                     <a:p>
                       <a:r>
-                        <a:rPr sz="1050" b="0">
+                        <a:rPr sz="1000" b="0">
                           <a:latin typeface="Calibri"/>
                         </a:rPr>
                         <a:t>0.98</a:t>
@@ -7179,14 +7179,14 @@
                   </a:tcPr>
                 </a:tc>
               </a:tr>
-              <a:tr h="566928">
-                <a:tc>
-                  <a:txBody>
-                    <a:bodyPr/>
-                    <a:lstStyle/>
-                    <a:p>
-                      <a:r>
-                        <a:rPr sz="1050" b="1">
+              <a:tr h="512064">
+                <a:tc>
+                  <a:txBody>
+                    <a:bodyPr/>
+                    <a:lstStyle/>
+                    <a:p>
+                      <a:r>
+                        <a:rPr sz="1000" b="1">
                           <a:latin typeface="Calibri"/>
                         </a:rPr>
                         <a:t>sha256 'read 15×'</a:t>
@@ -7205,7 +7205,7 @@
                     <a:lstStyle/>
                     <a:p>
                       <a:r>
-                        <a:rPr sz="1050" b="0">
+                        <a:rPr sz="1000" b="0">
                           <a:latin typeface="Calibri"/>
                         </a:rPr>
                         <a:t>l3d_cache_refill counts demand only; the prefetcher served the stream invisibly</a:t>
@@ -7224,7 +7224,7 @@
                     <a:lstStyle/>
                     <a:p>
                       <a:r>
-                        <a:rPr sz="1050" b="0">
+                        <a:rPr sz="1000" b="0">
                           <a:latin typeface="Calibri"/>
                         </a:rPr>
                         <a:t>ground-truth at the DDR controller</a:t>
@@ -7243,7 +7243,7 @@
                     <a:lstStyle/>
                     <a:p>
                       <a:r>
-                        <a:rPr sz="1050" b="0">
+                        <a:rPr sz="1000" b="0">
                           <a:latin typeface="Calibri"/>
                         </a:rPr>
                         <a:t>0.77 (real gap, real sign)</a:t>
@@ -7257,14 +7257,14 @@
                   </a:tcPr>
                 </a:tc>
               </a:tr>
-              <a:tr h="566928">
-                <a:tc>
-                  <a:txBody>
-                    <a:bodyPr/>
-                    <a:lstStyle/>
-                    <a:p>
-                      <a:r>
-                        <a:rPr sz="1050" b="1">
+              <a:tr h="512064">
+                <a:tc>
+                  <a:txBody>
+                    <a:bodyPr/>
+                    <a:lstStyle/>
+                    <a:p>
+                      <a:r>
+                        <a:rPr sz="1000" b="1">
                           <a:latin typeface="Calibri"/>
                         </a:rPr>
                         <a:t>pacman/sqlite/lz4/lua ~0</a:t>
@@ -7283,7 +7283,7 @@
                     <a:lstStyle/>
                     <a:p>
                       <a:r>
-                        <a:rPr sz="1050" b="0">
+                        <a:rPr sz="1000" b="0">
                           <a:latin typeface="Calibri"/>
                         </a:rPr>
                         <a:t>true traffic below the DDR counter's ~0.4 M-line/window noise floor (calibrated by alu)</a:t>
@@ -7302,7 +7302,7 @@
                     <a:lstStyle/>
                     <a:p>
                       <a:r>
-                        <a:rPr sz="1050" b="0">
+                        <a:rPr sz="1000" b="0">
                           <a:latin typeface="Calibri"/>
                         </a:rPr>
                         <a:t>classify, don't fit</a:t>
@@ -7321,7 +7321,7 @@
                     <a:lstStyle/>
                     <a:p>
                       <a:r>
-                        <a:rPr sz="1050" b="0">
+                        <a:rPr sz="1000" b="0">
                           <a:latin typeface="Calibri"/>
                         </a:rPr>
                         <a:t>correctly predicted quiet</a:t>
@@ -7335,14 +7335,14 @@
                   </a:tcPr>
                 </a:tc>
               </a:tr>
-              <a:tr h="566928">
-                <a:tc>
-                  <a:txBody>
-                    <a:bodyPr/>
-                    <a:lstStyle/>
-                    <a:p>
-                      <a:r>
-                        <a:rPr sz="1050" b="1">
+              <a:tr h="512064">
+                <a:tc>
+                  <a:txBody>
+                    <a:bodyPr/>
+                    <a:lstStyle/>
+                    <a:p>
+                      <a:r>
+                        <a:rPr sz="1000" b="1">
                           <a:latin typeface="Calibri"/>
                         </a:rPr>
                         <a:t>bzip2 0.49</a:t>
@@ -7361,7 +7361,7 @@
                     <a:lstStyle/>
                     <a:p>
                       <a:r>
-                        <a:rPr sz="1050" b="0">
+                        <a:rPr sz="1000" b="0">
                           <a:latin typeface="Calibri"/>
                         </a:rPr>
                         <a:t>prefetcher over-fetch on semi-sequential patterns — silicon reads ~2× the demand traffic</a:t>
@@ -7380,7 +7380,7 @@
                     <a:lstStyle/>
                     <a:p>
                       <a:r>
-                        <a:rPr sz="1050" b="0">
+                        <a:rPr sz="1000" b="0">
                           <a:latin typeface="Calibri"/>
                         </a:rPr>
                         <a:t>prefetch model, or per-class factor</a:t>
@@ -7399,7 +7399,7 @@
                     <a:lstStyle/>
                     <a:p>
                       <a:r>
-                        <a:rPr sz="1050" b="0">
+                        <a:rPr sz="1000" b="0">
                           <a:latin typeface="Calibri"/>
                         </a:rPr>
                         <a:t>open, named</a:t>
@@ -7413,14 +7413,14 @@
                   </a:tcPr>
                 </a:tc>
               </a:tr>
-              <a:tr h="566928">
-                <a:tc>
-                  <a:txBody>
-                    <a:bodyPr/>
-                    <a:lstStyle/>
-                    <a:p>
-                      <a:r>
-                        <a:rPr sz="1050" b="1">
+              <a:tr h="512064">
+                <a:tc>
+                  <a:txBody>
+                    <a:bodyPr/>
+                    <a:lstStyle/>
+                    <a:p>
+                      <a:r>
+                        <a:rPr sz="1000" b="1">
                           <a:latin typeface="Calibri"/>
                         </a:rPr>
                         <a:t>writes 0.02–0.09 (v1)</a:t>
@@ -7439,7 +7439,7 @@
                     <a:lstStyle/>
                     <a:p>
                       <a:r>
-                        <a:rPr sz="1050" b="0">
+                        <a:rPr sz="1000" b="0">
                           <a:latin typeface="Calibri"/>
                         </a:rPr>
                         <a:t>scattered stores exit DRAM as dirty EVICTIONS, which no allocation-time count can see</a:t>
@@ -7458,7 +7458,7 @@
                     <a:lstStyle/>
                     <a:p>
                       <a:r>
-                        <a:rPr sz="1050" b="0">
+                        <a:rPr sz="1000" b="0">
                           <a:latin typeface="Calibri"/>
                         </a:rPr>
                         <a:t>X1: dirty-line set + last-level eviction counting</a:t>
@@ -7477,7 +7477,7 @@
                     <a:lstStyle/>
                     <a:p>
                       <a:r>
-                        <a:rPr sz="1050" b="0">
+                        <a:rPr sz="1000" b="0">
                           <a:latin typeface="Calibri"/>
                         </a:rPr>
                         <a:t>0.90 ×/÷ 1.09</a:t>
@@ -7487,6 +7487,84 @@
                   <a:tcPr>
                     <a:solidFill>
                       <a:srgbClr val="FFFFFF"/>
+                    </a:solidFill>
+                  </a:tcPr>
+                </a:tc>
+              </a:tr>
+              <a:tr h="512064">
+                <a:tc>
+                  <a:txBody>
+                    <a:bodyPr/>
+                    <a:lstStyle/>
+                    <a:p>
+                      <a:r>
+                        <a:rPr sz="1000" b="1">
+                          <a:latin typeface="Calibri"/>
+                        </a:rPr>
+                        <a:t>sgm-mt insns 1.23 @4T</a:t>
+                      </a:r>
+                    </a:p>
+                  </a:txBody>
+                  <a:tcPr>
+                    <a:solidFill>
+                      <a:srgbClr val="EFF3FA"/>
+                    </a:solidFill>
+                  </a:tcPr>
+                </a:tc>
+                <a:tc>
+                  <a:txBody>
+                    <a:bodyPr/>
+                    <a:lstStyle/>
+                    <a:p>
+                      <a:r>
+                        <a:rPr sz="1000" b="0">
+                          <a:latin typeface="Calibri"/>
+                        </a:rPr>
+                        <a:t>OpenMP barrier SPIN — timing-dependent instructions, inflated by instrumentation skew</a:t>
+                      </a:r>
+                    </a:p>
+                  </a:txBody>
+                  <a:tcPr>
+                    <a:solidFill>
+                      <a:srgbClr val="EFF3FA"/>
+                    </a:solidFill>
+                  </a:tcPr>
+                </a:tc>
+                <a:tc>
+                  <a:txBody>
+                    <a:bodyPr/>
+                    <a:lstStyle/>
+                    <a:p>
+                      <a:r>
+                        <a:rPr sz="1000" b="0">
+                          <a:latin typeface="Calibri"/>
+                        </a:rPr>
+                        <a:t>X3: OMP_WAIT_POLICY=passive (proven, not argued)</a:t>
+                      </a:r>
+                    </a:p>
+                  </a:txBody>
+                  <a:tcPr>
+                    <a:solidFill>
+                      <a:srgbClr val="EFF3FA"/>
+                    </a:solidFill>
+                  </a:tcPr>
+                </a:tc>
+                <a:tc>
+                  <a:txBody>
+                    <a:bodyPr/>
+                    <a:lstStyle/>
+                    <a:p>
+                      <a:r>
+                        <a:rPr sz="1000" b="0">
+                          <a:latin typeface="Calibri"/>
+                        </a:rPr>
+                        <a:t>0.985; DRAM unmoved</a:t>
+                      </a:r>
+                    </a:p>
+                  </a:txBody>
+                  <a:tcPr>
+                    <a:solidFill>
+                      <a:srgbClr val="EFF3FA"/>
                     </a:solidFill>
                   </a:tcPr>
                 </a:tc>
@@ -7784,7 +7862,7 @@
         </p:nvGraphicFramePr>
         <p:xfrm>
           <a:off x="548640" y="1463040"/>
-          <a:ext cx="11064240" cy="3328416"/>
+          <a:ext cx="11064240" cy="3803904"/>
         </p:xfrm>
         <a:graphic>
           <a:graphicData uri="http://schemas.openxmlformats.org/drawingml/2006/table">
@@ -8185,7 +8263,7 @@
                         <a:rPr sz="1100" b="1">
                           <a:latin typeface="Calibri"/>
                         </a:rPr>
-                        <a:t>Duty cycle / multi-core</a:t>
+                        <a:t>Multi-core</a:t>
                       </a:r>
                     </a:p>
                   </a:txBody>
@@ -8203,11 +8281,11 @@
                       <a:r>
                         <a:rPr sz="1100" b="0">
                           <a:solidFill>
-                            <a:srgbClr val="B06000"/>
+                            <a:srgbClr val="187A33"/>
                           </a:solidFill>
                           <a:latin typeface="Calibri"/>
                         </a:rPr>
-                        <a:t>insufficient data</a:t>
+                        <a:t>use for DRAM directly; insns with passive waiting</a:t>
                       </a:r>
                     </a:p>
                   </a:txBody>
@@ -8226,13 +8304,75 @@
                         <a:rPr sz="1100" b="0">
                           <a:latin typeface="Calibri"/>
                         </a:rPr>
-                        <a:t>one 4-thread point (within 2%); P1 system-mode work</a:t>
+                        <a:t>DRAM ratios thread-invariant 1–6T; spin-wait inflates insns 18–23% on barrier-heavy code otherwise</a:t>
                       </a:r>
                     </a:p>
                   </a:txBody>
                   <a:tcPr>
                     <a:solidFill>
                       <a:srgbClr val="FFFFFF"/>
+                    </a:solidFill>
+                  </a:tcPr>
+                </a:tc>
+              </a:tr>
+              <a:tr h="475488">
+                <a:tc>
+                  <a:txBody>
+                    <a:bodyPr/>
+                    <a:lstStyle/>
+                    <a:p>
+                      <a:r>
+                        <a:rPr sz="1100" b="1">
+                          <a:latin typeface="Calibri"/>
+                        </a:rPr>
+                        <a:t>Duty cycle</a:t>
+                      </a:r>
+                    </a:p>
+                  </a:txBody>
+                  <a:tcPr>
+                    <a:solidFill>
+                      <a:srgbClr val="EFF3FA"/>
+                    </a:solidFill>
+                  </a:tcPr>
+                </a:tc>
+                <a:tc>
+                  <a:txBody>
+                    <a:bodyPr/>
+                    <a:lstStyle/>
+                    <a:p>
+                      <a:r>
+                        <a:rPr sz="1100" b="0">
+                          <a:solidFill>
+                            <a:srgbClr val="B31412"/>
+                          </a:solidFill>
+                          <a:latin typeface="Calibri"/>
+                        </a:rPr>
+                        <a:t>not yet measured</a:t>
+                      </a:r>
+                    </a:p>
+                  </a:txBody>
+                  <a:tcPr>
+                    <a:solidFill>
+                      <a:srgbClr val="EFF3FA"/>
+                    </a:solidFill>
+                  </a:tcPr>
+                </a:tc>
+                <a:tc>
+                  <a:txBody>
+                    <a:bodyPr/>
+                    <a:lstStyle/>
+                    <a:p>
+                      <a:r>
+                        <a:rPr sz="1100" b="0">
+                          <a:latin typeface="Calibri"/>
+                        </a:rPr>
+                        <a:t>rides on the X2 system-mode harness</a:t>
+                      </a:r>
+                    </a:p>
+                  </a:txBody>
+                  <a:tcPr>
+                    <a:solidFill>
+                      <a:srgbClr val="EFF3FA"/>
                     </a:solidFill>
                   </a:tcPr>
                 </a:tc>

</xml_diff>

<commit_message>
X2a: system-mode boot-differential lands -- kernel share measured at 10%
The imx95 machine (real SM on the M33) boots an app-selecting initramfs and
powers off; per-vcpu differentials against a null boot isolate each app.
sha256's kernel+system share = 10.0% over user mode, with the cpuidle.off
idle-poll decomposed per-cpu rather than laundered into it. Method limits
stated: +/-60M insn/cpu boot noise floor (chase falls below it), in-guest MT
needs passive waiting (sgm's 32% is X3's spin, on schedule). Byproduct: the
M33 SM's WFE idle-spin measured as an activity number (824M insns per 2.4s
boot). Exec summary splits kernel (MEASURABLE) from DMA/network (X2b: needs
the full-board NIC build). NXP boot artifacts operator-supplied, gitignored.
</commit_message>
<xml_diff>
--- a/xcheck/xcheck-correlation.pptx
+++ b/xcheck/xcheck-correlation.pptx
@@ -3532,7 +3532,7 @@
         </p:nvGraphicFramePr>
         <p:xfrm>
           <a:off x="548640" y="1417320"/>
-          <a:ext cx="11064240" cy="3584448"/>
+          <a:ext cx="11064240" cy="4096512"/>
         </p:xfrm>
         <a:graphic>
           <a:graphicData uri="http://schemas.openxmlformats.org/drawingml/2006/table">
@@ -3871,7 +3871,7 @@
                         <a:rPr sz="1050" b="1">
                           <a:latin typeface="Calibri"/>
                         </a:rPr>
-                        <a:t>Kernel &amp; DMA activity</a:t>
+                        <a:t>Kernel activity</a:t>
                       </a:r>
                     </a:p>
                   </a:txBody>
@@ -3890,13 +3890,75 @@
                         <a:rPr sz="1050" b="0">
                           <a:latin typeface="Calibri"/>
                         </a:rPr>
-                        <a:t>HTTP app: i-ratio 0.80, DRAM invisible — linux-user sees userspace only</a:t>
+                        <a:t>boot-differential harness live: sha256 kernel+system share MEASURED at 10.0% over user mode (noise floor ±60M insns/cpu stated)</a:t>
                       </a:r>
                     </a:p>
                   </a:txBody>
                   <a:tcPr>
                     <a:solidFill>
                       <a:srgbClr val="EFF3FA"/>
+                    </a:solidFill>
+                  </a:tcPr>
+                </a:tc>
+                <a:tc>
+                  <a:txBody>
+                    <a:bodyPr/>
+                    <a:lstStyle/>
+                    <a:p>
+                      <a:r>
+                        <a:rPr sz="1050" b="0">
+                          <a:solidFill>
+                            <a:srgbClr val="5F6368"/>
+                          </a:solidFill>
+                          <a:latin typeface="Calibri"/>
+                        </a:rPr>
+                        <a:t>MEASURABLE — X2a</a:t>
+                      </a:r>
+                    </a:p>
+                  </a:txBody>
+                  <a:tcPr>
+                    <a:solidFill>
+                      <a:srgbClr val="EFF3FA"/>
+                    </a:solidFill>
+                  </a:tcPr>
+                </a:tc>
+              </a:tr>
+              <a:tr h="512064">
+                <a:tc>
+                  <a:txBody>
+                    <a:bodyPr/>
+                    <a:lstStyle/>
+                    <a:p>
+                      <a:r>
+                        <a:rPr sz="1050" b="1">
+                          <a:latin typeface="Calibri"/>
+                        </a:rPr>
+                        <a:t>DMA / network activity</a:t>
+                      </a:r>
+                    </a:p>
+                  </a:txBody>
+                  <a:tcPr>
+                    <a:solidFill>
+                      <a:srgbClr val="FFFFFF"/>
+                    </a:solidFill>
+                  </a:tcPr>
+                </a:tc>
+                <a:tc>
+                  <a:txBody>
+                    <a:bodyPr/>
+                    <a:lstStyle/>
+                    <a:p>
+                      <a:r>
+                        <a:rPr sz="1050" b="0">
+                          <a:latin typeface="Calibri"/>
+                        </a:rPr>
+                        <a:t>HTTP app: i-ratio 0.80, DRAM invisible to linux-user; the minimal system machine has no NIC</a:t>
+                      </a:r>
+                    </a:p>
+                  </a:txBody>
+                  <a:tcPr>
+                    <a:solidFill>
+                      <a:srgbClr val="FFFFFF"/>
                     </a:solidFill>
                   </a:tcPr>
                 </a:tc>
@@ -3912,13 +3974,13 @@
                           </a:solidFill>
                           <a:latin typeface="Calibri"/>
                         </a:rPr>
-                        <a:t>GAP — system-mode harness</a:t>
-                      </a:r>
-                    </a:p>
-                  </a:txBody>
-                  <a:tcPr>
-                    <a:solidFill>
-                      <a:srgbClr val="EFF3FA"/>
+                        <a:t>GAP — X2b full-board build</a:t>
+                      </a:r>
+                    </a:p>
+                  </a:txBody>
+                  <a:tcPr>
+                    <a:solidFill>
+                      <a:srgbClr val="FFFFFF"/>
                     </a:solidFill>
                   </a:tcPr>
                 </a:tc>
@@ -3939,7 +4001,7 @@
                   </a:txBody>
                   <a:tcPr>
                     <a:solidFill>
-                      <a:srgbClr val="FFFFFF"/>
+                      <a:srgbClr val="EFF3FA"/>
                     </a:solidFill>
                   </a:tcPr>
                 </a:tc>
@@ -3958,7 +4020,7 @@
                   </a:txBody>
                   <a:tcPr>
                     <a:solidFill>
-                      <a:srgbClr val="FFFFFF"/>
+                      <a:srgbClr val="EFF3FA"/>
                     </a:solidFill>
                   </a:tcPr>
                 </a:tc>
@@ -3980,7 +4042,7 @@
                   </a:txBody>
                   <a:tcPr>
                     <a:solidFill>
-                      <a:srgbClr val="FFFFFF"/>
+                      <a:srgbClr val="EFF3FA"/>
                     </a:solidFill>
                   </a:tcPr>
                 </a:tc>

</xml_diff>

<commit_message>
X2b: network/DMA characterized on the full board -- boundaries named, not fudged
Full-board plugins build (worktree of the board branch, cache patch ported
across the older plugin API), guest fetches 33.5MB over virtio/slirp from a
live server under boot-differential instrumentation. (1) DMA visibility
boundary confirmed numerically: the DMA write bypasses TCG; every CPU-side
copy is visible and coherent (read diff ~2x payload). (2) Event-loop clients
carry timing-dependent instruction counts (0.80/1.51 bracket); the blocking
client's residual 1.42 partially falsifies poll-spin as dominant -- recorded.
(3) Kernel network share is device-path-dependent: silicon real-NIC 16.7% vs
guest virtio+slirp 41% idle-corrected (soft checksum, driver, softirq) -- the
emulated machine's true activity, so model the target's NIC for the target's
numbers. Exec summary: the last GAP becomes CHARACTERIZED.
</commit_message>
<xml_diff>
--- a/xcheck/xcheck-correlation.pptx
+++ b/xcheck/xcheck-correlation.pptx
@@ -3766,7 +3766,7 @@
                         <a:rPr sz="1050" b="0">
                           <a:latin typeface="Calibri"/>
                         </a:rPr>
-                        <a:t>5 low-traffic apps (alu, lua, lz4, pacman, sqlite) predicted quiet; silicon concurs</a:t>
+                        <a:t>6 low-traffic apps (alu, lua, lz4, net2, pacman, sqlite) predicted quiet; silicon concurs</a:t>
                       </a:r>
                     </a:p>
                   </a:txBody>
@@ -3952,7 +3952,7 @@
                         <a:rPr sz="1050" b="0">
                           <a:latin typeface="Calibri"/>
                         </a:rPr>
-                        <a:t>HTTP app: i-ratio 0.80, DRAM invisible to linux-user; the minimal system machine has no NIC</a:t>
+                        <a:t>full-board harness live: CPU-side traffic visible &amp; coherent (read diff ≈ 2× payload); DMA write invisible to TCG by construction (payload bytes known exactly); kernel share device-path-dependent (silicon NIC 17% vs guest virtio 41%)</a:t>
                       </a:r>
                     </a:p>
                   </a:txBody>
@@ -3970,11 +3970,11 @@
                       <a:r>
                         <a:rPr sz="1050" b="0">
                           <a:solidFill>
-                            <a:srgbClr val="B06000"/>
+                            <a:srgbClr val="5F6368"/>
                           </a:solidFill>
                           <a:latin typeface="Calibri"/>
                         </a:rPr>
-                        <a:t>GAP — X2b full-board build</a:t>
+                        <a:t>CHARACTERIZED — model the target's own NIC</a:t>
                       </a:r>
                     </a:p>
                   </a:txBody>
@@ -5029,7 +5029,7 @@
         </p:nvGraphicFramePr>
         <p:xfrm>
           <a:off x="548640" y="1463040"/>
-          <a:ext cx="5486400" cy="3072384"/>
+          <a:ext cx="5486400" cy="3456432"/>
         </p:xfrm>
         <a:graphic>
           <a:graphicData uri="http://schemas.openxmlformats.org/drawingml/2006/table">
@@ -5696,6 +5696,87 @@
                   <a:tcPr>
                     <a:solidFill>
                       <a:srgbClr val="EFF3FA"/>
+                    </a:solidFill>
+                  </a:tcPr>
+                </a:tc>
+              </a:tr>
+              <a:tr h="384048">
+                <a:tc>
+                  <a:txBody>
+                    <a:bodyPr/>
+                    <a:lstStyle/>
+                    <a:p>
+                      <a:r>
+                        <a:rPr sz="1000" b="0">
+                          <a:latin typeface="Calibri"/>
+                        </a:rPr>
+                        <a:t>mm</a:t>
+                      </a:r>
+                    </a:p>
+                  </a:txBody>
+                  <a:tcPr>
+                    <a:solidFill>
+                      <a:srgbClr val="FFFFFF"/>
+                    </a:solidFill>
+                  </a:tcPr>
+                </a:tc>
+                <a:tc>
+                  <a:txBody>
+                    <a:bodyPr/>
+                    <a:lstStyle/>
+                    <a:p>
+                      <a:r>
+                        <a:rPr sz="1000" b="0">
+                          <a:latin typeface="Calibri"/>
+                        </a:rPr>
+                        <a:t>blocked f64 matmul</a:t>
+                      </a:r>
+                    </a:p>
+                  </a:txBody>
+                  <a:tcPr>
+                    <a:solidFill>
+                      <a:srgbClr val="FFFFFF"/>
+                    </a:solidFill>
+                  </a:tcPr>
+                </a:tc>
+                <a:tc>
+                  <a:txBody>
+                    <a:bodyPr/>
+                    <a:lstStyle/>
+                    <a:p>
+                      <a:r>
+                        <a:rPr sz="1000" b="0">
+                          <a:latin typeface="Calibri"/>
+                        </a:rPr>
+                        <a:t>1,081,871,120</a:t>
+                      </a:r>
+                    </a:p>
+                  </a:txBody>
+                  <a:tcPr>
+                    <a:solidFill>
+                      <a:srgbClr val="FFFFFF"/>
+                    </a:solidFill>
+                  </a:tcPr>
+                </a:tc>
+                <a:tc>
+                  <a:txBody>
+                    <a:bodyPr/>
+                    <a:lstStyle/>
+                    <a:p>
+                      <a:r>
+                        <a:rPr sz="1000" b="0">
+                          <a:solidFill>
+                            <a:srgbClr val="187A33"/>
+                          </a:solidFill>
+                          <a:latin typeface="Calibri"/>
+                        </a:rPr>
+                        <a:t>0.997</a:t>
+                      </a:r>
+                    </a:p>
+                  </a:txBody>
+                  <a:tcPr>
+                    <a:solidFill>
+                      <a:srgbClr val="FFFFFF"/>
                     </a:solidFill>
                   </a:tcPr>
                 </a:tc>
@@ -5828,7 +5909,7 @@
                         <a:rPr sz="1000" b="0">
                           <a:latin typeface="Calibri"/>
                         </a:rPr>
-                        <a:t>mm</a:t>
+                        <a:t>net</a:t>
                       </a:r>
                     </a:p>
                   </a:txBody>
@@ -5847,7 +5928,7 @@
                         <a:rPr sz="1000" b="0">
                           <a:latin typeface="Calibri"/>
                         </a:rPr>
-                        <a:t>blocked f64 matmul</a:t>
+                        <a:t>HTTP GET 32 MiB + FNV hash</a:t>
                       </a:r>
                     </a:p>
                   </a:txBody>
@@ -5866,94 +5947,13 @@
                         <a:rPr sz="1000" b="0">
                           <a:latin typeface="Calibri"/>
                         </a:rPr>
-                        <a:t>1,081,871,120</a:t>
+                        <a:t>430,719,038</a:t>
                       </a:r>
                     </a:p>
                   </a:txBody>
                   <a:tcPr>
                     <a:solidFill>
                       <a:srgbClr val="EFF3FA"/>
-                    </a:solidFill>
-                  </a:tcPr>
-                </a:tc>
-                <a:tc>
-                  <a:txBody>
-                    <a:bodyPr/>
-                    <a:lstStyle/>
-                    <a:p>
-                      <a:r>
-                        <a:rPr sz="1000" b="0">
-                          <a:solidFill>
-                            <a:srgbClr val="187A33"/>
-                          </a:solidFill>
-                          <a:latin typeface="Calibri"/>
-                        </a:rPr>
-                        <a:t>0.997</a:t>
-                      </a:r>
-                    </a:p>
-                  </a:txBody>
-                  <a:tcPr>
-                    <a:solidFill>
-                      <a:srgbClr val="EFF3FA"/>
-                    </a:solidFill>
-                  </a:tcPr>
-                </a:tc>
-              </a:tr>
-              <a:tr h="384048">
-                <a:tc>
-                  <a:txBody>
-                    <a:bodyPr/>
-                    <a:lstStyle/>
-                    <a:p>
-                      <a:r>
-                        <a:rPr sz="1000" b="0">
-                          <a:latin typeface="Calibri"/>
-                        </a:rPr>
-                        <a:t>net</a:t>
-                      </a:r>
-                    </a:p>
-                  </a:txBody>
-                  <a:tcPr>
-                    <a:solidFill>
-                      <a:srgbClr val="FFFFFF"/>
-                    </a:solidFill>
-                  </a:tcPr>
-                </a:tc>
-                <a:tc>
-                  <a:txBody>
-                    <a:bodyPr/>
-                    <a:lstStyle/>
-                    <a:p>
-                      <a:r>
-                        <a:rPr sz="1000" b="0">
-                          <a:latin typeface="Calibri"/>
-                        </a:rPr>
-                        <a:t>HTTP GET 32 MiB + FNV hash</a:t>
-                      </a:r>
-                    </a:p>
-                  </a:txBody>
-                  <a:tcPr>
-                    <a:solidFill>
-                      <a:srgbClr val="FFFFFF"/>
-                    </a:solidFill>
-                  </a:tcPr>
-                </a:tc>
-                <a:tc>
-                  <a:txBody>
-                    <a:bodyPr/>
-                    <a:lstStyle/>
-                    <a:p>
-                      <a:r>
-                        <a:rPr sz="1000" b="0">
-                          <a:latin typeface="Calibri"/>
-                        </a:rPr>
-                        <a:t>430,719,038</a:t>
-                      </a:r>
-                    </a:p>
-                  </a:txBody>
-                  <a:tcPr>
-                    <a:solidFill>
-                      <a:srgbClr val="FFFFFF"/>
                     </a:solidFill>
                   </a:tcPr>
                 </a:tc>
@@ -5970,6 +5970,80 @@
                           <a:latin typeface="Calibri"/>
                         </a:rPr>
                         <a:t>0.798</a:t>
+                      </a:r>
+                    </a:p>
+                  </a:txBody>
+                  <a:tcPr>
+                    <a:solidFill>
+                      <a:srgbClr val="EFF3FA"/>
+                    </a:solidFill>
+                  </a:tcPr>
+                </a:tc>
+              </a:tr>
+              <a:tr h="384048">
+                <a:tc>
+                  <a:txBody>
+                    <a:bodyPr/>
+                    <a:lstStyle/>
+                    <a:p>
+                      <a:r>
+                        <a:rPr sz="1000" b="0">
+                          <a:latin typeface="Calibri"/>
+                        </a:rPr>
+                        <a:t>net2</a:t>
+                      </a:r>
+                    </a:p>
+                  </a:txBody>
+                  <a:tcPr>
+                    <a:solidFill>
+                      <a:srgbClr val="FFFFFF"/>
+                    </a:solidFill>
+                  </a:tcPr>
+                </a:tc>
+                <a:tc>
+                  <a:txBody>
+                    <a:bodyPr/>
+                    <a:lstStyle/>
+                    <a:p/>
+                  </a:txBody>
+                  <a:tcPr>
+                    <a:solidFill>
+                      <a:srgbClr val="FFFFFF"/>
+                    </a:solidFill>
+                  </a:tcPr>
+                </a:tc>
+                <a:tc>
+                  <a:txBody>
+                    <a:bodyPr/>
+                    <a:lstStyle/>
+                    <a:p>
+                      <a:r>
+                        <a:rPr sz="1000" b="0">
+                          <a:latin typeface="Calibri"/>
+                        </a:rPr>
+                        <a:t>241,898,307</a:t>
+                      </a:r>
+                    </a:p>
+                  </a:txBody>
+                  <a:tcPr>
+                    <a:solidFill>
+                      <a:srgbClr val="FFFFFF"/>
+                    </a:solidFill>
+                  </a:tcPr>
+                </a:tc>
+                <a:tc>
+                  <a:txBody>
+                    <a:bodyPr/>
+                    <a:lstStyle/>
+                    <a:p>
+                      <a:r>
+                        <a:rPr sz="1000" b="0">
+                          <a:solidFill>
+                            <a:srgbClr val="B06000"/>
+                          </a:solidFill>
+                          <a:latin typeface="Calibri"/>
+                        </a:rPr>
+                        <a:t>0.833</a:t>
                       </a:r>
                     </a:p>
                   </a:txBody>

</xml_diff>

<commit_message>
X4: stride prefetcher closes the read band -- 0.98 x/1.14, exit criterion met
Three mechanism-driven rounds recorded incl. the failures: naive d16 exploded
bzip2 to 4.27 via phantom streams and doubled mem by training on stores; the
fix set (train on load L1-misses only, strict +1 advance, ramped depth 2..16)
lands reads at geo 0.98 x/÷1.14 over the above-floor population -- from
0.81 x/÷1.26. Round 3 falsified L2-pollution as lz4's writeback mechanism
(recorded open). Shipping shape = two-pass extraction, now in afgen: reads
from the prefetcher pass (~1.0 correction), writes from the base pass
(0.90 x/÷1.09). Deck: reads row updated, mechanism table gains the X4 row.
50-app held-out validation sweeps running; verdict follows as its own commit.
</commit_message>
<xml_diff>
--- a/xcheck/xcheck-correlation.pptx
+++ b/xcheck/xcheck-correlation.pptx
@@ -3704,7 +3704,7 @@
                         <a:rPr sz="1050" b="0">
                           <a:latin typeface="Calibri"/>
                         </a:rPr>
-                        <a:t>proxy = 0.81 × silicon, geo-spread ×/÷ 1.26 (8 apps above noise floor)</a:t>
+                        <a:t>X4 prefetch model: proxy = 0.98 × silicon, ×/÷ 1.14 — the exit criterion met (was 0.81 ×/÷ 1.26)</a:t>
                       </a:r>
                     </a:p>
                   </a:txBody>
@@ -3726,7 +3726,7 @@
                           </a:solidFill>
                           <a:latin typeface="Calibri"/>
                         </a:rPr>
-                        <a:t>USABLE — apply ×1.23, carry ×/÷1.26</a:t>
+                        <a:t>USABLE — correction ~1.0</a:t>
                       </a:r>
                     </a:p>
                   </a:txBody>
@@ -3828,7 +3828,7 @@
                         <a:rPr sz="1050" b="0">
                           <a:latin typeface="Calibri"/>
                         </a:rPr>
-                        <a:t>proxy = 0.90 × silicon, ×/÷ 1.09 (X1 writeback model: streaming bursts + dirty evictions)</a:t>
+                        <a:t>proxy = 1.48 × silicon, ×/÷ 2.23 (X1 writeback model: streaming bursts + dirty evictions)</a:t>
                       </a:r>
                     </a:p>
                   </a:txBody>
@@ -3850,7 +3850,7 @@
                           </a:solidFill>
                           <a:latin typeface="Calibri"/>
                         </a:rPr>
-                        <a:t>USABLE — apply ×1.11</a:t>
+                        <a:t>USABLE — apply ×0.68</a:t>
                       </a:r>
                     </a:p>
                   </a:txBody>
@@ -6667,7 +6667,7 @@
                 </a:solidFill>
                 <a:latin typeface="Calibri"/>
               </a:rPr>
-              <a:t>log–log, one point per application above the noise floor · fit: proxy = 0.81 × silicon, ×/÷ 1.26</a:t>
+              <a:t>log–log, one point per application above the noise floor · fit: proxy = 0.98 × silicon, ×/÷ 1.14</a:t>
             </a:r>
           </a:p>
         </p:txBody>
@@ -7055,7 +7055,7 @@
         </p:nvGraphicFramePr>
         <p:xfrm>
           <a:off x="548640" y="1463040"/>
-          <a:ext cx="11064240" cy="4096512"/>
+          <a:ext cx="11064240" cy="4608576"/>
         </p:xfrm>
         <a:graphic>
           <a:graphicData uri="http://schemas.openxmlformats.org/drawingml/2006/table">
@@ -7701,6 +7701,84 @@
                   <a:tcPr>
                     <a:solidFill>
                       <a:srgbClr val="EFF3FA"/>
+                    </a:solidFill>
+                  </a:tcPr>
+                </a:tc>
+              </a:tr>
+              <a:tr h="512064">
+                <a:tc>
+                  <a:txBody>
+                    <a:bodyPr/>
+                    <a:lstStyle/>
+                    <a:p>
+                      <a:r>
+                        <a:rPr sz="1000" b="1">
+                          <a:latin typeface="Calibri"/>
+                        </a:rPr>
+                        <a:t>reads 0.49–0.77 (under)</a:t>
+                      </a:r>
+                    </a:p>
+                  </a:txBody>
+                  <a:tcPr>
+                    <a:solidFill>
+                      <a:srgbClr val="FFFFFF"/>
+                    </a:solidFill>
+                  </a:tcPr>
+                </a:tc>
+                <a:tc>
+                  <a:txBody>
+                    <a:bodyPr/>
+                    <a:lstStyle/>
+                    <a:p>
+                      <a:r>
+                        <a:rPr sz="1000" b="0">
+                          <a:latin typeface="Calibri"/>
+                        </a:rPr>
+                        <a:t>silicon prefetcher traffic the model never issued</a:t>
+                      </a:r>
+                    </a:p>
+                  </a:txBody>
+                  <a:tcPr>
+                    <a:solidFill>
+                      <a:srgbClr val="FFFFFF"/>
+                    </a:solidFill>
+                  </a:tcPr>
+                </a:tc>
+                <a:tc>
+                  <a:txBody>
+                    <a:bodyPr/>
+                    <a:lstStyle/>
+                    <a:p>
+                      <a:r>
+                        <a:rPr sz="1000" b="0">
+                          <a:latin typeface="Calibri"/>
+                        </a:rPr>
+                        <a:t>X4: 8-stream table, miss-trained, strict +1, ramped depth</a:t>
+                      </a:r>
+                    </a:p>
+                  </a:txBody>
+                  <a:tcPr>
+                    <a:solidFill>
+                      <a:srgbClr val="FFFFFF"/>
+                    </a:solidFill>
+                  </a:tcPr>
+                </a:tc>
+                <a:tc>
+                  <a:txBody>
+                    <a:bodyPr/>
+                    <a:lstStyle/>
+                    <a:p>
+                      <a:r>
+                        <a:rPr sz="1000" b="0">
+                          <a:latin typeface="Calibri"/>
+                        </a:rPr>
+                        <a:t>0.98 ×/÷ 1.14</a:t>
+                      </a:r>
+                    </a:p>
+                  </a:txBody>
+                  <a:tcPr>
+                    <a:solidFill>
+                      <a:srgbClr val="FFFFFF"/>
                     </a:solidFill>
                   </a:tcPr>
                 </a:tc>
@@ -8173,7 +8251,7 @@
                           </a:solidFill>
                           <a:latin typeface="Calibri"/>
                         </a:rPr>
-                        <a:t>use with ×1.23 correction</a:t>
+                        <a:t>use with ×1.02 correction</a:t>
                       </a:r>
                     </a:p>
                   </a:txBody>
@@ -8192,7 +8270,7 @@
                         <a:rPr sz="1100" b="0">
                           <a:latin typeface="Calibri"/>
                         </a:rPr>
-                        <a:t>carry the ×/÷1.26 band; latency/bandwidth-bound apps need almost none</a:t>
+                        <a:t>carry the ×/÷1.14 band; latency/bandwidth-bound apps need almost none</a:t>
                       </a:r>
                     </a:p>
                   </a:txBody>
@@ -8297,7 +8375,7 @@
                           </a:solidFill>
                           <a:latin typeface="Calibri"/>
                         </a:rPr>
-                        <a:t>use with ×1.11 correction</a:t>
+                        <a:t>use with ×0.68 correction</a:t>
                       </a:r>
                     </a:p>
                   </a:txBody>

</xml_diff>

<commit_message>
README + deck catch up with the day: 50-app held-out verdict, afgen, pinned write factors
README leads with the two-act validation (14 fitted / 36 held out) and its
numbers table, promotes afgen as the fifty-apps-in-fifty-AFs product, and
compresses the instrument lessons to include writeback and spin-wait.

Deck rev 3.1: new generalization slide (scatter50 between the money chart
and mechanisms), a Generalization row atop the executive summary, and the
DRAM-write factors PINNED to the recorded base-pass campaign (0.90 x/1.09
fitted, 0.83 x/1.28 held-out) instead of recomputed from out/ -- out/ has
held the prefetch pass since X4, which pollutes writeback and silently
drifted the write row to 1.48 x/2.23. The two-pass lesson, now enforced
in the deck's own build.
</commit_message>
<xml_diff>
--- a/xcheck/xcheck-correlation.pptx
+++ b/xcheck/xcheck-correlation.pptx
@@ -12,6 +12,7 @@
     <p:sldId id="260" r:id="rId11"/>
     <p:sldId id="261" r:id="rId12"/>
     <p:sldId id="262" r:id="rId13"/>
+    <p:sldId id="263" r:id="rId14"/>
   </p:sldIdLst>
   <p:sldSz cx="12191695" cy="6858000" type="screen4x3"/>
   <p:notesSz cx="6858000" cy="9144000"/>
@@ -3531,8 +3532,8 @@
           <p:nvPr/>
         </p:nvGraphicFramePr>
         <p:xfrm>
-          <a:off x="548640" y="1417320"/>
-          <a:ext cx="11064240" cy="4096512"/>
+          <a:off x="548640" y="1371600"/>
+          <a:ext cx="11064240" cy="3785616"/>
         </p:xfrm>
         <a:graphic>
           <a:graphicData uri="http://schemas.openxmlformats.org/drawingml/2006/table">
@@ -3545,14 +3546,14 @@
                 <a:gridCol w="5120640"/>
                 <a:gridCol w="3108960"/>
               </a:tblGrid>
-              <a:tr h="512064">
-                <a:tc>
-                  <a:txBody>
-                    <a:bodyPr/>
-                    <a:lstStyle/>
-                    <a:p>
-                      <a:r>
-                        <a:rPr sz="1050" b="1">
+              <a:tr h="420624">
+                <a:tc>
+                  <a:txBody>
+                    <a:bodyPr/>
+                    <a:lstStyle/>
+                    <a:p>
+                      <a:r>
+                        <a:rPr sz="1000" b="1">
                           <a:solidFill>
                             <a:srgbClr val="FFFFFF"/>
                           </a:solidFill>
@@ -3574,7 +3575,7 @@
                     <a:lstStyle/>
                     <a:p>
                       <a:r>
-                        <a:rPr sz="1050" b="1">
+                        <a:rPr sz="1000" b="1">
                           <a:solidFill>
                             <a:srgbClr val="FFFFFF"/>
                           </a:solidFill>
@@ -3596,7 +3597,7 @@
                     <a:lstStyle/>
                     <a:p>
                       <a:r>
-                        <a:rPr sz="1050" b="1">
+                        <a:rPr sz="1000" b="1">
                           <a:solidFill>
                             <a:srgbClr val="FFFFFF"/>
                           </a:solidFill>
@@ -3613,17 +3614,17 @@
                   </a:tcPr>
                 </a:tc>
               </a:tr>
-              <a:tr h="512064">
-                <a:tc>
-                  <a:txBody>
-                    <a:bodyPr/>
-                    <a:lstStyle/>
-                    <a:p>
-                      <a:r>
-                        <a:rPr sz="1050" b="1">
-                          <a:latin typeface="Calibri"/>
-                        </a:rPr>
-                        <a:t>Instruction activity, per core</a:t>
+              <a:tr h="420624">
+                <a:tc>
+                  <a:txBody>
+                    <a:bodyPr/>
+                    <a:lstStyle/>
+                    <a:p>
+                      <a:r>
+                        <a:rPr sz="1000" b="1">
+                          <a:latin typeface="Calibri"/>
+                        </a:rPr>
+                        <a:t>Generalization (the gate)</a:t>
                       </a:r>
                     </a:p>
                   </a:txBody>
@@ -3639,10 +3640,10 @@
                     <a:lstStyle/>
                     <a:p>
                       <a:r>
-                        <a:rPr sz="1050" b="0">
-                          <a:latin typeface="Calibri"/>
-                        </a:rPr>
-                        <a:t>0.98 – 1.06 across all 14 apps (0.997 on a 10.2 B-insn vision app)</a:t>
+                        <a:rPr sz="1000" b="0">
+                          <a:latin typeface="Calibri"/>
+                        </a:rPr>
+                        <a:t>corrections fitted on 14 apps HELD on 36 unseen apps: insns 0.979 ×/÷1.04, reads transfer with identical ×/÷1.21 spread</a:t>
                       </a:r>
                     </a:p>
                   </a:txBody>
@@ -3658,13 +3659,13 @@
                     <a:lstStyle/>
                     <a:p>
                       <a:r>
-                        <a:rPr sz="1050" b="0">
+                        <a:rPr sz="1000" b="0">
                           <a:solidFill>
                             <a:srgbClr val="187A33"/>
                           </a:solidFill>
                           <a:latin typeface="Calibri"/>
                         </a:rPr>
-                        <a:t>VALIDATED — use as-is</a:t>
+                        <a:t>VALIDATED — 50-app held-out</a:t>
                       </a:r>
                     </a:p>
                   </a:txBody>
@@ -3675,17 +3676,17 @@
                   </a:tcPr>
                 </a:tc>
               </a:tr>
-              <a:tr h="512064">
-                <a:tc>
-                  <a:txBody>
-                    <a:bodyPr/>
-                    <a:lstStyle/>
-                    <a:p>
-                      <a:r>
-                        <a:rPr sz="1050" b="1">
-                          <a:latin typeface="Calibri"/>
-                        </a:rPr>
-                        <a:t>DRAM read traffic</a:t>
+              <a:tr h="420624">
+                <a:tc>
+                  <a:txBody>
+                    <a:bodyPr/>
+                    <a:lstStyle/>
+                    <a:p>
+                      <a:r>
+                        <a:rPr sz="1000" b="1">
+                          <a:latin typeface="Calibri"/>
+                        </a:rPr>
+                        <a:t>Instruction activity, per core</a:t>
                       </a:r>
                     </a:p>
                   </a:txBody>
@@ -3701,10 +3702,10 @@
                     <a:lstStyle/>
                     <a:p>
                       <a:r>
-                        <a:rPr sz="1050" b="0">
-                          <a:latin typeface="Calibri"/>
-                        </a:rPr>
-                        <a:t>X4 prefetch model: proxy = 0.98 × silicon, ×/÷ 1.14 — the exit criterion met (was 0.81 ×/÷ 1.26)</a:t>
+                        <a:rPr sz="1000" b="0">
+                          <a:latin typeface="Calibri"/>
+                        </a:rPr>
+                        <a:t>0.98 – 1.06 across all 14 apps (0.997 on a 10.2 B-insn vision app)</a:t>
                       </a:r>
                     </a:p>
                   </a:txBody>
@@ -3720,13 +3721,13 @@
                     <a:lstStyle/>
                     <a:p>
                       <a:r>
-                        <a:rPr sz="1050" b="0">
+                        <a:rPr sz="1000" b="0">
                           <a:solidFill>
                             <a:srgbClr val="187A33"/>
                           </a:solidFill>
                           <a:latin typeface="Calibri"/>
                         </a:rPr>
-                        <a:t>USABLE — correction ~1.0</a:t>
+                        <a:t>VALIDATED — use as-is</a:t>
                       </a:r>
                     </a:p>
                   </a:txBody>
@@ -3737,17 +3738,17 @@
                   </a:tcPr>
                 </a:tc>
               </a:tr>
-              <a:tr h="512064">
-                <a:tc>
-                  <a:txBody>
-                    <a:bodyPr/>
-                    <a:lstStyle/>
-                    <a:p>
-                      <a:r>
-                        <a:rPr sz="1050" b="1">
-                          <a:latin typeface="Calibri"/>
-                        </a:rPr>
-                        <a:t>DRAM-quiet classification</a:t>
+              <a:tr h="420624">
+                <a:tc>
+                  <a:txBody>
+                    <a:bodyPr/>
+                    <a:lstStyle/>
+                    <a:p>
+                      <a:r>
+                        <a:rPr sz="1000" b="1">
+                          <a:latin typeface="Calibri"/>
+                        </a:rPr>
+                        <a:t>DRAM read traffic</a:t>
                       </a:r>
                     </a:p>
                   </a:txBody>
@@ -3763,10 +3764,10 @@
                     <a:lstStyle/>
                     <a:p>
                       <a:r>
-                        <a:rPr sz="1050" b="0">
-                          <a:latin typeface="Calibri"/>
-                        </a:rPr>
-                        <a:t>6 low-traffic apps (alu, lua, lz4, net2, pacman, sqlite) predicted quiet; silicon concurs</a:t>
+                        <a:rPr sz="1000" b="0">
+                          <a:latin typeface="Calibri"/>
+                        </a:rPr>
+                        <a:t>X4 prefetch model: proxy = 0.98 × silicon, ×/÷ 1.14 — the exit criterion met (was 0.81 ×/÷ 1.26)</a:t>
                       </a:r>
                     </a:p>
                   </a:txBody>
@@ -3782,13 +3783,13 @@
                     <a:lstStyle/>
                     <a:p>
                       <a:r>
-                        <a:rPr sz="1050" b="0">
+                        <a:rPr sz="1000" b="0">
                           <a:solidFill>
                             <a:srgbClr val="187A33"/>
                           </a:solidFill>
                           <a:latin typeface="Calibri"/>
                         </a:rPr>
-                        <a:t>VALIDATED</a:t>
+                        <a:t>USABLE — correction ~1.0</a:t>
                       </a:r>
                     </a:p>
                   </a:txBody>
@@ -3799,17 +3800,17 @@
                   </a:tcPr>
                 </a:tc>
               </a:tr>
-              <a:tr h="512064">
-                <a:tc>
-                  <a:txBody>
-                    <a:bodyPr/>
-                    <a:lstStyle/>
-                    <a:p>
-                      <a:r>
-                        <a:rPr sz="1050" b="1">
-                          <a:latin typeface="Calibri"/>
-                        </a:rPr>
-                        <a:t>DRAM write traffic</a:t>
+              <a:tr h="420624">
+                <a:tc>
+                  <a:txBody>
+                    <a:bodyPr/>
+                    <a:lstStyle/>
+                    <a:p>
+                      <a:r>
+                        <a:rPr sz="1000" b="1">
+                          <a:latin typeface="Calibri"/>
+                        </a:rPr>
+                        <a:t>DRAM-quiet classification</a:t>
                       </a:r>
                     </a:p>
                   </a:txBody>
@@ -3825,10 +3826,10 @@
                     <a:lstStyle/>
                     <a:p>
                       <a:r>
-                        <a:rPr sz="1050" b="0">
-                          <a:latin typeface="Calibri"/>
-                        </a:rPr>
-                        <a:t>proxy = 1.48 × silicon, ×/÷ 2.23 (X1 writeback model: streaming bursts + dirty evictions)</a:t>
+                        <a:rPr sz="1000" b="0">
+                          <a:latin typeface="Calibri"/>
+                        </a:rPr>
+                        <a:t>6 low-traffic apps (alu, lua, lz4, net2, pacman, sqlite) predicted quiet; silicon concurs</a:t>
                       </a:r>
                     </a:p>
                   </a:txBody>
@@ -3844,13 +3845,13 @@
                     <a:lstStyle/>
                     <a:p>
                       <a:r>
-                        <a:rPr sz="1050" b="0">
+                        <a:rPr sz="1000" b="0">
                           <a:solidFill>
                             <a:srgbClr val="187A33"/>
                           </a:solidFill>
                           <a:latin typeface="Calibri"/>
                         </a:rPr>
-                        <a:t>USABLE — apply ×0.68</a:t>
+                        <a:t>VALIDATED</a:t>
                       </a:r>
                     </a:p>
                   </a:txBody>
@@ -3861,14 +3862,76 @@
                   </a:tcPr>
                 </a:tc>
               </a:tr>
-              <a:tr h="512064">
-                <a:tc>
-                  <a:txBody>
-                    <a:bodyPr/>
-                    <a:lstStyle/>
-                    <a:p>
-                      <a:r>
-                        <a:rPr sz="1050" b="1">
+              <a:tr h="420624">
+                <a:tc>
+                  <a:txBody>
+                    <a:bodyPr/>
+                    <a:lstStyle/>
+                    <a:p>
+                      <a:r>
+                        <a:rPr sz="1000" b="1">
+                          <a:latin typeface="Calibri"/>
+                        </a:rPr>
+                        <a:t>DRAM write traffic</a:t>
+                      </a:r>
+                    </a:p>
+                  </a:txBody>
+                  <a:tcPr>
+                    <a:solidFill>
+                      <a:srgbClr val="EFF3FA"/>
+                    </a:solidFill>
+                  </a:tcPr>
+                </a:tc>
+                <a:tc>
+                  <a:txBody>
+                    <a:bodyPr/>
+                    <a:lstStyle/>
+                    <a:p>
+                      <a:r>
+                        <a:rPr sz="1000" b="0">
+                          <a:latin typeface="Calibri"/>
+                        </a:rPr>
+                        <a:t>proxy = 0.90 × silicon, ×/÷ 1.09 (X1 writeback model, base pass); 0.83 ×/÷ 1.28 held-out</a:t>
+                      </a:r>
+                    </a:p>
+                  </a:txBody>
+                  <a:tcPr>
+                    <a:solidFill>
+                      <a:srgbClr val="EFF3FA"/>
+                    </a:solidFill>
+                  </a:tcPr>
+                </a:tc>
+                <a:tc>
+                  <a:txBody>
+                    <a:bodyPr/>
+                    <a:lstStyle/>
+                    <a:p>
+                      <a:r>
+                        <a:rPr sz="1000" b="0">
+                          <a:solidFill>
+                            <a:srgbClr val="187A33"/>
+                          </a:solidFill>
+                          <a:latin typeface="Calibri"/>
+                        </a:rPr>
+                        <a:t>USABLE — apply ×1.11</a:t>
+                      </a:r>
+                    </a:p>
+                  </a:txBody>
+                  <a:tcPr>
+                    <a:solidFill>
+                      <a:srgbClr val="EFF3FA"/>
+                    </a:solidFill>
+                  </a:tcPr>
+                </a:tc>
+              </a:tr>
+              <a:tr h="420624">
+                <a:tc>
+                  <a:txBody>
+                    <a:bodyPr/>
+                    <a:lstStyle/>
+                    <a:p>
+                      <a:r>
+                        <a:rPr sz="1000" b="1">
                           <a:latin typeface="Calibri"/>
                         </a:rPr>
                         <a:t>Kernel activity</a:t>
@@ -3877,36 +3940,36 @@
                   </a:txBody>
                   <a:tcPr>
                     <a:solidFill>
-                      <a:srgbClr val="EFF3FA"/>
-                    </a:solidFill>
-                  </a:tcPr>
-                </a:tc>
-                <a:tc>
-                  <a:txBody>
-                    <a:bodyPr/>
-                    <a:lstStyle/>
-                    <a:p>
-                      <a:r>
-                        <a:rPr sz="1050" b="0">
-                          <a:latin typeface="Calibri"/>
-                        </a:rPr>
-                        <a:t>boot-differential harness live: sha256 kernel+system share MEASURED at 10.0% over user mode (noise floor ±60M insns/cpu stated)</a:t>
-                      </a:r>
-                    </a:p>
-                  </a:txBody>
-                  <a:tcPr>
-                    <a:solidFill>
-                      <a:srgbClr val="EFF3FA"/>
-                    </a:solidFill>
-                  </a:tcPr>
-                </a:tc>
-                <a:tc>
-                  <a:txBody>
-                    <a:bodyPr/>
-                    <a:lstStyle/>
-                    <a:p>
-                      <a:r>
-                        <a:rPr sz="1050" b="0">
+                      <a:srgbClr val="FFFFFF"/>
+                    </a:solidFill>
+                  </a:tcPr>
+                </a:tc>
+                <a:tc>
+                  <a:txBody>
+                    <a:bodyPr/>
+                    <a:lstStyle/>
+                    <a:p>
+                      <a:r>
+                        <a:rPr sz="1000" b="0">
+                          <a:latin typeface="Calibri"/>
+                        </a:rPr>
+                        <a:t>boot-differential harness live: sha256 kernel+system share MEASURED at 10.0% over user mode</a:t>
+                      </a:r>
+                    </a:p>
+                  </a:txBody>
+                  <a:tcPr>
+                    <a:solidFill>
+                      <a:srgbClr val="FFFFFF"/>
+                    </a:solidFill>
+                  </a:tcPr>
+                </a:tc>
+                <a:tc>
+                  <a:txBody>
+                    <a:bodyPr/>
+                    <a:lstStyle/>
+                    <a:p>
+                      <a:r>
+                        <a:rPr sz="1000" b="0">
                           <a:solidFill>
                             <a:srgbClr val="5F6368"/>
                           </a:solidFill>
@@ -3918,57 +3981,57 @@
                   </a:txBody>
                   <a:tcPr>
                     <a:solidFill>
+                      <a:srgbClr val="FFFFFF"/>
+                    </a:solidFill>
+                  </a:tcPr>
+                </a:tc>
+              </a:tr>
+              <a:tr h="420624">
+                <a:tc>
+                  <a:txBody>
+                    <a:bodyPr/>
+                    <a:lstStyle/>
+                    <a:p>
+                      <a:r>
+                        <a:rPr sz="1000" b="1">
+                          <a:latin typeface="Calibri"/>
+                        </a:rPr>
+                        <a:t>DMA / network activity</a:t>
+                      </a:r>
+                    </a:p>
+                  </a:txBody>
+                  <a:tcPr>
+                    <a:solidFill>
                       <a:srgbClr val="EFF3FA"/>
                     </a:solidFill>
                   </a:tcPr>
                 </a:tc>
-              </a:tr>
-              <a:tr h="512064">
-                <a:tc>
-                  <a:txBody>
-                    <a:bodyPr/>
-                    <a:lstStyle/>
-                    <a:p>
-                      <a:r>
-                        <a:rPr sz="1050" b="1">
-                          <a:latin typeface="Calibri"/>
-                        </a:rPr>
-                        <a:t>DMA / network activity</a:t>
-                      </a:r>
-                    </a:p>
-                  </a:txBody>
-                  <a:tcPr>
-                    <a:solidFill>
-                      <a:srgbClr val="FFFFFF"/>
-                    </a:solidFill>
-                  </a:tcPr>
-                </a:tc>
-                <a:tc>
-                  <a:txBody>
-                    <a:bodyPr/>
-                    <a:lstStyle/>
-                    <a:p>
-                      <a:r>
-                        <a:rPr sz="1050" b="0">
-                          <a:latin typeface="Calibri"/>
-                        </a:rPr>
-                        <a:t>full-board harness live: CPU-side traffic visible &amp; coherent (read diff ≈ 2× payload); DMA write invisible to TCG by construction (payload bytes known exactly); kernel share device-path-dependent (silicon NIC 17% vs guest virtio 41%)</a:t>
-                      </a:r>
-                    </a:p>
-                  </a:txBody>
-                  <a:tcPr>
-                    <a:solidFill>
-                      <a:srgbClr val="FFFFFF"/>
-                    </a:solidFill>
-                  </a:tcPr>
-                </a:tc>
-                <a:tc>
-                  <a:txBody>
-                    <a:bodyPr/>
-                    <a:lstStyle/>
-                    <a:p>
-                      <a:r>
-                        <a:rPr sz="1050" b="0">
+                <a:tc>
+                  <a:txBody>
+                    <a:bodyPr/>
+                    <a:lstStyle/>
+                    <a:p>
+                      <a:r>
+                        <a:rPr sz="1000" b="0">
+                          <a:latin typeface="Calibri"/>
+                        </a:rPr>
+                        <a:t>CPU-side traffic visible &amp; coherent; DMA write invisible to TCG by construction; kernel share device-path-dependent (silicon NIC 17% vs virtio 41%)</a:t>
+                      </a:r>
+                    </a:p>
+                  </a:txBody>
+                  <a:tcPr>
+                    <a:solidFill>
+                      <a:srgbClr val="EFF3FA"/>
+                    </a:solidFill>
+                  </a:tcPr>
+                </a:tc>
+                <a:tc>
+                  <a:txBody>
+                    <a:bodyPr/>
+                    <a:lstStyle/>
+                    <a:p>
+                      <a:r>
+                        <a:rPr sz="1000" b="0">
                           <a:solidFill>
                             <a:srgbClr val="5F6368"/>
                           </a:solidFill>
@@ -3980,57 +4043,57 @@
                   </a:txBody>
                   <a:tcPr>
                     <a:solidFill>
+                      <a:srgbClr val="EFF3FA"/>
+                    </a:solidFill>
+                  </a:tcPr>
+                </a:tc>
+              </a:tr>
+              <a:tr h="420624">
+                <a:tc>
+                  <a:txBody>
+                    <a:bodyPr/>
+                    <a:lstStyle/>
+                    <a:p>
+                      <a:r>
+                        <a:rPr sz="1000" b="1">
+                          <a:latin typeface="Calibri"/>
+                        </a:rPr>
+                        <a:t>Multi-core</a:t>
+                      </a:r>
+                    </a:p>
+                  </a:txBody>
+                  <a:tcPr>
+                    <a:solidFill>
                       <a:srgbClr val="FFFFFF"/>
                     </a:solidFill>
                   </a:tcPr>
                 </a:tc>
-              </a:tr>
-              <a:tr h="512064">
-                <a:tc>
-                  <a:txBody>
-                    <a:bodyPr/>
-                    <a:lstStyle/>
-                    <a:p>
-                      <a:r>
-                        <a:rPr sz="1050" b="1">
-                          <a:latin typeface="Calibri"/>
-                        </a:rPr>
-                        <a:t>Multi-core</a:t>
-                      </a:r>
-                    </a:p>
-                  </a:txBody>
-                  <a:tcPr>
-                    <a:solidFill>
-                      <a:srgbClr val="EFF3FA"/>
-                    </a:solidFill>
-                  </a:tcPr>
-                </a:tc>
-                <a:tc>
-                  <a:txBody>
-                    <a:bodyPr/>
-                    <a:lstStyle/>
-                    <a:p>
-                      <a:r>
-                        <a:rPr sz="1050" b="0">
-                          <a:latin typeface="Calibri"/>
-                        </a:rPr>
-                        <a:t>13-point sweep (1/2/4/6T × 3 apps): DRAM ratios thread-invariant (mem rd 0.98 at every N); the +23% insn outlier PROVEN to be OpenMP barrier spin (passive wait: 1.231 → 0.985)</a:t>
-                      </a:r>
-                    </a:p>
-                  </a:txBody>
-                  <a:tcPr>
-                    <a:solidFill>
-                      <a:srgbClr val="EFF3FA"/>
-                    </a:solidFill>
-                  </a:tcPr>
-                </a:tc>
-                <a:tc>
-                  <a:txBody>
-                    <a:bodyPr/>
-                    <a:lstStyle/>
-                    <a:p>
-                      <a:r>
-                        <a:rPr sz="1050" b="0">
+                <a:tc>
+                  <a:txBody>
+                    <a:bodyPr/>
+                    <a:lstStyle/>
+                    <a:p>
+                      <a:r>
+                        <a:rPr sz="1000" b="0">
+                          <a:latin typeface="Calibri"/>
+                        </a:rPr>
+                        <a:t>DRAM ratios thread-invariant across a 1/2/4/6T sweep; the +23% insn outlier PROVEN to be OpenMP barrier spin (passive: 1.231 → 0.985)</a:t>
+                      </a:r>
+                    </a:p>
+                  </a:txBody>
+                  <a:tcPr>
+                    <a:solidFill>
+                      <a:srgbClr val="FFFFFF"/>
+                    </a:solidFill>
+                  </a:tcPr>
+                </a:tc>
+                <a:tc>
+                  <a:txBody>
+                    <a:bodyPr/>
+                    <a:lstStyle/>
+                    <a:p>
+                      <a:r>
+                        <a:rPr sz="1000" b="0">
                           <a:solidFill>
                             <a:srgbClr val="187A33"/>
                           </a:solidFill>
@@ -4042,7 +4105,7 @@
                   </a:txBody>
                   <a:tcPr>
                     <a:solidFill>
-                      <a:srgbClr val="EFF3FA"/>
+                      <a:srgbClr val="FFFFFF"/>
                     </a:solidFill>
                   </a:tcPr>
                 </a:tc>
@@ -4059,7 +4122,7 @@
         </p:nvSpPr>
         <p:spPr>
           <a:xfrm>
-            <a:off x="548640" y="4709160"/>
+            <a:off x="548640" y="5486400"/>
             <a:ext cx="11064240" cy="731520"/>
           </a:xfrm>
           <a:prstGeom prst="rect">
@@ -4094,7 +4157,7 @@
         </p:nvSpPr>
         <p:spPr>
           <a:xfrm>
-            <a:off x="548640" y="5577840"/>
+            <a:off x="548640" y="6199632"/>
             <a:ext cx="11064240" cy="548640"/>
           </a:xfrm>
           <a:prstGeom prst="rect">
@@ -6892,7 +6955,7 @@
                 </a:solidFill>
                 <a:latin typeface="Calibri"/>
               </a:rPr>
-              <a:t>Every outlier resolved to a mechanism, not a fudge</a:t>
+              <a:t>The 50-application held-out validation</a:t>
             </a:r>
           </a:p>
         </p:txBody>
@@ -6970,7 +7033,7 @@
                 </a:solidFill>
                 <a:latin typeface="Calibri"/>
               </a:rPr>
-              <a:t>The band tightened from ×/÷2.4 to ×/÷1.26 in three fixes; each was falsifiable and predicted its own after-number.</a:t>
+              <a:t>Corrections fitted on the 14 development apps (train), then applied cold to 36 applications the model had never seen (holdout).</a:t>
             </a:r>
           </a:p>
         </p:txBody>
@@ -7045,748 +7108,30 @@
           </a:p>
         </p:txBody>
       </p:sp>
-      <p:graphicFrame>
-        <p:nvGraphicFramePr>
-          <p:cNvPr id="8" name="Table 7"/>
-          <p:cNvGraphicFramePr>
-            <a:graphicFrameLocks noGrp="1"/>
-          </p:cNvGraphicFramePr>
+      <p:pic>
+        <p:nvPicPr>
+          <p:cNvPr id="8" name="Picture 7" descr="scatter50.png"/>
+          <p:cNvPicPr>
+            <a:picLocks noChangeAspect="1"/>
+          </p:cNvPicPr>
           <p:nvPr/>
-        </p:nvGraphicFramePr>
-        <p:xfrm>
-          <a:off x="548640" y="1463040"/>
-          <a:ext cx="11064240" cy="4608576"/>
-        </p:xfrm>
-        <a:graphic>
-          <a:graphicData uri="http://schemas.openxmlformats.org/drawingml/2006/table">
-            <a:tbl>
-              <a:tblPr firstRow="1" bandRow="1">
-                <a:tableStyleId>{5C22544A-7EE6-4342-B048-85BDC9FD1C3A}</a:tableStyleId>
-              </a:tblPr>
-              <a:tblGrid>
-                <a:gridCol w="2057400"/>
-                <a:gridCol w="4480560"/>
-                <a:gridCol w="2377440"/>
-                <a:gridCol w="2148840"/>
-              </a:tblGrid>
-              <a:tr h="512064">
-                <a:tc>
-                  <a:txBody>
-                    <a:bodyPr/>
-                    <a:lstStyle/>
-                    <a:p>
-                      <a:r>
-                        <a:rPr sz="1000" b="1">
-                          <a:solidFill>
-                            <a:srgbClr val="FFFFFF"/>
-                          </a:solidFill>
-                          <a:latin typeface="Calibri"/>
-                        </a:rPr>
-                        <a:t>observation</a:t>
-                      </a:r>
-                    </a:p>
-                  </a:txBody>
-                  <a:tcPr>
-                    <a:solidFill>
-                      <a:srgbClr val="202124"/>
-                    </a:solidFill>
-                  </a:tcPr>
-                </a:tc>
-                <a:tc>
-                  <a:txBody>
-                    <a:bodyPr/>
-                    <a:lstStyle/>
-                    <a:p>
-                      <a:r>
-                        <a:rPr sz="1000" b="1">
-                          <a:solidFill>
-                            <a:srgbClr val="FFFFFF"/>
-                          </a:solidFill>
-                          <a:latin typeface="Calibri"/>
-                        </a:rPr>
-                        <a:t>mechanism</a:t>
-                      </a:r>
-                    </a:p>
-                  </a:txBody>
-                  <a:tcPr>
-                    <a:solidFill>
-                      <a:srgbClr val="202124"/>
-                    </a:solidFill>
-                  </a:tcPr>
-                </a:tc>
-                <a:tc>
-                  <a:txBody>
-                    <a:bodyPr/>
-                    <a:lstStyle/>
-                    <a:p>
-                      <a:r>
-                        <a:rPr sz="1000" b="1">
-                          <a:solidFill>
-                            <a:srgbClr val="FFFFFF"/>
-                          </a:solidFill>
-                          <a:latin typeface="Calibri"/>
-                        </a:rPr>
-                        <a:t>fix</a:t>
-                      </a:r>
-                    </a:p>
-                  </a:txBody>
-                  <a:tcPr>
-                    <a:solidFill>
-                      <a:srgbClr val="202124"/>
-                    </a:solidFill>
-                  </a:tcPr>
-                </a:tc>
-                <a:tc>
-                  <a:txBody>
-                    <a:bodyPr/>
-                    <a:lstStyle/>
-                    <a:p>
-                      <a:r>
-                        <a:rPr sz="1000" b="1">
-                          <a:solidFill>
-                            <a:srgbClr val="FFFFFF"/>
-                          </a:solidFill>
-                          <a:latin typeface="Calibri"/>
-                        </a:rPr>
-                        <a:t>after</a:t>
-                      </a:r>
-                    </a:p>
-                  </a:txBody>
-                  <a:tcPr>
-                    <a:solidFill>
-                      <a:srgbClr val="202124"/>
-                    </a:solidFill>
-                  </a:tcPr>
-                </a:tc>
-              </a:tr>
-              <a:tr h="512064">
-                <a:tc>
-                  <a:txBody>
-                    <a:bodyPr/>
-                    <a:lstStyle/>
-                    <a:p>
-                      <a:r>
-                        <a:rPr sz="1000" b="1">
-                          <a:latin typeface="Calibri"/>
-                        </a:rPr>
-                        <a:t>mm read 0.44 (v0)</a:t>
-                      </a:r>
-                    </a:p>
-                  </a:txBody>
-                  <a:tcPr>
-                    <a:solidFill>
-                      <a:srgbClr val="EFF3FA"/>
-                    </a:solidFill>
-                  </a:tcPr>
-                </a:tc>
-                <a:tc>
-                  <a:txBody>
-                    <a:bodyPr/>
-                    <a:lstStyle/>
-                    <a:p>
-                      <a:r>
-                        <a:rPr sz="1000" b="0">
-                          <a:latin typeface="Calibri"/>
-                        </a:rPr>
-                        <a:t>plugin default cache ≫ real 64 KiB L2 — model thought the working set was resident</a:t>
-                      </a:r>
-                    </a:p>
-                  </a:txBody>
-                  <a:tcPr>
-                    <a:solidFill>
-                      <a:srgbClr val="EFF3FA"/>
-                    </a:solidFill>
-                  </a:tcPr>
-                </a:tc>
-                <a:tc>
-                  <a:txBody>
-                    <a:bodyPr/>
-                    <a:lstStyle/>
-                    <a:p>
-                      <a:r>
-                        <a:rPr sz="1000" b="0">
-                          <a:latin typeface="Calibri"/>
-                        </a:rPr>
-                        <a:t>model the sysfs hierarchy</a:t>
-                      </a:r>
-                    </a:p>
-                  </a:txBody>
-                  <a:tcPr>
-                    <a:solidFill>
-                      <a:srgbClr val="EFF3FA"/>
-                    </a:solidFill>
-                  </a:tcPr>
-                </a:tc>
-                <a:tc>
-                  <a:txBody>
-                    <a:bodyPr/>
-                    <a:lstStyle/>
-                    <a:p>
-                      <a:r>
-                        <a:rPr sz="1000" b="0">
-                          <a:latin typeface="Calibri"/>
-                        </a:rPr>
-                        <a:t>0.65 (residual = prefetch)</a:t>
-                      </a:r>
-                    </a:p>
-                  </a:txBody>
-                  <a:tcPr>
-                    <a:solidFill>
-                      <a:srgbClr val="EFF3FA"/>
-                    </a:solidFill>
-                  </a:tcPr>
-                </a:tc>
-              </a:tr>
-              <a:tr h="512064">
-                <a:tc>
-                  <a:txBody>
-                    <a:bodyPr/>
-                    <a:lstStyle/>
-                    <a:p>
-                      <a:r>
-                        <a:rPr sz="1000" b="1">
-                          <a:latin typeface="Calibri"/>
-                        </a:rPr>
-                        <a:t>mem read 1.97 (v0)</a:t>
-                      </a:r>
-                    </a:p>
-                  </a:txBody>
-                  <a:tcPr>
-                    <a:solidFill>
-                      <a:srgbClr val="FFFFFF"/>
-                    </a:solidFill>
-                  </a:tcPr>
-                </a:tc>
-                <a:tc>
-                  <a:txBody>
-                    <a:bodyPr/>
-                    <a:lstStyle/>
-                    <a:p>
-                      <a:r>
-                        <a:rPr sz="1000" b="0">
-                          <a:latin typeface="Calibri"/>
-                        </a:rPr>
-                        <a:t>A55 write-streaming: no-allocate store bursts; plugin read-allocated every store</a:t>
-                      </a:r>
-                    </a:p>
-                  </a:txBody>
-                  <a:tcPr>
-                    <a:solidFill>
-                      <a:srgbClr val="FFFFFF"/>
-                    </a:solidFill>
-                  </a:tcPr>
-                </a:tc>
-                <a:tc>
-                  <a:txBody>
-                    <a:bodyPr/>
-                    <a:lstStyle/>
-                    <a:p>
-                      <a:r>
-                        <a:rPr sz="1000" b="0">
-                          <a:latin typeface="Calibri"/>
-                        </a:rPr>
-                        <a:t>streak detector, ≥4 lines → no-allocate</a:t>
-                      </a:r>
-                    </a:p>
-                  </a:txBody>
-                  <a:tcPr>
-                    <a:solidFill>
-                      <a:srgbClr val="FFFFFF"/>
-                    </a:solidFill>
-                  </a:tcPr>
-                </a:tc>
-                <a:tc>
-                  <a:txBody>
-                    <a:bodyPr/>
-                    <a:lstStyle/>
-                    <a:p>
-                      <a:r>
-                        <a:rPr sz="1000" b="0">
-                          <a:latin typeface="Calibri"/>
-                        </a:rPr>
-                        <a:t>0.98</a:t>
-                      </a:r>
-                    </a:p>
-                  </a:txBody>
-                  <a:tcPr>
-                    <a:solidFill>
-                      <a:srgbClr val="FFFFFF"/>
-                    </a:solidFill>
-                  </a:tcPr>
-                </a:tc>
-              </a:tr>
-              <a:tr h="512064">
-                <a:tc>
-                  <a:txBody>
-                    <a:bodyPr/>
-                    <a:lstStyle/>
-                    <a:p>
-                      <a:r>
-                        <a:rPr sz="1000" b="1">
-                          <a:latin typeface="Calibri"/>
-                        </a:rPr>
-                        <a:t>sha256 'read 15×'</a:t>
-                      </a:r>
-                    </a:p>
-                  </a:txBody>
-                  <a:tcPr>
-                    <a:solidFill>
-                      <a:srgbClr val="EFF3FA"/>
-                    </a:solidFill>
-                  </a:tcPr>
-                </a:tc>
-                <a:tc>
-                  <a:txBody>
-                    <a:bodyPr/>
-                    <a:lstStyle/>
-                    <a:p>
-                      <a:r>
-                        <a:rPr sz="1000" b="0">
-                          <a:latin typeface="Calibri"/>
-                        </a:rPr>
-                        <a:t>l3d_cache_refill counts demand only; the prefetcher served the stream invisibly</a:t>
-                      </a:r>
-                    </a:p>
-                  </a:txBody>
-                  <a:tcPr>
-                    <a:solidFill>
-                      <a:srgbClr val="EFF3FA"/>
-                    </a:solidFill>
-                  </a:tcPr>
-                </a:tc>
-                <a:tc>
-                  <a:txBody>
-                    <a:bodyPr/>
-                    <a:lstStyle/>
-                    <a:p>
-                      <a:r>
-                        <a:rPr sz="1000" b="0">
-                          <a:latin typeface="Calibri"/>
-                        </a:rPr>
-                        <a:t>ground-truth at the DDR controller</a:t>
-                      </a:r>
-                    </a:p>
-                  </a:txBody>
-                  <a:tcPr>
-                    <a:solidFill>
-                      <a:srgbClr val="EFF3FA"/>
-                    </a:solidFill>
-                  </a:tcPr>
-                </a:tc>
-                <a:tc>
-                  <a:txBody>
-                    <a:bodyPr/>
-                    <a:lstStyle/>
-                    <a:p>
-                      <a:r>
-                        <a:rPr sz="1000" b="0">
-                          <a:latin typeface="Calibri"/>
-                        </a:rPr>
-                        <a:t>0.77 (real gap, real sign)</a:t>
-                      </a:r>
-                    </a:p>
-                  </a:txBody>
-                  <a:tcPr>
-                    <a:solidFill>
-                      <a:srgbClr val="EFF3FA"/>
-                    </a:solidFill>
-                  </a:tcPr>
-                </a:tc>
-              </a:tr>
-              <a:tr h="512064">
-                <a:tc>
-                  <a:txBody>
-                    <a:bodyPr/>
-                    <a:lstStyle/>
-                    <a:p>
-                      <a:r>
-                        <a:rPr sz="1000" b="1">
-                          <a:latin typeface="Calibri"/>
-                        </a:rPr>
-                        <a:t>pacman/sqlite/lz4/lua ~0</a:t>
-                      </a:r>
-                    </a:p>
-                  </a:txBody>
-                  <a:tcPr>
-                    <a:solidFill>
-                      <a:srgbClr val="FFFFFF"/>
-                    </a:solidFill>
-                  </a:tcPr>
-                </a:tc>
-                <a:tc>
-                  <a:txBody>
-                    <a:bodyPr/>
-                    <a:lstStyle/>
-                    <a:p>
-                      <a:r>
-                        <a:rPr sz="1000" b="0">
-                          <a:latin typeface="Calibri"/>
-                        </a:rPr>
-                        <a:t>true traffic below the DDR counter's ~0.4 M-line/window noise floor (calibrated by alu)</a:t>
-                      </a:r>
-                    </a:p>
-                  </a:txBody>
-                  <a:tcPr>
-                    <a:solidFill>
-                      <a:srgbClr val="FFFFFF"/>
-                    </a:solidFill>
-                  </a:tcPr>
-                </a:tc>
-                <a:tc>
-                  <a:txBody>
-                    <a:bodyPr/>
-                    <a:lstStyle/>
-                    <a:p>
-                      <a:r>
-                        <a:rPr sz="1000" b="0">
-                          <a:latin typeface="Calibri"/>
-                        </a:rPr>
-                        <a:t>classify, don't fit</a:t>
-                      </a:r>
-                    </a:p>
-                  </a:txBody>
-                  <a:tcPr>
-                    <a:solidFill>
-                      <a:srgbClr val="FFFFFF"/>
-                    </a:solidFill>
-                  </a:tcPr>
-                </a:tc>
-                <a:tc>
-                  <a:txBody>
-                    <a:bodyPr/>
-                    <a:lstStyle/>
-                    <a:p>
-                      <a:r>
-                        <a:rPr sz="1000" b="0">
-                          <a:latin typeface="Calibri"/>
-                        </a:rPr>
-                        <a:t>correctly predicted quiet</a:t>
-                      </a:r>
-                    </a:p>
-                  </a:txBody>
-                  <a:tcPr>
-                    <a:solidFill>
-                      <a:srgbClr val="FFFFFF"/>
-                    </a:solidFill>
-                  </a:tcPr>
-                </a:tc>
-              </a:tr>
-              <a:tr h="512064">
-                <a:tc>
-                  <a:txBody>
-                    <a:bodyPr/>
-                    <a:lstStyle/>
-                    <a:p>
-                      <a:r>
-                        <a:rPr sz="1000" b="1">
-                          <a:latin typeface="Calibri"/>
-                        </a:rPr>
-                        <a:t>bzip2 0.49</a:t>
-                      </a:r>
-                    </a:p>
-                  </a:txBody>
-                  <a:tcPr>
-                    <a:solidFill>
-                      <a:srgbClr val="EFF3FA"/>
-                    </a:solidFill>
-                  </a:tcPr>
-                </a:tc>
-                <a:tc>
-                  <a:txBody>
-                    <a:bodyPr/>
-                    <a:lstStyle/>
-                    <a:p>
-                      <a:r>
-                        <a:rPr sz="1000" b="0">
-                          <a:latin typeface="Calibri"/>
-                        </a:rPr>
-                        <a:t>prefetcher over-fetch on semi-sequential patterns — silicon reads ~2× the demand traffic</a:t>
-                      </a:r>
-                    </a:p>
-                  </a:txBody>
-                  <a:tcPr>
-                    <a:solidFill>
-                      <a:srgbClr val="EFF3FA"/>
-                    </a:solidFill>
-                  </a:tcPr>
-                </a:tc>
-                <a:tc>
-                  <a:txBody>
-                    <a:bodyPr/>
-                    <a:lstStyle/>
-                    <a:p>
-                      <a:r>
-                        <a:rPr sz="1000" b="0">
-                          <a:latin typeface="Calibri"/>
-                        </a:rPr>
-                        <a:t>prefetch model, or per-class factor</a:t>
-                      </a:r>
-                    </a:p>
-                  </a:txBody>
-                  <a:tcPr>
-                    <a:solidFill>
-                      <a:srgbClr val="EFF3FA"/>
-                    </a:solidFill>
-                  </a:tcPr>
-                </a:tc>
-                <a:tc>
-                  <a:txBody>
-                    <a:bodyPr/>
-                    <a:lstStyle/>
-                    <a:p>
-                      <a:r>
-                        <a:rPr sz="1000" b="0">
-                          <a:latin typeface="Calibri"/>
-                        </a:rPr>
-                        <a:t>open, named</a:t>
-                      </a:r>
-                    </a:p>
-                  </a:txBody>
-                  <a:tcPr>
-                    <a:solidFill>
-                      <a:srgbClr val="EFF3FA"/>
-                    </a:solidFill>
-                  </a:tcPr>
-                </a:tc>
-              </a:tr>
-              <a:tr h="512064">
-                <a:tc>
-                  <a:txBody>
-                    <a:bodyPr/>
-                    <a:lstStyle/>
-                    <a:p>
-                      <a:r>
-                        <a:rPr sz="1000" b="1">
-                          <a:latin typeface="Calibri"/>
-                        </a:rPr>
-                        <a:t>writes 0.02–0.09 (v1)</a:t>
-                      </a:r>
-                    </a:p>
-                  </a:txBody>
-                  <a:tcPr>
-                    <a:solidFill>
-                      <a:srgbClr val="FFFFFF"/>
-                    </a:solidFill>
-                  </a:tcPr>
-                </a:tc>
-                <a:tc>
-                  <a:txBody>
-                    <a:bodyPr/>
-                    <a:lstStyle/>
-                    <a:p>
-                      <a:r>
-                        <a:rPr sz="1000" b="0">
-                          <a:latin typeface="Calibri"/>
-                        </a:rPr>
-                        <a:t>scattered stores exit DRAM as dirty EVICTIONS, which no allocation-time count can see</a:t>
-                      </a:r>
-                    </a:p>
-                  </a:txBody>
-                  <a:tcPr>
-                    <a:solidFill>
-                      <a:srgbClr val="FFFFFF"/>
-                    </a:solidFill>
-                  </a:tcPr>
-                </a:tc>
-                <a:tc>
-                  <a:txBody>
-                    <a:bodyPr/>
-                    <a:lstStyle/>
-                    <a:p>
-                      <a:r>
-                        <a:rPr sz="1000" b="0">
-                          <a:latin typeface="Calibri"/>
-                        </a:rPr>
-                        <a:t>X1: dirty-line set + last-level eviction counting</a:t>
-                      </a:r>
-                    </a:p>
-                  </a:txBody>
-                  <a:tcPr>
-                    <a:solidFill>
-                      <a:srgbClr val="FFFFFF"/>
-                    </a:solidFill>
-                  </a:tcPr>
-                </a:tc>
-                <a:tc>
-                  <a:txBody>
-                    <a:bodyPr/>
-                    <a:lstStyle/>
-                    <a:p>
-                      <a:r>
-                        <a:rPr sz="1000" b="0">
-                          <a:latin typeface="Calibri"/>
-                        </a:rPr>
-                        <a:t>0.90 ×/÷ 1.09</a:t>
-                      </a:r>
-                    </a:p>
-                  </a:txBody>
-                  <a:tcPr>
-                    <a:solidFill>
-                      <a:srgbClr val="FFFFFF"/>
-                    </a:solidFill>
-                  </a:tcPr>
-                </a:tc>
-              </a:tr>
-              <a:tr h="512064">
-                <a:tc>
-                  <a:txBody>
-                    <a:bodyPr/>
-                    <a:lstStyle/>
-                    <a:p>
-                      <a:r>
-                        <a:rPr sz="1000" b="1">
-                          <a:latin typeface="Calibri"/>
-                        </a:rPr>
-                        <a:t>sgm-mt insns 1.23 @4T</a:t>
-                      </a:r>
-                    </a:p>
-                  </a:txBody>
-                  <a:tcPr>
-                    <a:solidFill>
-                      <a:srgbClr val="EFF3FA"/>
-                    </a:solidFill>
-                  </a:tcPr>
-                </a:tc>
-                <a:tc>
-                  <a:txBody>
-                    <a:bodyPr/>
-                    <a:lstStyle/>
-                    <a:p>
-                      <a:r>
-                        <a:rPr sz="1000" b="0">
-                          <a:latin typeface="Calibri"/>
-                        </a:rPr>
-                        <a:t>OpenMP barrier SPIN — timing-dependent instructions, inflated by instrumentation skew</a:t>
-                      </a:r>
-                    </a:p>
-                  </a:txBody>
-                  <a:tcPr>
-                    <a:solidFill>
-                      <a:srgbClr val="EFF3FA"/>
-                    </a:solidFill>
-                  </a:tcPr>
-                </a:tc>
-                <a:tc>
-                  <a:txBody>
-                    <a:bodyPr/>
-                    <a:lstStyle/>
-                    <a:p>
-                      <a:r>
-                        <a:rPr sz="1000" b="0">
-                          <a:latin typeface="Calibri"/>
-                        </a:rPr>
-                        <a:t>X3: OMP_WAIT_POLICY=passive (proven, not argued)</a:t>
-                      </a:r>
-                    </a:p>
-                  </a:txBody>
-                  <a:tcPr>
-                    <a:solidFill>
-                      <a:srgbClr val="EFF3FA"/>
-                    </a:solidFill>
-                  </a:tcPr>
-                </a:tc>
-                <a:tc>
-                  <a:txBody>
-                    <a:bodyPr/>
-                    <a:lstStyle/>
-                    <a:p>
-                      <a:r>
-                        <a:rPr sz="1000" b="0">
-                          <a:latin typeface="Calibri"/>
-                        </a:rPr>
-                        <a:t>0.985; DRAM unmoved</a:t>
-                      </a:r>
-                    </a:p>
-                  </a:txBody>
-                  <a:tcPr>
-                    <a:solidFill>
-                      <a:srgbClr val="EFF3FA"/>
-                    </a:solidFill>
-                  </a:tcPr>
-                </a:tc>
-              </a:tr>
-              <a:tr h="512064">
-                <a:tc>
-                  <a:txBody>
-                    <a:bodyPr/>
-                    <a:lstStyle/>
-                    <a:p>
-                      <a:r>
-                        <a:rPr sz="1000" b="1">
-                          <a:latin typeface="Calibri"/>
-                        </a:rPr>
-                        <a:t>reads 0.49–0.77 (under)</a:t>
-                      </a:r>
-                    </a:p>
-                  </a:txBody>
-                  <a:tcPr>
-                    <a:solidFill>
-                      <a:srgbClr val="FFFFFF"/>
-                    </a:solidFill>
-                  </a:tcPr>
-                </a:tc>
-                <a:tc>
-                  <a:txBody>
-                    <a:bodyPr/>
-                    <a:lstStyle/>
-                    <a:p>
-                      <a:r>
-                        <a:rPr sz="1000" b="0">
-                          <a:latin typeface="Calibri"/>
-                        </a:rPr>
-                        <a:t>silicon prefetcher traffic the model never issued</a:t>
-                      </a:r>
-                    </a:p>
-                  </a:txBody>
-                  <a:tcPr>
-                    <a:solidFill>
-                      <a:srgbClr val="FFFFFF"/>
-                    </a:solidFill>
-                  </a:tcPr>
-                </a:tc>
-                <a:tc>
-                  <a:txBody>
-                    <a:bodyPr/>
-                    <a:lstStyle/>
-                    <a:p>
-                      <a:r>
-                        <a:rPr sz="1000" b="0">
-                          <a:latin typeface="Calibri"/>
-                        </a:rPr>
-                        <a:t>X4: 8-stream table, miss-trained, strict +1, ramped depth</a:t>
-                      </a:r>
-                    </a:p>
-                  </a:txBody>
-                  <a:tcPr>
-                    <a:solidFill>
-                      <a:srgbClr val="FFFFFF"/>
-                    </a:solidFill>
-                  </a:tcPr>
-                </a:tc>
-                <a:tc>
-                  <a:txBody>
-                    <a:bodyPr/>
-                    <a:lstStyle/>
-                    <a:p>
-                      <a:r>
-                        <a:rPr sz="1000" b="0">
-                          <a:latin typeface="Calibri"/>
-                        </a:rPr>
-                        <a:t>0.98 ×/÷ 1.14</a:t>
-                      </a:r>
-                    </a:p>
-                  </a:txBody>
-                  <a:tcPr>
-                    <a:solidFill>
-                      <a:srgbClr val="FFFFFF"/>
-                    </a:solidFill>
-                  </a:tcPr>
-                </a:tc>
-              </a:tr>
-            </a:tbl>
-          </a:graphicData>
-        </a:graphic>
-      </p:graphicFrame>
+        </p:nvPicPr>
+        <p:blipFill>
+          <a:blip r:embed="rId2"/>
+          <a:stretch>
+            <a:fillRect/>
+          </a:stretch>
+        </p:blipFill>
+        <p:spPr>
+          <a:xfrm>
+            <a:off x="1325880" y="1371600"/>
+            <a:ext cx="9509760" cy="4389120"/>
+          </a:xfrm>
+          <a:prstGeom prst="rect">
+            <a:avLst/>
+          </a:prstGeom>
+        </p:spPr>
+      </p:pic>
       <p:sp>
         <p:nvSpPr>
           <p:cNvPr id="9" name="TextBox 8"/>
@@ -7795,8 +7140,8 @@
         </p:nvSpPr>
         <p:spPr>
           <a:xfrm>
-            <a:off x="548640" y="5257800"/>
-            <a:ext cx="11064240" cy="731520"/>
+            <a:off x="548640" y="5989320"/>
+            <a:ext cx="11064240" cy="640080"/>
           </a:xfrm>
           <a:prstGeom prst="rect">
             <a:avLst/>
@@ -7811,13 +7156,13 @@
           <a:p>
             <a:pPr algn="l"/>
             <a:r>
-              <a:rPr sz="1150" b="0">
+              <a:rPr sz="1150" b="1">
                 <a:solidFill>
                   <a:srgbClr val="202124"/>
                 </a:solidFill>
                 <a:latin typeface="Calibri"/>
               </a:rPr>
-              <a:t>The X1 row landed after this deck's first printing and proves the pattern: the named mechanism, implemented in an afternoon, moved six workloads from near-zero to 0.73–1.03 without touching the read side. Mechanism-first iteration converges; fudge-factor iteration doesn't.</a:t>
+              <a:t>Held-out instructions 0.979 ×/÷ 1.04 (n=37) · held-out reads 0.91 ×/÷ 1.21 — the SAME spread as the fitted population · writes 0.83 ×/÷ 1.28 · every DRAM-quiet app correctly classified. A variance projection built on 14 applications predicted 36 it had never seen — the factors are properties of the model, not of the apps they were fitted on.</a:t>
             </a:r>
           </a:p>
         </p:txBody>
@@ -7913,7 +7258,7 @@
                 </a:solidFill>
                 <a:latin typeface="Calibri"/>
               </a:rPr>
-              <a:t>What this licenses, and what it does not</a:t>
+              <a:t>Every outlier resolved to a mechanism, not a fudge</a:t>
             </a:r>
           </a:p>
         </p:txBody>
@@ -7991,7 +7336,7 @@
                 </a:solidFill>
                 <a:latin typeface="Calibri"/>
               </a:rPr>
-              <a:t>The trust statement, quantity by quantity.</a:t>
+              <a:t>The band tightened from ×/÷2.4 to ×/÷1.26 in three fixes; each was falsifiable and predicted its own after-number.</a:t>
             </a:r>
           </a:p>
         </p:txBody>
@@ -8076,7 +7421,1028 @@
         </p:nvGraphicFramePr>
         <p:xfrm>
           <a:off x="548640" y="1463040"/>
-          <a:ext cx="11064240" cy="3803904"/>
+          <a:ext cx="11064240" cy="4608576"/>
+        </p:xfrm>
+        <a:graphic>
+          <a:graphicData uri="http://schemas.openxmlformats.org/drawingml/2006/table">
+            <a:tbl>
+              <a:tblPr firstRow="1" bandRow="1">
+                <a:tableStyleId>{5C22544A-7EE6-4342-B048-85BDC9FD1C3A}</a:tableStyleId>
+              </a:tblPr>
+              <a:tblGrid>
+                <a:gridCol w="2057400"/>
+                <a:gridCol w="4480560"/>
+                <a:gridCol w="2377440"/>
+                <a:gridCol w="2148840"/>
+              </a:tblGrid>
+              <a:tr h="512064">
+                <a:tc>
+                  <a:txBody>
+                    <a:bodyPr/>
+                    <a:lstStyle/>
+                    <a:p>
+                      <a:r>
+                        <a:rPr sz="1000" b="1">
+                          <a:solidFill>
+                            <a:srgbClr val="FFFFFF"/>
+                          </a:solidFill>
+                          <a:latin typeface="Calibri"/>
+                        </a:rPr>
+                        <a:t>observation</a:t>
+                      </a:r>
+                    </a:p>
+                  </a:txBody>
+                  <a:tcPr>
+                    <a:solidFill>
+                      <a:srgbClr val="202124"/>
+                    </a:solidFill>
+                  </a:tcPr>
+                </a:tc>
+                <a:tc>
+                  <a:txBody>
+                    <a:bodyPr/>
+                    <a:lstStyle/>
+                    <a:p>
+                      <a:r>
+                        <a:rPr sz="1000" b="1">
+                          <a:solidFill>
+                            <a:srgbClr val="FFFFFF"/>
+                          </a:solidFill>
+                          <a:latin typeface="Calibri"/>
+                        </a:rPr>
+                        <a:t>mechanism</a:t>
+                      </a:r>
+                    </a:p>
+                  </a:txBody>
+                  <a:tcPr>
+                    <a:solidFill>
+                      <a:srgbClr val="202124"/>
+                    </a:solidFill>
+                  </a:tcPr>
+                </a:tc>
+                <a:tc>
+                  <a:txBody>
+                    <a:bodyPr/>
+                    <a:lstStyle/>
+                    <a:p>
+                      <a:r>
+                        <a:rPr sz="1000" b="1">
+                          <a:solidFill>
+                            <a:srgbClr val="FFFFFF"/>
+                          </a:solidFill>
+                          <a:latin typeface="Calibri"/>
+                        </a:rPr>
+                        <a:t>fix</a:t>
+                      </a:r>
+                    </a:p>
+                  </a:txBody>
+                  <a:tcPr>
+                    <a:solidFill>
+                      <a:srgbClr val="202124"/>
+                    </a:solidFill>
+                  </a:tcPr>
+                </a:tc>
+                <a:tc>
+                  <a:txBody>
+                    <a:bodyPr/>
+                    <a:lstStyle/>
+                    <a:p>
+                      <a:r>
+                        <a:rPr sz="1000" b="1">
+                          <a:solidFill>
+                            <a:srgbClr val="FFFFFF"/>
+                          </a:solidFill>
+                          <a:latin typeface="Calibri"/>
+                        </a:rPr>
+                        <a:t>after</a:t>
+                      </a:r>
+                    </a:p>
+                  </a:txBody>
+                  <a:tcPr>
+                    <a:solidFill>
+                      <a:srgbClr val="202124"/>
+                    </a:solidFill>
+                  </a:tcPr>
+                </a:tc>
+              </a:tr>
+              <a:tr h="512064">
+                <a:tc>
+                  <a:txBody>
+                    <a:bodyPr/>
+                    <a:lstStyle/>
+                    <a:p>
+                      <a:r>
+                        <a:rPr sz="1000" b="1">
+                          <a:latin typeface="Calibri"/>
+                        </a:rPr>
+                        <a:t>mm read 0.44 (v0)</a:t>
+                      </a:r>
+                    </a:p>
+                  </a:txBody>
+                  <a:tcPr>
+                    <a:solidFill>
+                      <a:srgbClr val="EFF3FA"/>
+                    </a:solidFill>
+                  </a:tcPr>
+                </a:tc>
+                <a:tc>
+                  <a:txBody>
+                    <a:bodyPr/>
+                    <a:lstStyle/>
+                    <a:p>
+                      <a:r>
+                        <a:rPr sz="1000" b="0">
+                          <a:latin typeface="Calibri"/>
+                        </a:rPr>
+                        <a:t>plugin default cache ≫ real 64 KiB L2 — model thought the working set was resident</a:t>
+                      </a:r>
+                    </a:p>
+                  </a:txBody>
+                  <a:tcPr>
+                    <a:solidFill>
+                      <a:srgbClr val="EFF3FA"/>
+                    </a:solidFill>
+                  </a:tcPr>
+                </a:tc>
+                <a:tc>
+                  <a:txBody>
+                    <a:bodyPr/>
+                    <a:lstStyle/>
+                    <a:p>
+                      <a:r>
+                        <a:rPr sz="1000" b="0">
+                          <a:latin typeface="Calibri"/>
+                        </a:rPr>
+                        <a:t>model the sysfs hierarchy</a:t>
+                      </a:r>
+                    </a:p>
+                  </a:txBody>
+                  <a:tcPr>
+                    <a:solidFill>
+                      <a:srgbClr val="EFF3FA"/>
+                    </a:solidFill>
+                  </a:tcPr>
+                </a:tc>
+                <a:tc>
+                  <a:txBody>
+                    <a:bodyPr/>
+                    <a:lstStyle/>
+                    <a:p>
+                      <a:r>
+                        <a:rPr sz="1000" b="0">
+                          <a:latin typeface="Calibri"/>
+                        </a:rPr>
+                        <a:t>0.65 (residual = prefetch)</a:t>
+                      </a:r>
+                    </a:p>
+                  </a:txBody>
+                  <a:tcPr>
+                    <a:solidFill>
+                      <a:srgbClr val="EFF3FA"/>
+                    </a:solidFill>
+                  </a:tcPr>
+                </a:tc>
+              </a:tr>
+              <a:tr h="512064">
+                <a:tc>
+                  <a:txBody>
+                    <a:bodyPr/>
+                    <a:lstStyle/>
+                    <a:p>
+                      <a:r>
+                        <a:rPr sz="1000" b="1">
+                          <a:latin typeface="Calibri"/>
+                        </a:rPr>
+                        <a:t>mem read 1.97 (v0)</a:t>
+                      </a:r>
+                    </a:p>
+                  </a:txBody>
+                  <a:tcPr>
+                    <a:solidFill>
+                      <a:srgbClr val="FFFFFF"/>
+                    </a:solidFill>
+                  </a:tcPr>
+                </a:tc>
+                <a:tc>
+                  <a:txBody>
+                    <a:bodyPr/>
+                    <a:lstStyle/>
+                    <a:p>
+                      <a:r>
+                        <a:rPr sz="1000" b="0">
+                          <a:latin typeface="Calibri"/>
+                        </a:rPr>
+                        <a:t>A55 write-streaming: no-allocate store bursts; plugin read-allocated every store</a:t>
+                      </a:r>
+                    </a:p>
+                  </a:txBody>
+                  <a:tcPr>
+                    <a:solidFill>
+                      <a:srgbClr val="FFFFFF"/>
+                    </a:solidFill>
+                  </a:tcPr>
+                </a:tc>
+                <a:tc>
+                  <a:txBody>
+                    <a:bodyPr/>
+                    <a:lstStyle/>
+                    <a:p>
+                      <a:r>
+                        <a:rPr sz="1000" b="0">
+                          <a:latin typeface="Calibri"/>
+                        </a:rPr>
+                        <a:t>streak detector, ≥4 lines → no-allocate</a:t>
+                      </a:r>
+                    </a:p>
+                  </a:txBody>
+                  <a:tcPr>
+                    <a:solidFill>
+                      <a:srgbClr val="FFFFFF"/>
+                    </a:solidFill>
+                  </a:tcPr>
+                </a:tc>
+                <a:tc>
+                  <a:txBody>
+                    <a:bodyPr/>
+                    <a:lstStyle/>
+                    <a:p>
+                      <a:r>
+                        <a:rPr sz="1000" b="0">
+                          <a:latin typeface="Calibri"/>
+                        </a:rPr>
+                        <a:t>0.98</a:t>
+                      </a:r>
+                    </a:p>
+                  </a:txBody>
+                  <a:tcPr>
+                    <a:solidFill>
+                      <a:srgbClr val="FFFFFF"/>
+                    </a:solidFill>
+                  </a:tcPr>
+                </a:tc>
+              </a:tr>
+              <a:tr h="512064">
+                <a:tc>
+                  <a:txBody>
+                    <a:bodyPr/>
+                    <a:lstStyle/>
+                    <a:p>
+                      <a:r>
+                        <a:rPr sz="1000" b="1">
+                          <a:latin typeface="Calibri"/>
+                        </a:rPr>
+                        <a:t>sha256 'read 15×'</a:t>
+                      </a:r>
+                    </a:p>
+                  </a:txBody>
+                  <a:tcPr>
+                    <a:solidFill>
+                      <a:srgbClr val="EFF3FA"/>
+                    </a:solidFill>
+                  </a:tcPr>
+                </a:tc>
+                <a:tc>
+                  <a:txBody>
+                    <a:bodyPr/>
+                    <a:lstStyle/>
+                    <a:p>
+                      <a:r>
+                        <a:rPr sz="1000" b="0">
+                          <a:latin typeface="Calibri"/>
+                        </a:rPr>
+                        <a:t>l3d_cache_refill counts demand only; the prefetcher served the stream invisibly</a:t>
+                      </a:r>
+                    </a:p>
+                  </a:txBody>
+                  <a:tcPr>
+                    <a:solidFill>
+                      <a:srgbClr val="EFF3FA"/>
+                    </a:solidFill>
+                  </a:tcPr>
+                </a:tc>
+                <a:tc>
+                  <a:txBody>
+                    <a:bodyPr/>
+                    <a:lstStyle/>
+                    <a:p>
+                      <a:r>
+                        <a:rPr sz="1000" b="0">
+                          <a:latin typeface="Calibri"/>
+                        </a:rPr>
+                        <a:t>ground-truth at the DDR controller</a:t>
+                      </a:r>
+                    </a:p>
+                  </a:txBody>
+                  <a:tcPr>
+                    <a:solidFill>
+                      <a:srgbClr val="EFF3FA"/>
+                    </a:solidFill>
+                  </a:tcPr>
+                </a:tc>
+                <a:tc>
+                  <a:txBody>
+                    <a:bodyPr/>
+                    <a:lstStyle/>
+                    <a:p>
+                      <a:r>
+                        <a:rPr sz="1000" b="0">
+                          <a:latin typeface="Calibri"/>
+                        </a:rPr>
+                        <a:t>0.77 (real gap, real sign)</a:t>
+                      </a:r>
+                    </a:p>
+                  </a:txBody>
+                  <a:tcPr>
+                    <a:solidFill>
+                      <a:srgbClr val="EFF3FA"/>
+                    </a:solidFill>
+                  </a:tcPr>
+                </a:tc>
+              </a:tr>
+              <a:tr h="512064">
+                <a:tc>
+                  <a:txBody>
+                    <a:bodyPr/>
+                    <a:lstStyle/>
+                    <a:p>
+                      <a:r>
+                        <a:rPr sz="1000" b="1">
+                          <a:latin typeface="Calibri"/>
+                        </a:rPr>
+                        <a:t>pacman/sqlite/lz4/lua ~0</a:t>
+                      </a:r>
+                    </a:p>
+                  </a:txBody>
+                  <a:tcPr>
+                    <a:solidFill>
+                      <a:srgbClr val="FFFFFF"/>
+                    </a:solidFill>
+                  </a:tcPr>
+                </a:tc>
+                <a:tc>
+                  <a:txBody>
+                    <a:bodyPr/>
+                    <a:lstStyle/>
+                    <a:p>
+                      <a:r>
+                        <a:rPr sz="1000" b="0">
+                          <a:latin typeface="Calibri"/>
+                        </a:rPr>
+                        <a:t>true traffic below the DDR counter's ~0.4 M-line/window noise floor (calibrated by alu)</a:t>
+                      </a:r>
+                    </a:p>
+                  </a:txBody>
+                  <a:tcPr>
+                    <a:solidFill>
+                      <a:srgbClr val="FFFFFF"/>
+                    </a:solidFill>
+                  </a:tcPr>
+                </a:tc>
+                <a:tc>
+                  <a:txBody>
+                    <a:bodyPr/>
+                    <a:lstStyle/>
+                    <a:p>
+                      <a:r>
+                        <a:rPr sz="1000" b="0">
+                          <a:latin typeface="Calibri"/>
+                        </a:rPr>
+                        <a:t>classify, don't fit</a:t>
+                      </a:r>
+                    </a:p>
+                  </a:txBody>
+                  <a:tcPr>
+                    <a:solidFill>
+                      <a:srgbClr val="FFFFFF"/>
+                    </a:solidFill>
+                  </a:tcPr>
+                </a:tc>
+                <a:tc>
+                  <a:txBody>
+                    <a:bodyPr/>
+                    <a:lstStyle/>
+                    <a:p>
+                      <a:r>
+                        <a:rPr sz="1000" b="0">
+                          <a:latin typeface="Calibri"/>
+                        </a:rPr>
+                        <a:t>correctly predicted quiet</a:t>
+                      </a:r>
+                    </a:p>
+                  </a:txBody>
+                  <a:tcPr>
+                    <a:solidFill>
+                      <a:srgbClr val="FFFFFF"/>
+                    </a:solidFill>
+                  </a:tcPr>
+                </a:tc>
+              </a:tr>
+              <a:tr h="512064">
+                <a:tc>
+                  <a:txBody>
+                    <a:bodyPr/>
+                    <a:lstStyle/>
+                    <a:p>
+                      <a:r>
+                        <a:rPr sz="1000" b="1">
+                          <a:latin typeface="Calibri"/>
+                        </a:rPr>
+                        <a:t>bzip2 0.49</a:t>
+                      </a:r>
+                    </a:p>
+                  </a:txBody>
+                  <a:tcPr>
+                    <a:solidFill>
+                      <a:srgbClr val="EFF3FA"/>
+                    </a:solidFill>
+                  </a:tcPr>
+                </a:tc>
+                <a:tc>
+                  <a:txBody>
+                    <a:bodyPr/>
+                    <a:lstStyle/>
+                    <a:p>
+                      <a:r>
+                        <a:rPr sz="1000" b="0">
+                          <a:latin typeface="Calibri"/>
+                        </a:rPr>
+                        <a:t>prefetcher over-fetch on semi-sequential patterns — silicon reads ~2× the demand traffic</a:t>
+                      </a:r>
+                    </a:p>
+                  </a:txBody>
+                  <a:tcPr>
+                    <a:solidFill>
+                      <a:srgbClr val="EFF3FA"/>
+                    </a:solidFill>
+                  </a:tcPr>
+                </a:tc>
+                <a:tc>
+                  <a:txBody>
+                    <a:bodyPr/>
+                    <a:lstStyle/>
+                    <a:p>
+                      <a:r>
+                        <a:rPr sz="1000" b="0">
+                          <a:latin typeface="Calibri"/>
+                        </a:rPr>
+                        <a:t>prefetch model, or per-class factor</a:t>
+                      </a:r>
+                    </a:p>
+                  </a:txBody>
+                  <a:tcPr>
+                    <a:solidFill>
+                      <a:srgbClr val="EFF3FA"/>
+                    </a:solidFill>
+                  </a:tcPr>
+                </a:tc>
+                <a:tc>
+                  <a:txBody>
+                    <a:bodyPr/>
+                    <a:lstStyle/>
+                    <a:p>
+                      <a:r>
+                        <a:rPr sz="1000" b="0">
+                          <a:latin typeface="Calibri"/>
+                        </a:rPr>
+                        <a:t>open, named</a:t>
+                      </a:r>
+                    </a:p>
+                  </a:txBody>
+                  <a:tcPr>
+                    <a:solidFill>
+                      <a:srgbClr val="EFF3FA"/>
+                    </a:solidFill>
+                  </a:tcPr>
+                </a:tc>
+              </a:tr>
+              <a:tr h="512064">
+                <a:tc>
+                  <a:txBody>
+                    <a:bodyPr/>
+                    <a:lstStyle/>
+                    <a:p>
+                      <a:r>
+                        <a:rPr sz="1000" b="1">
+                          <a:latin typeface="Calibri"/>
+                        </a:rPr>
+                        <a:t>writes 0.02–0.09 (v1)</a:t>
+                      </a:r>
+                    </a:p>
+                  </a:txBody>
+                  <a:tcPr>
+                    <a:solidFill>
+                      <a:srgbClr val="FFFFFF"/>
+                    </a:solidFill>
+                  </a:tcPr>
+                </a:tc>
+                <a:tc>
+                  <a:txBody>
+                    <a:bodyPr/>
+                    <a:lstStyle/>
+                    <a:p>
+                      <a:r>
+                        <a:rPr sz="1000" b="0">
+                          <a:latin typeface="Calibri"/>
+                        </a:rPr>
+                        <a:t>scattered stores exit DRAM as dirty EVICTIONS, which no allocation-time count can see</a:t>
+                      </a:r>
+                    </a:p>
+                  </a:txBody>
+                  <a:tcPr>
+                    <a:solidFill>
+                      <a:srgbClr val="FFFFFF"/>
+                    </a:solidFill>
+                  </a:tcPr>
+                </a:tc>
+                <a:tc>
+                  <a:txBody>
+                    <a:bodyPr/>
+                    <a:lstStyle/>
+                    <a:p>
+                      <a:r>
+                        <a:rPr sz="1000" b="0">
+                          <a:latin typeface="Calibri"/>
+                        </a:rPr>
+                        <a:t>X1: dirty-line set + last-level eviction counting</a:t>
+                      </a:r>
+                    </a:p>
+                  </a:txBody>
+                  <a:tcPr>
+                    <a:solidFill>
+                      <a:srgbClr val="FFFFFF"/>
+                    </a:solidFill>
+                  </a:tcPr>
+                </a:tc>
+                <a:tc>
+                  <a:txBody>
+                    <a:bodyPr/>
+                    <a:lstStyle/>
+                    <a:p>
+                      <a:r>
+                        <a:rPr sz="1000" b="0">
+                          <a:latin typeface="Calibri"/>
+                        </a:rPr>
+                        <a:t>0.90 ×/÷ 1.09</a:t>
+                      </a:r>
+                    </a:p>
+                  </a:txBody>
+                  <a:tcPr>
+                    <a:solidFill>
+                      <a:srgbClr val="FFFFFF"/>
+                    </a:solidFill>
+                  </a:tcPr>
+                </a:tc>
+              </a:tr>
+              <a:tr h="512064">
+                <a:tc>
+                  <a:txBody>
+                    <a:bodyPr/>
+                    <a:lstStyle/>
+                    <a:p>
+                      <a:r>
+                        <a:rPr sz="1000" b="1">
+                          <a:latin typeface="Calibri"/>
+                        </a:rPr>
+                        <a:t>sgm-mt insns 1.23 @4T</a:t>
+                      </a:r>
+                    </a:p>
+                  </a:txBody>
+                  <a:tcPr>
+                    <a:solidFill>
+                      <a:srgbClr val="EFF3FA"/>
+                    </a:solidFill>
+                  </a:tcPr>
+                </a:tc>
+                <a:tc>
+                  <a:txBody>
+                    <a:bodyPr/>
+                    <a:lstStyle/>
+                    <a:p>
+                      <a:r>
+                        <a:rPr sz="1000" b="0">
+                          <a:latin typeface="Calibri"/>
+                        </a:rPr>
+                        <a:t>OpenMP barrier SPIN — timing-dependent instructions, inflated by instrumentation skew</a:t>
+                      </a:r>
+                    </a:p>
+                  </a:txBody>
+                  <a:tcPr>
+                    <a:solidFill>
+                      <a:srgbClr val="EFF3FA"/>
+                    </a:solidFill>
+                  </a:tcPr>
+                </a:tc>
+                <a:tc>
+                  <a:txBody>
+                    <a:bodyPr/>
+                    <a:lstStyle/>
+                    <a:p>
+                      <a:r>
+                        <a:rPr sz="1000" b="0">
+                          <a:latin typeface="Calibri"/>
+                        </a:rPr>
+                        <a:t>X3: OMP_WAIT_POLICY=passive (proven, not argued)</a:t>
+                      </a:r>
+                    </a:p>
+                  </a:txBody>
+                  <a:tcPr>
+                    <a:solidFill>
+                      <a:srgbClr val="EFF3FA"/>
+                    </a:solidFill>
+                  </a:tcPr>
+                </a:tc>
+                <a:tc>
+                  <a:txBody>
+                    <a:bodyPr/>
+                    <a:lstStyle/>
+                    <a:p>
+                      <a:r>
+                        <a:rPr sz="1000" b="0">
+                          <a:latin typeface="Calibri"/>
+                        </a:rPr>
+                        <a:t>0.985; DRAM unmoved</a:t>
+                      </a:r>
+                    </a:p>
+                  </a:txBody>
+                  <a:tcPr>
+                    <a:solidFill>
+                      <a:srgbClr val="EFF3FA"/>
+                    </a:solidFill>
+                  </a:tcPr>
+                </a:tc>
+              </a:tr>
+              <a:tr h="512064">
+                <a:tc>
+                  <a:txBody>
+                    <a:bodyPr/>
+                    <a:lstStyle/>
+                    <a:p>
+                      <a:r>
+                        <a:rPr sz="1000" b="1">
+                          <a:latin typeface="Calibri"/>
+                        </a:rPr>
+                        <a:t>reads 0.49–0.77 (under)</a:t>
+                      </a:r>
+                    </a:p>
+                  </a:txBody>
+                  <a:tcPr>
+                    <a:solidFill>
+                      <a:srgbClr val="FFFFFF"/>
+                    </a:solidFill>
+                  </a:tcPr>
+                </a:tc>
+                <a:tc>
+                  <a:txBody>
+                    <a:bodyPr/>
+                    <a:lstStyle/>
+                    <a:p>
+                      <a:r>
+                        <a:rPr sz="1000" b="0">
+                          <a:latin typeface="Calibri"/>
+                        </a:rPr>
+                        <a:t>silicon prefetcher traffic the model never issued</a:t>
+                      </a:r>
+                    </a:p>
+                  </a:txBody>
+                  <a:tcPr>
+                    <a:solidFill>
+                      <a:srgbClr val="FFFFFF"/>
+                    </a:solidFill>
+                  </a:tcPr>
+                </a:tc>
+                <a:tc>
+                  <a:txBody>
+                    <a:bodyPr/>
+                    <a:lstStyle/>
+                    <a:p>
+                      <a:r>
+                        <a:rPr sz="1000" b="0">
+                          <a:latin typeface="Calibri"/>
+                        </a:rPr>
+                        <a:t>X4: 8-stream table, miss-trained, strict +1, ramped depth</a:t>
+                      </a:r>
+                    </a:p>
+                  </a:txBody>
+                  <a:tcPr>
+                    <a:solidFill>
+                      <a:srgbClr val="FFFFFF"/>
+                    </a:solidFill>
+                  </a:tcPr>
+                </a:tc>
+                <a:tc>
+                  <a:txBody>
+                    <a:bodyPr/>
+                    <a:lstStyle/>
+                    <a:p>
+                      <a:r>
+                        <a:rPr sz="1000" b="0">
+                          <a:latin typeface="Calibri"/>
+                        </a:rPr>
+                        <a:t>0.98 ×/÷ 1.14</a:t>
+                      </a:r>
+                    </a:p>
+                  </a:txBody>
+                  <a:tcPr>
+                    <a:solidFill>
+                      <a:srgbClr val="FFFFFF"/>
+                    </a:solidFill>
+                  </a:tcPr>
+                </a:tc>
+              </a:tr>
+            </a:tbl>
+          </a:graphicData>
+        </a:graphic>
+      </p:graphicFrame>
+      <p:sp>
+        <p:nvSpPr>
+          <p:cNvPr id="9" name="TextBox 8"/>
+          <p:cNvSpPr txBox="1"/>
+          <p:nvPr/>
+        </p:nvSpPr>
+        <p:spPr>
+          <a:xfrm>
+            <a:off x="548640" y="5257800"/>
+            <a:ext cx="11064240" cy="731520"/>
+          </a:xfrm>
+          <a:prstGeom prst="rect">
+            <a:avLst/>
+          </a:prstGeom>
+          <a:noFill/>
+        </p:spPr>
+        <p:txBody>
+          <a:bodyPr wrap="square">
+            <a:spAutoFit/>
+          </a:bodyPr>
+          <a:lstStyle/>
+          <a:p>
+            <a:pPr algn="l"/>
+            <a:r>
+              <a:rPr sz="1150" b="0">
+                <a:solidFill>
+                  <a:srgbClr val="202124"/>
+                </a:solidFill>
+                <a:latin typeface="Calibri"/>
+              </a:rPr>
+              <a:t>The X1 row landed after this deck's first printing and proves the pattern: the named mechanism, implemented in an afternoon, moved six workloads from near-zero to 0.73–1.03 without touching the read side. Mechanism-first iteration converges; fudge-factor iteration doesn't.</a:t>
+            </a:r>
+          </a:p>
+        </p:txBody>
+      </p:sp>
+    </p:spTree>
+  </p:cSld>
+  <p:clrMapOvr>
+    <a:masterClrMapping/>
+  </p:clrMapOvr>
+</p:sld>
+</file>
+
+<file path=ppt/slides/slide8.xml><?xml version="1.0" encoding="utf-8"?>
+<p:sld xmlns:a="http://schemas.openxmlformats.org/drawingml/2006/main" xmlns:p="http://schemas.openxmlformats.org/presentationml/2006/main" xmlns:r="http://schemas.openxmlformats.org/officeDocument/2006/relationships">
+  <p:cSld>
+    <p:spTree>
+      <p:nvGrpSpPr>
+        <p:cNvPr id="1" name=""/>
+        <p:cNvGrpSpPr/>
+        <p:nvPr/>
+      </p:nvGrpSpPr>
+      <p:grpSpPr/>
+      <p:sp>
+        <p:nvSpPr>
+          <p:cNvPr id="2" name="Rectangle 1"/>
+          <p:cNvSpPr/>
+          <p:nvPr/>
+        </p:nvSpPr>
+        <p:spPr>
+          <a:xfrm>
+            <a:off x="0" y="0"/>
+            <a:ext cx="12191695" cy="841248"/>
+          </a:xfrm>
+          <a:prstGeom prst="rect">
+            <a:avLst/>
+          </a:prstGeom>
+          <a:solidFill>
+            <a:srgbClr val="202124"/>
+          </a:solidFill>
+          <a:ln>
+            <a:noFill/>
+          </a:ln>
+        </p:spPr>
+        <p:style>
+          <a:lnRef idx="1">
+            <a:schemeClr val="accent1"/>
+          </a:lnRef>
+          <a:fillRef idx="3">
+            <a:schemeClr val="accent1"/>
+          </a:fillRef>
+          <a:effectRef idx="2">
+            <a:schemeClr val="accent1"/>
+          </a:effectRef>
+          <a:fontRef idx="minor">
+            <a:schemeClr val="lt1"/>
+          </a:fontRef>
+        </p:style>
+        <p:txBody>
+          <a:bodyPr rtlCol="0" anchor="ctr"/>
+          <a:lstStyle/>
+          <a:p>
+            <a:pPr algn="ctr"/>
+          </a:p>
+        </p:txBody>
+      </p:sp>
+      <p:sp>
+        <p:nvSpPr>
+          <p:cNvPr id="3" name="TextBox 2"/>
+          <p:cNvSpPr txBox="1"/>
+          <p:nvPr/>
+        </p:nvSpPr>
+        <p:spPr>
+          <a:xfrm>
+            <a:off x="548640" y="118872"/>
+            <a:ext cx="10058400" cy="548640"/>
+          </a:xfrm>
+          <a:prstGeom prst="rect">
+            <a:avLst/>
+          </a:prstGeom>
+          <a:noFill/>
+        </p:spPr>
+        <p:txBody>
+          <a:bodyPr wrap="square">
+            <a:spAutoFit/>
+          </a:bodyPr>
+          <a:lstStyle/>
+          <a:p>
+            <a:pPr algn="l"/>
+            <a:r>
+              <a:rPr sz="2600" b="1">
+                <a:solidFill>
+                  <a:srgbClr val="FFFFFF"/>
+                </a:solidFill>
+                <a:latin typeface="Calibri"/>
+              </a:rPr>
+              <a:t>What this licenses, and what it does not</a:t>
+            </a:r>
+          </a:p>
+        </p:txBody>
+      </p:sp>
+      <p:sp>
+        <p:nvSpPr>
+          <p:cNvPr id="4" name="Rectangle 3"/>
+          <p:cNvSpPr/>
+          <p:nvPr/>
+        </p:nvSpPr>
+        <p:spPr>
+          <a:xfrm>
+            <a:off x="0" y="841248"/>
+            <a:ext cx="12191695" cy="38100"/>
+          </a:xfrm>
+          <a:prstGeom prst="rect">
+            <a:avLst/>
+          </a:prstGeom>
+          <a:solidFill>
+            <a:srgbClr val="1A53A0"/>
+          </a:solidFill>
+          <a:ln>
+            <a:noFill/>
+          </a:ln>
+        </p:spPr>
+        <p:style>
+          <a:lnRef idx="1">
+            <a:schemeClr val="accent1"/>
+          </a:lnRef>
+          <a:fillRef idx="3">
+            <a:schemeClr val="accent1"/>
+          </a:fillRef>
+          <a:effectRef idx="2">
+            <a:schemeClr val="accent1"/>
+          </a:effectRef>
+          <a:fontRef idx="minor">
+            <a:schemeClr val="lt1"/>
+          </a:fontRef>
+        </p:style>
+        <p:txBody>
+          <a:bodyPr rtlCol="0" anchor="ctr"/>
+          <a:lstStyle/>
+          <a:p>
+            <a:pPr algn="ctr"/>
+          </a:p>
+        </p:txBody>
+      </p:sp>
+      <p:sp>
+        <p:nvSpPr>
+          <p:cNvPr id="5" name="TextBox 4"/>
+          <p:cNvSpPr txBox="1"/>
+          <p:nvPr/>
+        </p:nvSpPr>
+        <p:spPr>
+          <a:xfrm>
+            <a:off x="548640" y="969264"/>
+            <a:ext cx="11155680" cy="365760"/>
+          </a:xfrm>
+          <a:prstGeom prst="rect">
+            <a:avLst/>
+          </a:prstGeom>
+          <a:noFill/>
+        </p:spPr>
+        <p:txBody>
+          <a:bodyPr wrap="square">
+            <a:spAutoFit/>
+          </a:bodyPr>
+          <a:lstStyle/>
+          <a:p>
+            <a:pPr algn="l"/>
+            <a:r>
+              <a:rPr sz="1200" b="0">
+                <a:solidFill>
+                  <a:srgbClr val="5F6368"/>
+                </a:solidFill>
+                <a:latin typeface="Calibri"/>
+              </a:rPr>
+              <a:t>The trust statement, quantity by quantity.</a:t>
+            </a:r>
+          </a:p>
+        </p:txBody>
+      </p:sp>
+      <p:sp>
+        <p:nvSpPr>
+          <p:cNvPr id="6" name="TextBox 5"/>
+          <p:cNvSpPr txBox="1"/>
+          <p:nvPr/>
+        </p:nvSpPr>
+        <p:spPr>
+          <a:xfrm>
+            <a:off x="548640" y="6528816"/>
+            <a:ext cx="9601200" cy="274320"/>
+          </a:xfrm>
+          <a:prstGeom prst="rect">
+            <a:avLst/>
+          </a:prstGeom>
+          <a:noFill/>
+        </p:spPr>
+        <p:txBody>
+          <a:bodyPr wrap="square">
+            <a:spAutoFit/>
+          </a:bodyPr>
+          <a:lstStyle/>
+          <a:p>
+            <a:pPr algn="l"/>
+            <a:r>
+              <a:rPr sz="950" b="0">
+                <a:solidFill>
+                  <a:srgbClr val="5F6368"/>
+                </a:solidFill>
+                <a:latin typeface="Calibri"/>
+              </a:rPr>
+              <a:t>wattson xcheck rev 2 · QEMU counts DERIVED, PMU/DDR counts MEASURED · 2026-08-30</a:t>
+            </a:r>
+          </a:p>
+        </p:txBody>
+      </p:sp>
+      <p:sp>
+        <p:nvSpPr>
+          <p:cNvPr id="7" name="TextBox 6"/>
+          <p:cNvSpPr txBox="1"/>
+          <p:nvPr/>
+        </p:nvSpPr>
+        <p:spPr>
+          <a:xfrm>
+            <a:off x="11247120" y="6528816"/>
+            <a:ext cx="457200" cy="274320"/>
+          </a:xfrm>
+          <a:prstGeom prst="rect">
+            <a:avLst/>
+          </a:prstGeom>
+          <a:noFill/>
+        </p:spPr>
+        <p:txBody>
+          <a:bodyPr wrap="square">
+            <a:spAutoFit/>
+          </a:bodyPr>
+          <a:lstStyle/>
+          <a:p>
+            <a:pPr algn="r"/>
+            <a:r>
+              <a:rPr sz="950" b="0">
+                <a:solidFill>
+                  <a:srgbClr val="5F6368"/>
+                </a:solidFill>
+                <a:latin typeface="Calibri"/>
+              </a:rPr>
+              <a:t>8</a:t>
+            </a:r>
+          </a:p>
+        </p:txBody>
+      </p:sp>
+      <p:graphicFrame>
+        <p:nvGraphicFramePr>
+          <p:cNvPr id="8" name="Table 7"/>
+          <p:cNvGraphicFramePr>
+            <a:graphicFrameLocks noGrp="1"/>
+          </p:cNvGraphicFramePr>
+          <p:nvPr/>
+        </p:nvGraphicFramePr>
+        <p:xfrm>
+          <a:off x="548640" y="1417320"/>
+          <a:ext cx="11064240" cy="3657600"/>
         </p:xfrm>
         <a:graphic>
           <a:graphicData uri="http://schemas.openxmlformats.org/drawingml/2006/table">
@@ -8089,14 +8455,14 @@
                 <a:gridCol w="2743200"/>
                 <a:gridCol w="5303520"/>
               </a:tblGrid>
-              <a:tr h="475488">
-                <a:tc>
-                  <a:txBody>
-                    <a:bodyPr/>
-                    <a:lstStyle/>
-                    <a:p>
-                      <a:r>
-                        <a:rPr sz="1100" b="1">
+              <a:tr h="457200">
+                <a:tc>
+                  <a:txBody>
+                    <a:bodyPr/>
+                    <a:lstStyle/>
+                    <a:p>
+                      <a:r>
+                        <a:rPr sz="1050" b="1">
                           <a:solidFill>
                             <a:srgbClr val="FFFFFF"/>
                           </a:solidFill>
@@ -8118,7 +8484,7 @@
                     <a:lstStyle/>
                     <a:p>
                       <a:r>
-                        <a:rPr sz="1100" b="1">
+                        <a:rPr sz="1050" b="1">
                           <a:solidFill>
                             <a:srgbClr val="FFFFFF"/>
                           </a:solidFill>
@@ -8140,7 +8506,7 @@
                     <a:lstStyle/>
                     <a:p>
                       <a:r>
-                        <a:rPr sz="1100" b="1">
+                        <a:rPr sz="1050" b="1">
                           <a:solidFill>
                             <a:srgbClr val="FFFFFF"/>
                           </a:solidFill>
@@ -8157,14 +8523,14 @@
                   </a:tcPr>
                 </a:tc>
               </a:tr>
-              <a:tr h="475488">
-                <a:tc>
-                  <a:txBody>
-                    <a:bodyPr/>
-                    <a:lstStyle/>
-                    <a:p>
-                      <a:r>
-                        <a:rPr sz="1100" b="1">
+              <a:tr h="457200">
+                <a:tc>
+                  <a:txBody>
+                    <a:bodyPr/>
+                    <a:lstStyle/>
+                    <a:p>
+                      <a:r>
+                        <a:rPr sz="1050" b="1">
                           <a:latin typeface="Calibri"/>
                         </a:rPr>
                         <a:t>Per-core instruction activity</a:t>
@@ -8183,7 +8549,7 @@
                     <a:lstStyle/>
                     <a:p>
                       <a:r>
-                        <a:rPr sz="1100" b="0">
+                        <a:rPr sz="1050" b="0">
                           <a:solidFill>
                             <a:srgbClr val="187A33"/>
                           </a:solidFill>
@@ -8205,7 +8571,7 @@
                     <a:lstStyle/>
                     <a:p>
                       <a:r>
-                        <a:rPr sz="1100" b="0">
+                        <a:rPr sz="1050" b="0">
                           <a:latin typeface="Calibri"/>
                         </a:rPr>
                         <a:t>±4% envelope held across every application class tested</a:t>
@@ -8219,14 +8585,14 @@
                   </a:tcPr>
                 </a:tc>
               </a:tr>
-              <a:tr h="475488">
-                <a:tc>
-                  <a:txBody>
-                    <a:bodyPr/>
-                    <a:lstStyle/>
-                    <a:p>
-                      <a:r>
-                        <a:rPr sz="1100" b="1">
+              <a:tr h="457200">
+                <a:tc>
+                  <a:txBody>
+                    <a:bodyPr/>
+                    <a:lstStyle/>
+                    <a:p>
+                      <a:r>
+                        <a:rPr sz="1050" b="1">
                           <a:latin typeface="Calibri"/>
                         </a:rPr>
                         <a:t>DRAM read transactions</a:t>
@@ -8245,7 +8611,7 @@
                     <a:lstStyle/>
                     <a:p>
                       <a:r>
-                        <a:rPr sz="1100" b="0">
+                        <a:rPr sz="1050" b="0">
                           <a:solidFill>
                             <a:srgbClr val="187A33"/>
                           </a:solidFill>
@@ -8267,7 +8633,7 @@
                     <a:lstStyle/>
                     <a:p>
                       <a:r>
-                        <a:rPr sz="1100" b="0">
+                        <a:rPr sz="1050" b="0">
                           <a:latin typeface="Calibri"/>
                         </a:rPr>
                         <a:t>carry the ×/÷1.14 band; latency/bandwidth-bound apps need almost none</a:t>
@@ -8281,14 +8647,14 @@
                   </a:tcPr>
                 </a:tc>
               </a:tr>
-              <a:tr h="475488">
-                <a:tc>
-                  <a:txBody>
-                    <a:bodyPr/>
-                    <a:lstStyle/>
-                    <a:p>
-                      <a:r>
-                        <a:rPr sz="1100" b="1">
+              <a:tr h="457200">
+                <a:tc>
+                  <a:txBody>
+                    <a:bodyPr/>
+                    <a:lstStyle/>
+                    <a:p>
+                      <a:r>
+                        <a:rPr sz="1050" b="1">
                           <a:latin typeface="Calibri"/>
                         </a:rPr>
                         <a:t>DRAM-quiet screening</a:t>
@@ -8307,7 +8673,7 @@
                     <a:lstStyle/>
                     <a:p>
                       <a:r>
-                        <a:rPr sz="1100" b="0">
+                        <a:rPr sz="1050" b="0">
                           <a:solidFill>
                             <a:srgbClr val="187A33"/>
                           </a:solidFill>
@@ -8329,7 +8695,7 @@
                     <a:lstStyle/>
                     <a:p>
                       <a:r>
-                        <a:rPr sz="1100" b="0">
+                        <a:rPr sz="1050" b="0">
                           <a:latin typeface="Calibri"/>
                         </a:rPr>
                         <a:t>proxy under ~1 M lines reliably means a DRAM-quiet application</a:t>
@@ -8343,14 +8709,14 @@
                   </a:tcPr>
                 </a:tc>
               </a:tr>
-              <a:tr h="475488">
-                <a:tc>
-                  <a:txBody>
-                    <a:bodyPr/>
-                    <a:lstStyle/>
-                    <a:p>
-                      <a:r>
-                        <a:rPr sz="1100" b="1">
+              <a:tr h="457200">
+                <a:tc>
+                  <a:txBody>
+                    <a:bodyPr/>
+                    <a:lstStyle/>
+                    <a:p>
+                      <a:r>
+                        <a:rPr sz="1050" b="1">
                           <a:latin typeface="Calibri"/>
                         </a:rPr>
                         <a:t>DRAM write transactions</a:t>
@@ -8369,13 +8735,13 @@
                     <a:lstStyle/>
                     <a:p>
                       <a:r>
-                        <a:rPr sz="1100" b="0">
+                        <a:rPr sz="1050" b="0">
                           <a:solidFill>
                             <a:srgbClr val="187A33"/>
                           </a:solidFill>
                           <a:latin typeface="Calibri"/>
                         </a:rPr>
-                        <a:t>use with ×0.68 correction</a:t>
+                        <a:t>use with ×1.11 correction (base pass)</a:t>
                       </a:r>
                     </a:p>
                   </a:txBody>
@@ -8391,10 +8757,10 @@
                     <a:lstStyle/>
                     <a:p>
                       <a:r>
-                        <a:rPr sz="1100" b="0">
-                          <a:latin typeface="Calibri"/>
-                        </a:rPr>
-                        <a:t>×/÷{SW:.2f} band above the write noise floor (X1 writeback model)</a:t>
+                        <a:rPr sz="1050" b="0">
+                          <a:latin typeface="Calibri"/>
+                        </a:rPr>
+                        <a:t>×/÷1.09 fitted, ×/÷1.28 held-out, above the write noise floor</a:t>
                       </a:r>
                     </a:p>
                   </a:txBody>
@@ -8405,14 +8771,14 @@
                   </a:tcPr>
                 </a:tc>
               </a:tr>
-              <a:tr h="475488">
-                <a:tc>
-                  <a:txBody>
-                    <a:bodyPr/>
-                    <a:lstStyle/>
-                    <a:p>
-                      <a:r>
-                        <a:rPr sz="1100" b="1">
+              <a:tr h="457200">
+                <a:tc>
+                  <a:txBody>
+                    <a:bodyPr/>
+                    <a:lstStyle/>
+                    <a:p>
+                      <a:r>
+                        <a:rPr sz="1050" b="1">
                           <a:latin typeface="Calibri"/>
                         </a:rPr>
                         <a:t>Network / DMA activity</a:t>
@@ -8431,7 +8797,7 @@
                     <a:lstStyle/>
                     <a:p>
                       <a:r>
-                        <a:rPr sz="1100" b="0">
+                        <a:rPr sz="1050" b="0">
                           <a:solidFill>
                             <a:srgbClr val="B31412"/>
                           </a:solidFill>
@@ -8453,7 +8819,7 @@
                     <a:lstStyle/>
                     <a:p>
                       <a:r>
-                        <a:rPr sz="1100" b="0">
+                        <a:rPr sz="1050" b="0">
                           <a:latin typeface="Calibri"/>
                         </a:rPr>
                         <a:t>system-mode harness (exists, boot-differential) required</a:t>
@@ -8467,14 +8833,14 @@
                   </a:tcPr>
                 </a:tc>
               </a:tr>
-              <a:tr h="475488">
-                <a:tc>
-                  <a:txBody>
-                    <a:bodyPr/>
-                    <a:lstStyle/>
-                    <a:p>
-                      <a:r>
-                        <a:rPr sz="1100" b="1">
+              <a:tr h="457200">
+                <a:tc>
+                  <a:txBody>
+                    <a:bodyPr/>
+                    <a:lstStyle/>
+                    <a:p>
+                      <a:r>
+                        <a:rPr sz="1050" b="1">
                           <a:latin typeface="Calibri"/>
                         </a:rPr>
                         <a:t>Multi-core</a:t>
@@ -8493,7 +8859,7 @@
                     <a:lstStyle/>
                     <a:p>
                       <a:r>
-                        <a:rPr sz="1100" b="0">
+                        <a:rPr sz="1050" b="0">
                           <a:solidFill>
                             <a:srgbClr val="187A33"/>
                           </a:solidFill>
@@ -8515,7 +8881,7 @@
                     <a:lstStyle/>
                     <a:p>
                       <a:r>
-                        <a:rPr sz="1100" b="0">
+                        <a:rPr sz="1050" b="0">
                           <a:latin typeface="Calibri"/>
                         </a:rPr>
                         <a:t>DRAM ratios thread-invariant 1–6T; spin-wait inflates insns 18–23% on barrier-heavy code otherwise</a:t>
@@ -8529,14 +8895,14 @@
                   </a:tcPr>
                 </a:tc>
               </a:tr>
-              <a:tr h="475488">
-                <a:tc>
-                  <a:txBody>
-                    <a:bodyPr/>
-                    <a:lstStyle/>
-                    <a:p>
-                      <a:r>
-                        <a:rPr sz="1100" b="1">
+              <a:tr h="457200">
+                <a:tc>
+                  <a:txBody>
+                    <a:bodyPr/>
+                    <a:lstStyle/>
+                    <a:p>
+                      <a:r>
+                        <a:rPr sz="1050" b="1">
                           <a:latin typeface="Calibri"/>
                         </a:rPr>
                         <a:t>Duty cycle</a:t>
@@ -8555,7 +8921,7 @@
                     <a:lstStyle/>
                     <a:p>
                       <a:r>
-                        <a:rPr sz="1100" b="0">
+                        <a:rPr sz="1050" b="0">
                           <a:solidFill>
                             <a:srgbClr val="B31412"/>
                           </a:solidFill>
@@ -8577,7 +8943,7 @@
                     <a:lstStyle/>
                     <a:p>
                       <a:r>
-                        <a:rPr sz="1100" b="0">
+                        <a:rPr sz="1050" b="0">
                           <a:latin typeface="Calibri"/>
                         </a:rPr>
                         <a:t>rides on the X2 system-mode harness</a:t>
@@ -8603,7 +8969,7 @@
         </p:nvSpPr>
         <p:spPr>
           <a:xfrm>
-            <a:off x="548640" y="4892040"/>
+            <a:off x="548640" y="5349240"/>
             <a:ext cx="11064240" cy="822960"/>
           </a:xfrm>
           <a:prstGeom prst="rect">
@@ -8638,7 +9004,7 @@
         </p:nvSpPr>
         <p:spPr>
           <a:xfrm>
-            <a:off x="548640" y="5806440"/>
+            <a:off x="548640" y="6263640"/>
             <a:ext cx="11064240" cy="457200"/>
           </a:xfrm>
           <a:prstGeom prst="rect">

</xml_diff>

<commit_message>
formatting: containers sized to their content, no half-empty boxes
The method slide was the clearest case -- two panels roughly twice the
height of the text inside them, and a dead band across the bottom third.
Rebuilt: the panels carry the detail they were always meant to (two-pass
extraction, frequency-free counts, medians and spreads), line leading
distributes the text down the box instead of stacking it at the top, and the
bottom half becomes two matching blocks (the 50 applications, and how a run
is accepted) so the whole slide carries weight.

Same discipline applied across the deck -- table row heights raised so
tables fill their slides, wrapped kickers that collided with the first table
row fixed on slides 3 and 4, and the last row of a table no longer runs into
the paragraph beneath it. A bbox sweep now shows every content slide
reaching 98% of page height.

Footer no longer carries a rev number that drifts out of date.
</commit_message>
<xml_diff>
--- a/xcheck/xcheck-correlation.pptx
+++ b/xcheck/xcheck-correlation.pptx
@@ -3241,7 +3241,7 @@
                 </a:solidFill>
                 <a:latin typeface="Calibri"/>
               </a:rPr>
-              <a:t>Kyle Fox · 2026-08-30</a:t>
+              <a:t>Kyle Fox · 2026-08-31</a:t>
             </a:r>
           </a:p>
         </p:txBody>
@@ -3415,7 +3415,7 @@
                 </a:solidFill>
                 <a:latin typeface="Calibri"/>
               </a:rPr>
-              <a:t>wattson xcheck rev 2 · QEMU counts DERIVED, PMU/DDR counts MEASURED · 2026-08-30</a:t>
+              <a:t>wattson xcheck · QEMU counts DERIVED, PMU/DDR counts MEASURED · 2026-08-31</a:t>
             </a:r>
           </a:p>
         </p:txBody>
@@ -4358,7 +4358,7 @@
                 </a:solidFill>
                 <a:latin typeface="Calibri"/>
               </a:rPr>
-              <a:t>wattson xcheck rev 2 · QEMU counts DERIVED, PMU/DDR counts MEASURED · 2026-08-30</a:t>
+              <a:t>wattson xcheck · QEMU counts DERIVED, PMU/DDR counts MEASURED · 2026-08-31</a:t>
             </a:r>
           </a:p>
         </p:txBody>
@@ -5340,7 +5340,7 @@
                 </a:solidFill>
                 <a:latin typeface="Calibri"/>
               </a:rPr>
-              <a:t>wattson xcheck rev 2 · QEMU counts DERIVED, PMU/DDR counts MEASURED · 2026-08-30</a:t>
+              <a:t>wattson xcheck · QEMU counts DERIVED, PMU/DDR counts MEASURED · 2026-08-31</a:t>
             </a:r>
           </a:p>
         </p:txBody>
@@ -5503,7 +5503,7 @@
         </p:nvGraphicFramePr>
         <p:xfrm>
           <a:off x="548640" y="2157984"/>
-          <a:ext cx="5486400" cy="2304288"/>
+          <a:ext cx="5486400" cy="2523744"/>
         </p:xfrm>
         <a:graphic>
           <a:graphicData uri="http://schemas.openxmlformats.org/drawingml/2006/table">
@@ -5517,14 +5517,14 @@
                 <a:gridCol w="1051560"/>
                 <a:gridCol w="1051560"/>
               </a:tblGrid>
-              <a:tr h="384048">
-                <a:tc>
-                  <a:txBody>
-                    <a:bodyPr/>
-                    <a:lstStyle/>
-                    <a:p>
-                      <a:r>
-                        <a:rPr sz="1000" b="1">
+              <a:tr h="420624">
+                <a:tc>
+                  <a:txBody>
+                    <a:bodyPr/>
+                    <a:lstStyle/>
+                    <a:p>
+                      <a:r>
+                        <a:rPr sz="1050" b="1">
                           <a:solidFill>
                             <a:srgbClr val="FFFFFF"/>
                           </a:solidFill>
@@ -5546,7 +5546,7 @@
                     <a:lstStyle/>
                     <a:p>
                       <a:r>
-                        <a:rPr sz="1000" b="1">
+                        <a:rPr sz="1050" b="1">
                           <a:solidFill>
                             <a:srgbClr val="FFFFFF"/>
                           </a:solidFill>
@@ -5568,7 +5568,7 @@
                     <a:lstStyle/>
                     <a:p>
                       <a:r>
-                        <a:rPr sz="1000" b="1">
+                        <a:rPr sz="1050" b="1">
                           <a:solidFill>
                             <a:srgbClr val="FFFFFF"/>
                           </a:solidFill>
@@ -5590,7 +5590,7 @@
                     <a:lstStyle/>
                     <a:p>
                       <a:r>
-                        <a:rPr sz="1000" b="1">
+                        <a:rPr sz="1050" b="1">
                           <a:solidFill>
                             <a:srgbClr val="FFFFFF"/>
                           </a:solidFill>
@@ -5607,14 +5607,14 @@
                   </a:tcPr>
                 </a:tc>
               </a:tr>
-              <a:tr h="384048">
-                <a:tc>
-                  <a:txBody>
-                    <a:bodyPr/>
-                    <a:lstStyle/>
-                    <a:p>
-                      <a:r>
-                        <a:rPr sz="1000" b="1">
+              <a:tr h="420624">
+                <a:tc>
+                  <a:txBody>
+                    <a:bodyPr/>
+                    <a:lstStyle/>
+                    <a:p>
+                      <a:r>
+                        <a:rPr sz="1050" b="1">
                           <a:latin typeface="Calibri"/>
                         </a:rPr>
                         <a:t>Instructions, per core</a:t>
@@ -5633,7 +5633,7 @@
                     <a:lstStyle/>
                     <a:p>
                       <a:r>
-                        <a:rPr sz="1000" b="0">
+                        <a:rPr sz="1050" b="0">
                           <a:latin typeface="Calibri"/>
                         </a:rPr>
                         <a:t>use raw</a:t>
@@ -5652,7 +5652,7 @@
                     <a:lstStyle/>
                     <a:p>
                       <a:r>
-                        <a:rPr sz="1000" b="0">
+                        <a:rPr sz="1050" b="0">
                           <a:latin typeface="Calibri"/>
                         </a:rPr>
                         <a:t>0.979</a:t>
@@ -5671,7 +5671,7 @@
                     <a:lstStyle/>
                     <a:p>
                       <a:r>
-                        <a:rPr sz="1000" b="0">
+                        <a:rPr sz="1050" b="0">
                           <a:latin typeface="Calibri"/>
                         </a:rPr>
                         <a:t>×/÷1.04</a:t>
@@ -5685,14 +5685,14 @@
                   </a:tcPr>
                 </a:tc>
               </a:tr>
-              <a:tr h="384048">
-                <a:tc>
-                  <a:txBody>
-                    <a:bodyPr/>
-                    <a:lstStyle/>
-                    <a:p>
-                      <a:r>
-                        <a:rPr sz="1000" b="1">
+              <a:tr h="420624">
+                <a:tc>
+                  <a:txBody>
+                    <a:bodyPr/>
+                    <a:lstStyle/>
+                    <a:p>
+                      <a:r>
+                        <a:rPr sz="1050" b="1">
                           <a:latin typeface="Calibri"/>
                         </a:rPr>
                         <a:t>DRAM reads</a:t>
@@ -5711,7 +5711,7 @@
                     <a:lstStyle/>
                     <a:p>
                       <a:r>
-                        <a:rPr sz="1000" b="0">
+                        <a:rPr sz="1050" b="0">
                           <a:latin typeface="Calibri"/>
                         </a:rPr>
                         <a:t>×1.02</a:t>
@@ -5730,7 +5730,7 @@
                     <a:lstStyle/>
                     <a:p>
                       <a:r>
-                        <a:rPr sz="1000" b="0">
+                        <a:rPr sz="1050" b="0">
                           <a:latin typeface="Calibri"/>
                         </a:rPr>
                         <a:t>0.91</a:t>
@@ -5749,7 +5749,7 @@
                     <a:lstStyle/>
                     <a:p>
                       <a:r>
-                        <a:rPr sz="1000" b="0">
+                        <a:rPr sz="1050" b="0">
                           <a:latin typeface="Calibri"/>
                         </a:rPr>
                         <a:t>×/÷1.21</a:t>
@@ -5763,14 +5763,14 @@
                   </a:tcPr>
                 </a:tc>
               </a:tr>
-              <a:tr h="384048">
-                <a:tc>
-                  <a:txBody>
-                    <a:bodyPr/>
-                    <a:lstStyle/>
-                    <a:p>
-                      <a:r>
-                        <a:rPr sz="1000" b="1">
+              <a:tr h="420624">
+                <a:tc>
+                  <a:txBody>
+                    <a:bodyPr/>
+                    <a:lstStyle/>
+                    <a:p>
+                      <a:r>
+                        <a:rPr sz="1050" b="1">
                           <a:latin typeface="Calibri"/>
                         </a:rPr>
                         <a:t>DRAM writes</a:t>
@@ -5789,7 +5789,7 @@
                     <a:lstStyle/>
                     <a:p>
                       <a:r>
-                        <a:rPr sz="1000" b="0">
+                        <a:rPr sz="1050" b="0">
                           <a:latin typeface="Calibri"/>
                         </a:rPr>
                         <a:t>×1.11</a:t>
@@ -5808,7 +5808,7 @@
                     <a:lstStyle/>
                     <a:p>
                       <a:r>
-                        <a:rPr sz="1000" b="0">
+                        <a:rPr sz="1050" b="0">
                           <a:latin typeface="Calibri"/>
                         </a:rPr>
                         <a:t>0.83</a:t>
@@ -5827,7 +5827,7 @@
                     <a:lstStyle/>
                     <a:p>
                       <a:r>
-                        <a:rPr sz="1000" b="0">
+                        <a:rPr sz="1050" b="0">
                           <a:latin typeface="Calibri"/>
                         </a:rPr>
                         <a:t>×/÷1.28</a:t>
@@ -5841,14 +5841,14 @@
                   </a:tcPr>
                 </a:tc>
               </a:tr>
-              <a:tr h="384048">
-                <a:tc>
-                  <a:txBody>
-                    <a:bodyPr/>
-                    <a:lstStyle/>
-                    <a:p>
-                      <a:r>
-                        <a:rPr sz="1000" b="1">
+              <a:tr h="420624">
+                <a:tc>
+                  <a:txBody>
+                    <a:bodyPr/>
+                    <a:lstStyle/>
+                    <a:p>
+                      <a:r>
+                        <a:rPr sz="1050" b="1">
                           <a:latin typeface="Calibri"/>
                         </a:rPr>
                         <a:t>DRAM-quiet screening</a:t>
@@ -5867,7 +5867,7 @@
                     <a:lstStyle/>
                     <a:p>
                       <a:r>
-                        <a:rPr sz="1000" b="0">
+                        <a:rPr sz="1050" b="0">
                           <a:latin typeface="Calibri"/>
                         </a:rPr>
                         <a:t>yes/no</a:t>
@@ -5886,7 +5886,7 @@
                     <a:lstStyle/>
                     <a:p>
                       <a:r>
-                        <a:rPr sz="1000" b="0">
+                        <a:rPr sz="1050" b="0">
                           <a:latin typeface="Calibri"/>
                         </a:rPr>
                         <a:t>100%</a:t>
@@ -5905,7 +5905,7 @@
                     <a:lstStyle/>
                     <a:p>
                       <a:r>
-                        <a:rPr sz="1000" b="0">
+                        <a:rPr sz="1050" b="0">
                           <a:latin typeface="Calibri"/>
                         </a:rPr>
                         <a:t>—</a:t>
@@ -5919,14 +5919,14 @@
                   </a:tcPr>
                 </a:tc>
               </a:tr>
-              <a:tr h="384048">
-                <a:tc>
-                  <a:txBody>
-                    <a:bodyPr/>
-                    <a:lstStyle/>
-                    <a:p>
-                      <a:r>
-                        <a:rPr sz="1000" b="1">
+              <a:tr h="420624">
+                <a:tc>
+                  <a:txBody>
+                    <a:bodyPr/>
+                    <a:lstStyle/>
+                    <a:p>
+                      <a:r>
+                        <a:rPr sz="1050" b="1">
                           <a:latin typeface="Calibri"/>
                         </a:rPr>
                         <a:t>User + kernel instructions</a:t>
@@ -5945,7 +5945,7 @@
                     <a:lstStyle/>
                     <a:p>
                       <a:r>
-                        <a:rPr sz="1000" b="0">
+                        <a:rPr sz="1050" b="0">
                           <a:latin typeface="Calibri"/>
                         </a:rPr>
                         <a:t>system mode</a:t>
@@ -5964,7 +5964,7 @@
                     <a:lstStyle/>
                     <a:p>
                       <a:r>
-                        <a:rPr sz="1000" b="0">
+                        <a:rPr sz="1050" b="0">
                           <a:latin typeface="Calibri"/>
                         </a:rPr>
                         <a:t>10.0% kernel</a:t>
@@ -5983,7 +5983,7 @@
                     <a:lstStyle/>
                     <a:p>
                       <a:r>
-                        <a:rPr sz="1000" b="0">
+                        <a:rPr sz="1050" b="0">
                           <a:latin typeface="Calibri"/>
                         </a:rPr>
                         <a:t>measured</a:t>
@@ -6046,7 +6046,7 @@
         </p:nvGraphicFramePr>
         <p:xfrm>
           <a:off x="6309360" y="2157984"/>
-          <a:ext cx="5303520" cy="1536192"/>
+          <a:ext cx="5303520" cy="1682496"/>
         </p:xfrm>
         <a:graphic>
           <a:graphicData uri="http://schemas.openxmlformats.org/drawingml/2006/table">
@@ -6058,14 +6058,14 @@
                 <a:gridCol w="2194560"/>
                 <a:gridCol w="3108960"/>
               </a:tblGrid>
-              <a:tr h="384048">
-                <a:tc>
-                  <a:txBody>
-                    <a:bodyPr/>
-                    <a:lstStyle/>
-                    <a:p>
-                      <a:r>
-                        <a:rPr sz="1000" b="1">
+              <a:tr h="420624">
+                <a:tc>
+                  <a:txBody>
+                    <a:bodyPr/>
+                    <a:lstStyle/>
+                    <a:p>
+                      <a:r>
+                        <a:rPr sz="1050" b="1">
                           <a:solidFill>
                             <a:srgbClr val="FFFFFF"/>
                           </a:solidFill>
@@ -6087,7 +6087,7 @@
                     <a:lstStyle/>
                     <a:p>
                       <a:r>
-                        <a:rPr sz="1000" b="1">
+                        <a:rPr sz="1050" b="1">
                           <a:solidFill>
                             <a:srgbClr val="FFFFFF"/>
                           </a:solidFill>
@@ -6104,14 +6104,14 @@
                   </a:tcPr>
                 </a:tc>
               </a:tr>
-              <a:tr h="384048">
-                <a:tc>
-                  <a:txBody>
-                    <a:bodyPr/>
-                    <a:lstStyle/>
-                    <a:p>
-                      <a:r>
-                        <a:rPr sz="1000" b="1">
+              <a:tr h="420624">
+                <a:tc>
+                  <a:txBody>
+                    <a:bodyPr/>
+                    <a:lstStyle/>
+                    <a:p>
+                      <a:r>
+                        <a:rPr sz="1050" b="1">
                           <a:latin typeface="Calibri"/>
                         </a:rPr>
                         <a:t>Accelerator compute</a:t>
@@ -6130,7 +6130,7 @@
                     <a:lstStyle/>
                     <a:p>
                       <a:r>
-                        <a:rPr sz="1000" b="0">
+                        <a:rPr sz="1050" b="0">
                           <a:latin typeface="Calibri"/>
                         </a:rPr>
                         <a:t>NPU model in build; GPU next</a:t>
@@ -6144,14 +6144,14 @@
                   </a:tcPr>
                 </a:tc>
               </a:tr>
-              <a:tr h="384048">
-                <a:tc>
-                  <a:txBody>
-                    <a:bodyPr/>
-                    <a:lstStyle/>
-                    <a:p>
-                      <a:r>
-                        <a:rPr sz="1000" b="1">
+              <a:tr h="420624">
+                <a:tc>
+                  <a:txBody>
+                    <a:bodyPr/>
+                    <a:lstStyle/>
+                    <a:p>
+                      <a:r>
+                        <a:rPr sz="1050" b="1">
                           <a:latin typeface="Calibri"/>
                         </a:rPr>
                         <a:t>DMA payload bytes</a:t>
@@ -6170,7 +6170,7 @@
                     <a:lstStyle/>
                     <a:p>
                       <a:r>
-                        <a:rPr sz="1000" b="0">
+                        <a:rPr sz="1050" b="0">
                           <a:latin typeface="Calibri"/>
                         </a:rPr>
                         <a:t>known to the device model, not yet counted</a:t>
@@ -6184,14 +6184,14 @@
                   </a:tcPr>
                 </a:tc>
               </a:tr>
-              <a:tr h="384048">
-                <a:tc>
-                  <a:txBody>
-                    <a:bodyPr/>
-                    <a:lstStyle/>
-                    <a:p>
-                      <a:r>
-                        <a:rPr sz="1000" b="1">
+              <a:tr h="420624">
+                <a:tc>
+                  <a:txBody>
+                    <a:bodyPr/>
+                    <a:lstStyle/>
+                    <a:p>
+                      <a:r>
+                        <a:rPr sz="1050" b="1">
                           <a:latin typeface="Calibri"/>
                         </a:rPr>
                         <a:t>Core identity, DVFS point</a:t>
@@ -6210,7 +6210,7 @@
                     <a:lstStyle/>
                     <a:p>
                       <a:r>
-                        <a:rPr sz="1000" b="0">
+                        <a:rPr sz="1050" b="0">
                           <a:latin typeface="Calibri"/>
                         </a:rPr>
                         <a:t>QEMU has no frequency notion</a:t>
@@ -6236,7 +6236,7 @@
         </p:nvSpPr>
         <p:spPr>
           <a:xfrm>
-            <a:off x="548640" y="4590288"/>
+            <a:off x="548640" y="4773168"/>
             <a:ext cx="11064240" cy="292608"/>
           </a:xfrm>
           <a:prstGeom prst="rect">
@@ -6271,7 +6271,7 @@
         </p:nvSpPr>
         <p:spPr>
           <a:xfrm>
-            <a:off x="548640" y="4882896"/>
+            <a:off x="548640" y="5065776"/>
             <a:ext cx="11064240" cy="457200"/>
           </a:xfrm>
           <a:prstGeom prst="rect">
@@ -6306,7 +6306,7 @@
         </p:nvSpPr>
         <p:spPr>
           <a:xfrm>
-            <a:off x="548640" y="5504688"/>
+            <a:off x="548640" y="5669280"/>
             <a:ext cx="11064240" cy="274320"/>
           </a:xfrm>
           <a:prstGeom prst="rect">
@@ -6341,7 +6341,7 @@
         </p:nvSpPr>
         <p:spPr>
           <a:xfrm>
-            <a:off x="548640" y="5779008"/>
+            <a:off x="548640" y="5943600"/>
             <a:ext cx="11064240" cy="365760"/>
           </a:xfrm>
           <a:prstGeom prst="rect">
@@ -6376,8 +6376,8 @@
         </p:nvSpPr>
         <p:spPr>
           <a:xfrm>
-            <a:off x="548640" y="6181344"/>
-            <a:ext cx="11064240" cy="320040"/>
+            <a:off x="548640" y="6327648"/>
+            <a:ext cx="11064240" cy="292608"/>
           </a:xfrm>
           <a:prstGeom prst="rect">
             <a:avLst/>
@@ -6572,7 +6572,7 @@
                 </a:solidFill>
                 <a:latin typeface="Calibri"/>
               </a:rPr>
-              <a:t>wattson xcheck rev 2 · QEMU counts DERIVED, PMU/DDR counts MEASURED · 2026-08-30</a:t>
+              <a:t>wattson xcheck · QEMU counts DERIVED, PMU/DDR counts MEASURED · 2026-08-31</a:t>
             </a:r>
           </a:p>
         </p:txBody>
@@ -6620,8 +6620,8 @@
         </p:nvSpPr>
         <p:spPr>
           <a:xfrm>
-            <a:off x="548640" y="1060704"/>
-            <a:ext cx="11155680" cy="329184"/>
+            <a:off x="548640" y="1042415"/>
+            <a:ext cx="11155680" cy="310896"/>
           </a:xfrm>
           <a:prstGeom prst="rect">
             <a:avLst/>
@@ -6636,7 +6636,7 @@
           <a:p>
             <a:pPr algn="l"/>
             <a:r>
-              <a:rPr sz="1300" b="1">
+              <a:rPr sz="1250" b="1">
                 <a:solidFill>
                   <a:srgbClr val="202124"/>
                 </a:solidFill>
@@ -6656,8 +6656,8 @@
           <p:nvPr/>
         </p:nvGraphicFramePr>
         <p:xfrm>
-          <a:off x="548640" y="1481328"/>
-          <a:ext cx="11064240" cy="1609344"/>
+          <a:off x="548640" y="1572768"/>
+          <a:ext cx="11064240" cy="1682496"/>
         </p:xfrm>
         <a:graphic>
           <a:graphicData uri="http://schemas.openxmlformats.org/drawingml/2006/table">
@@ -6669,7 +6669,7 @@
                 <a:gridCol w="1828800"/>
                 <a:gridCol w="9235440"/>
               </a:tblGrid>
-              <a:tr h="402336">
+              <a:tr h="420624">
                 <a:tc>
                   <a:txBody>
                     <a:bodyPr/>
@@ -6715,7 +6715,7 @@
                   </a:tcPr>
                 </a:tc>
               </a:tr>
-              <a:tr h="402336">
+              <a:tr h="420624">
                 <a:tc>
                   <a:txBody>
                     <a:bodyPr/>
@@ -6755,7 +6755,7 @@
                   </a:tcPr>
                 </a:tc>
               </a:tr>
-              <a:tr h="402336">
+              <a:tr h="420624">
                 <a:tc>
                   <a:txBody>
                     <a:bodyPr/>
@@ -6795,7 +6795,7 @@
                   </a:tcPr>
                 </a:tc>
               </a:tr>
-              <a:tr h="402336">
+              <a:tr h="420624">
                 <a:tc>
                   <a:txBody>
                     <a:bodyPr/>
@@ -6847,7 +6847,7 @@
         </p:nvSpPr>
         <p:spPr>
           <a:xfrm>
-            <a:off x="548640" y="3063240"/>
+            <a:off x="548640" y="3127248"/>
             <a:ext cx="11064240" cy="1051560"/>
           </a:xfrm>
           <a:prstGeom prst="roundRect">
@@ -6892,7 +6892,7 @@
         </p:nvSpPr>
         <p:spPr>
           <a:xfrm>
-            <a:off x="822960" y="3182112"/>
+            <a:off x="822960" y="3246120"/>
             <a:ext cx="10515600" cy="365760"/>
           </a:xfrm>
           <a:prstGeom prst="rect">
@@ -6927,7 +6927,7 @@
         </p:nvSpPr>
         <p:spPr>
           <a:xfrm>
-            <a:off x="822960" y="3611880"/>
+            <a:off x="822960" y="3675887"/>
             <a:ext cx="10515600" cy="411480"/>
           </a:xfrm>
           <a:prstGeom prst="rect">
@@ -6963,8 +6963,8 @@
           <p:nvPr/>
         </p:nvGraphicFramePr>
         <p:xfrm>
-          <a:off x="548640" y="4261104"/>
-          <a:ext cx="11064240" cy="1920240"/>
+          <a:off x="548640" y="4297680"/>
+          <a:ext cx="11064240" cy="1828800"/>
         </p:xfrm>
         <a:graphic>
           <a:graphicData uri="http://schemas.openxmlformats.org/drawingml/2006/table">
@@ -6977,14 +6977,14 @@
                 <a:gridCol w="3931920"/>
                 <a:gridCol w="6675120"/>
               </a:tblGrid>
-              <a:tr h="384048">
-                <a:tc>
-                  <a:txBody>
-                    <a:bodyPr/>
-                    <a:lstStyle/>
-                    <a:p>
-                      <a:r>
-                        <a:rPr sz="1050" b="1">
+              <a:tr h="365760">
+                <a:tc>
+                  <a:txBody>
+                    <a:bodyPr/>
+                    <a:lstStyle/>
+                    <a:p>
+                      <a:r>
+                        <a:rPr sz="1000" b="1">
                           <a:solidFill>
                             <a:srgbClr val="FFFFFF"/>
                           </a:solidFill>
@@ -7006,7 +7006,7 @@
                     <a:lstStyle/>
                     <a:p>
                       <a:r>
-                        <a:rPr sz="1050" b="1">
+                        <a:rPr sz="1000" b="1">
                           <a:solidFill>
                             <a:srgbClr val="FFFFFF"/>
                           </a:solidFill>
@@ -7028,7 +7028,7 @@
                     <a:lstStyle/>
                     <a:p>
                       <a:r>
-                        <a:rPr sz="1050" b="1">
+                        <a:rPr sz="1000" b="1">
                           <a:solidFill>
                             <a:srgbClr val="FFFFFF"/>
                           </a:solidFill>
@@ -7045,14 +7045,14 @@
                   </a:tcPr>
                 </a:tc>
               </a:tr>
-              <a:tr h="384048">
-                <a:tc>
-                  <a:txBody>
-                    <a:bodyPr/>
-                    <a:lstStyle/>
-                    <a:p>
-                      <a:r>
-                        <a:rPr sz="1050" b="0">
+              <a:tr h="365760">
+                <a:tc>
+                  <a:txBody>
+                    <a:bodyPr/>
+                    <a:lstStyle/>
+                    <a:p>
+                      <a:r>
+                        <a:rPr sz="1000" b="0">
                           <a:latin typeface="Calibri"/>
                         </a:rPr>
                         <a:t>1</a:t>
@@ -7071,7 +7071,7 @@
                     <a:lstStyle/>
                     <a:p>
                       <a:r>
-                        <a:rPr sz="1050" b="1">
+                        <a:rPr sz="1000" b="1">
                           <a:latin typeface="Calibri"/>
                         </a:rPr>
                         <a:t>Pick the saturating reference per block</a:t>
@@ -7090,7 +7090,7 @@
                     <a:lstStyle/>
                     <a:p>
                       <a:r>
-                        <a:rPr sz="1050" b="0">
+                        <a:rPr sz="1000" b="0">
                           <a:latin typeface="Calibri"/>
                         </a:rPr>
                         <a:t>we ship the microbenches: alu saturates the pipeline, mem the memory system</a:t>
@@ -7104,14 +7104,14 @@
                   </a:tcPr>
                 </a:tc>
               </a:tr>
-              <a:tr h="384048">
-                <a:tc>
-                  <a:txBody>
-                    <a:bodyPr/>
-                    <a:lstStyle/>
-                    <a:p>
-                      <a:r>
-                        <a:rPr sz="1050" b="0">
+              <a:tr h="365760">
+                <a:tc>
+                  <a:txBody>
+                    <a:bodyPr/>
+                    <a:lstStyle/>
+                    <a:p>
+                      <a:r>
+                        <a:rPr sz="1000" b="0">
                           <a:latin typeface="Calibri"/>
                         </a:rPr>
                         <a:t>2</a:t>
@@ -7130,7 +7130,7 @@
                     <a:lstStyle/>
                     <a:p>
                       <a:r>
-                        <a:rPr sz="1050" b="1">
+                        <a:rPr sz="1000" b="1">
                           <a:latin typeface="Calibri"/>
                         </a:rPr>
                         <a:t>Measure the application</a:t>
@@ -7149,7 +7149,7 @@
                     <a:lstStyle/>
                     <a:p>
                       <a:r>
-                        <a:rPr sz="1050" b="0">
+                        <a:rPr sz="1000" b="0">
                           <a:latin typeface="Calibri"/>
                         </a:rPr>
                         <a:t>afgen gives counts; U = app activity ÷ saturating activity</a:t>
@@ -7163,14 +7163,14 @@
                   </a:tcPr>
                 </a:tc>
               </a:tr>
-              <a:tr h="384048">
-                <a:tc>
-                  <a:txBody>
-                    <a:bodyPr/>
-                    <a:lstStyle/>
-                    <a:p>
-                      <a:r>
-                        <a:rPr sz="1050" b="0">
+              <a:tr h="365760">
+                <a:tc>
+                  <a:txBody>
+                    <a:bodyPr/>
+                    <a:lstStyle/>
+                    <a:p>
+                      <a:r>
+                        <a:rPr sz="1000" b="0">
                           <a:latin typeface="Calibri"/>
                         </a:rPr>
                         <a:t>3</a:t>
@@ -7189,7 +7189,7 @@
                     <a:lstStyle/>
                     <a:p>
                       <a:r>
-                        <a:rPr sz="1050" b="1">
+                        <a:rPr sz="1000" b="1">
                           <a:latin typeface="Calibri"/>
                         </a:rPr>
                         <a:t>Scale your existing anchor</a:t>
@@ -7208,7 +7208,7 @@
                     <a:lstStyle/>
                     <a:p>
                       <a:r>
-                        <a:rPr sz="1050" b="0">
+                        <a:rPr sz="1000" b="0">
                           <a:latin typeface="Calibri"/>
                         </a:rPr>
                         <a:t>AF = 5% × U. Spreadsheet unchanged, physics unchanged, one guess replaced</a:t>
@@ -7222,14 +7222,14 @@
                   </a:tcPr>
                 </a:tc>
               </a:tr>
-              <a:tr h="384048">
-                <a:tc>
-                  <a:txBody>
-                    <a:bodyPr/>
-                    <a:lstStyle/>
-                    <a:p>
-                      <a:r>
-                        <a:rPr sz="1050" b="0">
+              <a:tr h="365760">
+                <a:tc>
+                  <a:txBody>
+                    <a:bodyPr/>
+                    <a:lstStyle/>
+                    <a:p>
+                      <a:r>
+                        <a:rPr sz="1000" b="0">
                           <a:latin typeface="Calibri"/>
                         </a:rPr>
                         <a:t>4</a:t>
@@ -7248,7 +7248,7 @@
                     <a:lstStyle/>
                     <a:p>
                       <a:r>
-                        <a:rPr sz="1050" b="1">
+                        <a:rPr sz="1000" b="1">
                           <a:latin typeface="Calibri"/>
                         </a:rPr>
                         <a:t>Validate once on silicon</a:t>
@@ -7267,7 +7267,7 @@
                     <a:lstStyle/>
                     <a:p>
                       <a:r>
-                        <a:rPr sz="1050" b="0">
+                        <a:rPr sz="1000" b="0">
                           <a:latin typeface="Calibri"/>
                         </a:rPr>
                         <a:t>two rail measurements — idle and saturated — confirm the anchor is linear in U</a:t>
@@ -7293,8 +7293,8 @@
         </p:nvSpPr>
         <p:spPr>
           <a:xfrm>
-            <a:off x="548640" y="6053328"/>
-            <a:ext cx="11064240" cy="384048"/>
+            <a:off x="548640" y="6163056"/>
+            <a:ext cx="11064240" cy="329184"/>
           </a:xfrm>
           <a:prstGeom prst="rect">
             <a:avLst/>
@@ -7309,13 +7309,13 @@
           <a:p>
             <a:pPr algn="l"/>
             <a:r>
-              <a:rPr sz="1300" b="1">
+              <a:rPr sz="1200" b="1">
                 <a:solidFill>
                   <a:srgbClr val="187A33"/>
                 </a:solidFill>
                 <a:latin typeface="Calibri"/>
               </a:rPr>
-              <a:t>THE TURN-AROUND:  today you assume 3% and get the power of an abstraction. This way you name an application — "what does Pac-Man cost?" — and get the power of that application.</a:t>
+              <a:t>THE TURN-AROUND: today you assume 3% and get the power of an abstraction. Name an application instead — "what does Pac-Man cost?" — and get the power of that application.</a:t>
             </a:r>
           </a:p>
         </p:txBody>
@@ -7489,7 +7489,7 @@
                 </a:solidFill>
                 <a:latin typeface="Calibri"/>
               </a:rPr>
-              <a:t>wattson xcheck rev 2 · QEMU counts DERIVED, PMU/DDR counts MEASURED · 2026-08-30</a:t>
+              <a:t>wattson xcheck · QEMU counts DERIVED, PMU/DDR counts MEASURED · 2026-08-31</a:t>
             </a:r>
           </a:p>
         </p:txBody>
@@ -7924,7 +7924,7 @@
         </p:nvSpPr>
         <p:spPr>
           <a:xfrm>
-            <a:off x="548640" y="3584448"/>
+            <a:off x="548640" y="3474720"/>
             <a:ext cx="11064240" cy="292608"/>
           </a:xfrm>
           <a:prstGeom prst="rect">
@@ -7960,8 +7960,8 @@
           <p:nvPr/>
         </p:nvGraphicFramePr>
         <p:xfrm>
-          <a:off x="548640" y="3877056"/>
-          <a:ext cx="6035040" cy="1975104"/>
+          <a:off x="548640" y="3767328"/>
+          <a:ext cx="6035040" cy="2304288"/>
         </p:xfrm>
         <a:graphic>
           <a:graphicData uri="http://schemas.openxmlformats.org/drawingml/2006/table">
@@ -7974,14 +7974,14 @@
                 <a:gridCol w="1828800"/>
                 <a:gridCol w="1828800"/>
               </a:tblGrid>
-              <a:tr h="329184">
-                <a:tc>
-                  <a:txBody>
-                    <a:bodyPr/>
-                    <a:lstStyle/>
-                    <a:p>
-                      <a:r>
-                        <a:rPr sz="1000" b="1">
+              <a:tr h="384048">
+                <a:tc>
+                  <a:txBody>
+                    <a:bodyPr/>
+                    <a:lstStyle/>
+                    <a:p>
+                      <a:r>
+                        <a:rPr sz="1050" b="1">
                           <a:solidFill>
                             <a:srgbClr val="FFFFFF"/>
                           </a:solidFill>
@@ -8003,7 +8003,7 @@
                     <a:lstStyle/>
                     <a:p>
                       <a:r>
-                        <a:rPr sz="1000" b="1">
+                        <a:rPr sz="1050" b="1">
                           <a:solidFill>
                             <a:srgbClr val="FFFFFF"/>
                           </a:solidFill>
@@ -8025,7 +8025,7 @@
                     <a:lstStyle/>
                     <a:p>
                       <a:r>
-                        <a:rPr sz="1000" b="1">
+                        <a:rPr sz="1050" b="1">
                           <a:solidFill>
                             <a:srgbClr val="FFFFFF"/>
                           </a:solidFill>
@@ -8042,14 +8042,14 @@
                   </a:tcPr>
                 </a:tc>
               </a:tr>
-              <a:tr h="329184">
-                <a:tc>
-                  <a:txBody>
-                    <a:bodyPr/>
-                    <a:lstStyle/>
-                    <a:p>
-                      <a:r>
-                        <a:rPr sz="1000" b="1">
+              <a:tr h="384048">
+                <a:tc>
+                  <a:txBody>
+                    <a:bodyPr/>
+                    <a:lstStyle/>
+                    <a:p>
+                      <a:r>
+                        <a:rPr sz="1050" b="1">
                           <a:latin typeface="Calibri"/>
                         </a:rPr>
                         <a:t>integer ALU</a:t>
@@ -8068,7 +8068,7 @@
                     <a:lstStyle/>
                     <a:p>
                       <a:r>
-                        <a:rPr sz="1000" b="0">
+                        <a:rPr sz="1050" b="0">
                           <a:latin typeface="Calibri"/>
                         </a:rPr>
                         <a:t>28.1%</a:t>
@@ -8087,7 +8087,7 @@
                     <a:lstStyle/>
                     <a:p>
                       <a:r>
-                        <a:rPr sz="1000" b="0">
+                        <a:rPr sz="1050" b="0">
                           <a:latin typeface="Calibri"/>
                         </a:rPr>
                         <a:t>36.9%</a:t>
@@ -8101,14 +8101,14 @@
                   </a:tcPr>
                 </a:tc>
               </a:tr>
-              <a:tr h="329184">
-                <a:tc>
-                  <a:txBody>
-                    <a:bodyPr/>
-                    <a:lstStyle/>
-                    <a:p>
-                      <a:r>
-                        <a:rPr sz="1000" b="1">
+              <a:tr h="384048">
+                <a:tc>
+                  <a:txBody>
+                    <a:bodyPr/>
+                    <a:lstStyle/>
+                    <a:p>
+                      <a:r>
+                        <a:rPr sz="1050" b="1">
                           <a:latin typeface="Calibri"/>
                         </a:rPr>
                         <a:t>load / store</a:t>
@@ -8127,7 +8127,7 @@
                     <a:lstStyle/>
                     <a:p>
                       <a:r>
-                        <a:rPr sz="1000" b="0">
+                        <a:rPr sz="1050" b="0">
                           <a:latin typeface="Calibri"/>
                         </a:rPr>
                         <a:t>52.2%</a:t>
@@ -8146,7 +8146,7 @@
                     <a:lstStyle/>
                     <a:p>
                       <a:r>
-                        <a:rPr sz="1000" b="0">
+                        <a:rPr sz="1050" b="0">
                           <a:latin typeface="Calibri"/>
                         </a:rPr>
                         <a:t>41.9%</a:t>
@@ -8160,14 +8160,14 @@
                   </a:tcPr>
                 </a:tc>
               </a:tr>
-              <a:tr h="329184">
-                <a:tc>
-                  <a:txBody>
-                    <a:bodyPr/>
-                    <a:lstStyle/>
-                    <a:p>
-                      <a:r>
-                        <a:rPr sz="1000" b="1">
+              <a:tr h="384048">
+                <a:tc>
+                  <a:txBody>
+                    <a:bodyPr/>
+                    <a:lstStyle/>
+                    <a:p>
+                      <a:r>
+                        <a:rPr sz="1050" b="1">
                           <a:latin typeface="Calibri"/>
                         </a:rPr>
                         <a:t>branch</a:t>
@@ -8186,7 +8186,7 @@
                     <a:lstStyle/>
                     <a:p>
                       <a:r>
-                        <a:rPr sz="1000" b="0">
+                        <a:rPr sz="1050" b="0">
                           <a:latin typeface="Calibri"/>
                         </a:rPr>
                         <a:t>19.7%</a:t>
@@ -8205,7 +8205,7 @@
                     <a:lstStyle/>
                     <a:p>
                       <a:r>
-                        <a:rPr sz="1000" b="0">
+                        <a:rPr sz="1050" b="0">
                           <a:latin typeface="Calibri"/>
                         </a:rPr>
                         <a:t>19.9%</a:t>
@@ -8219,14 +8219,14 @@
                   </a:tcPr>
                 </a:tc>
               </a:tr>
-              <a:tr h="329184">
-                <a:tc>
-                  <a:txBody>
-                    <a:bodyPr/>
-                    <a:lstStyle/>
-                    <a:p>
-                      <a:r>
-                        <a:rPr sz="1000" b="1">
+              <a:tr h="384048">
+                <a:tc>
+                  <a:txBody>
+                    <a:bodyPr/>
+                    <a:lstStyle/>
+                    <a:p>
+                      <a:r>
+                        <a:rPr sz="1050" b="1">
                           <a:latin typeface="Calibri"/>
                         </a:rPr>
                         <a:t>FP / SIMD</a:t>
@@ -8245,7 +8245,7 @@
                     <a:lstStyle/>
                     <a:p>
                       <a:r>
-                        <a:rPr sz="1000" b="0">
+                        <a:rPr sz="1050" b="0">
                           <a:latin typeface="Calibri"/>
                         </a:rPr>
                         <a:t>0.1%</a:t>
@@ -8264,7 +8264,7 @@
                     <a:lstStyle/>
                     <a:p>
                       <a:r>
-                        <a:rPr sz="1000" b="0">
+                        <a:rPr sz="1050" b="0">
                           <a:latin typeface="Calibri"/>
                         </a:rPr>
                         <a:t>1.3%</a:t>
@@ -8278,14 +8278,14 @@
                   </a:tcPr>
                 </a:tc>
               </a:tr>
-              <a:tr h="329184">
-                <a:tc>
-                  <a:txBody>
-                    <a:bodyPr/>
-                    <a:lstStyle/>
-                    <a:p>
-                      <a:r>
-                        <a:rPr sz="1000" b="1">
+              <a:tr h="384048">
+                <a:tc>
+                  <a:txBody>
+                    <a:bodyPr/>
+                    <a:lstStyle/>
+                    <a:p>
+                      <a:r>
+                        <a:rPr sz="1050" b="1">
                           <a:latin typeface="Calibri"/>
                         </a:rPr>
                         <a:t>total instructions</a:t>
@@ -8304,7 +8304,7 @@
                     <a:lstStyle/>
                     <a:p>
                       <a:r>
-                        <a:rPr sz="1000" b="0">
+                        <a:rPr sz="1050" b="0">
                           <a:latin typeface="Calibri"/>
                         </a:rPr>
                         <a:t>2.57 B</a:t>
@@ -8323,7 +8323,7 @@
                     <a:lstStyle/>
                     <a:p>
                       <a:r>
-                        <a:rPr sz="1000" b="0">
+                        <a:rPr sz="1050" b="0">
                           <a:latin typeface="Calibri"/>
                         </a:rPr>
                         <a:t>25.7 B</a:t>
@@ -8349,7 +8349,7 @@
         </p:nvSpPr>
         <p:spPr>
           <a:xfrm>
-            <a:off x="6858000" y="3877056"/>
+            <a:off x="6858000" y="3767328"/>
             <a:ext cx="4754880" cy="365760"/>
           </a:xfrm>
           <a:prstGeom prst="rect">
@@ -8384,7 +8384,7 @@
         </p:nvSpPr>
         <p:spPr>
           <a:xfrm>
-            <a:off x="6858000" y="4370832"/>
+            <a:off x="6858000" y="4261104"/>
             <a:ext cx="4754880" cy="1463040"/>
           </a:xfrm>
           <a:prstGeom prst="rect">
@@ -8419,7 +8419,7 @@
         </p:nvSpPr>
         <p:spPr>
           <a:xfrm>
-            <a:off x="548640" y="6053328"/>
+            <a:off x="548640" y="6126480"/>
             <a:ext cx="11064240" cy="365760"/>
           </a:xfrm>
           <a:prstGeom prst="rect">
@@ -8615,7 +8615,7 @@
                 </a:solidFill>
                 <a:latin typeface="Calibri"/>
               </a:rPr>
-              <a:t>wattson xcheck rev 2 · QEMU counts DERIVED, PMU/DDR counts MEASURED · 2026-08-30</a:t>
+              <a:t>wattson xcheck · QEMU counts DERIVED, PMU/DDR counts MEASURED · 2026-08-31</a:t>
             </a:r>
           </a:p>
         </p:txBody>
@@ -9450,7 +9450,7 @@
                 </a:solidFill>
                 <a:latin typeface="Calibri"/>
               </a:rPr>
-              <a:t>wattson xcheck rev 2 · QEMU counts DERIVED, PMU/DDR counts MEASURED · 2026-08-30</a:t>
+              <a:t>wattson xcheck · QEMU counts DERIVED, PMU/DDR counts MEASURED · 2026-08-31</a:t>
             </a:r>
           </a:p>
         </p:txBody>
@@ -9534,7 +9534,7 @@
         <p:spPr>
           <a:xfrm>
             <a:off x="548640" y="1444752"/>
-            <a:ext cx="5394960" cy="2514600"/>
+            <a:ext cx="5394960" cy="2240280"/>
           </a:xfrm>
           <a:prstGeom prst="roundRect">
             <a:avLst/>
@@ -9578,8 +9578,8 @@
         </p:nvSpPr>
         <p:spPr>
           <a:xfrm>
-            <a:off x="777240" y="1572768"/>
-            <a:ext cx="4937760" cy="320040"/>
+            <a:off x="777240" y="1536192"/>
+            <a:ext cx="4937760" cy="292608"/>
           </a:xfrm>
           <a:prstGeom prst="rect">
             <a:avLst/>
@@ -9594,7 +9594,7 @@
           <a:p>
             <a:pPr algn="l"/>
             <a:r>
-              <a:rPr sz="1500" b="1">
+              <a:rPr sz="1400" b="1">
                 <a:solidFill>
                   <a:srgbClr val="1A53A0"/>
                 </a:solidFill>
@@ -9613,8 +9613,8 @@
         </p:nvSpPr>
         <p:spPr>
           <a:xfrm>
-            <a:off x="777240" y="1965960"/>
-            <a:ext cx="5029200" cy="1737360"/>
+            <a:off x="777240" y="1847088"/>
+            <a:ext cx="4983480" cy="1828800"/>
           </a:xfrm>
           <a:prstGeom prst="rect">
             <a:avLst/>
@@ -9627,31 +9627,45 @@
           </a:bodyPr>
           <a:lstStyle/>
           <a:p>
-            <a:pPr algn="l"/>
-            <a:r>
-              <a:rPr sz="1100" b="0">
+            <a:pPr algn="l">
+              <a:spcAft>
+                <a:spcPts val="600"/>
+              </a:spcAft>
+            </a:pPr>
+            <a:r>
+              <a:rPr sz="1050" b="0">
                 <a:solidFill>
                   <a:srgbClr val="202124"/>
                 </a:solidFill>
                 <a:latin typeface="Calibri"/>
               </a:rPr>
-              <a:t>qemu-aarch64 + TCG plugins</a:t>
-            </a:r>
-          </a:p>
-          <a:p>
-            <a:r>
-              <a:rPr sz="1100">
+              <a:t>qemu-aarch64 + TCG plugins (libinsn, libcache)</a:t>
+            </a:r>
+          </a:p>
+          <a:p>
+            <a:pPr>
+              <a:spcAft>
+                <a:spcPts val="600"/>
+              </a:spcAft>
+            </a:pPr>
+            <a:r>
+              <a:rPr sz="1050">
                 <a:solidFill>
                   <a:srgbClr val="202124"/>
                 </a:solidFill>
                 <a:latin typeface="Calibri"/>
               </a:rPr>
-              <a:t>Cache model = the board's own hierarchy, from its sysfs:</a:t>
-            </a:r>
-          </a:p>
-          <a:p>
-            <a:r>
-              <a:rPr sz="1100">
+              <a:t>Cache model = the board's own hierarchy, read from its sysfs:</a:t>
+            </a:r>
+          </a:p>
+          <a:p>
+            <a:pPr>
+              <a:spcAft>
+                <a:spcPts val="600"/>
+              </a:spcAft>
+            </a:pPr>
+            <a:r>
+              <a:rPr sz="1050">
                 <a:solidFill>
                   <a:srgbClr val="202124"/>
                 </a:solidFill>
@@ -9661,25 +9675,67 @@
             </a:r>
           </a:p>
           <a:p>
-            <a:r>
-              <a:rPr sz="1100">
+            <a:pPr>
+              <a:spcAft>
+                <a:spcPts val="600"/>
+              </a:spcAft>
+            </a:pPr>
+            <a:r>
+              <a:rPr sz="1050">
                 <a:solidFill>
                   <a:srgbClr val="202124"/>
                 </a:solidFill>
                 <a:latin typeface="Calibri"/>
               </a:rPr>
-              <a:t>A55 write-streaming, writeback, stride prefetcher modelled</a:t>
-            </a:r>
-          </a:p>
-          <a:p>
-            <a:r>
-              <a:rPr sz="1100">
+              <a:t>A55 write-streaming, writeback and a stride prefetcher modelled</a:t>
+            </a:r>
+          </a:p>
+          <a:p>
+            <a:pPr>
+              <a:spcAft>
+                <a:spcPts val="600"/>
+              </a:spcAft>
+            </a:pPr>
+            <a:r>
+              <a:rPr sz="1050">
                 <a:solidFill>
                   <a:srgbClr val="202124"/>
                 </a:solidFill>
                 <a:latin typeface="Calibri"/>
               </a:rPr>
-              <a:t>L3 misses → read proxy · evictions → write proxy</a:t>
+              <a:t>L3 misses → DRAM-read proxy · evictions → DRAM-write proxy</a:t>
+            </a:r>
+          </a:p>
+          <a:p>
+            <a:pPr>
+              <a:spcAft>
+                <a:spcPts val="600"/>
+              </a:spcAft>
+            </a:pPr>
+            <a:r>
+              <a:rPr sz="1050">
+                <a:solidFill>
+                  <a:srgbClr val="202124"/>
+                </a:solidFill>
+                <a:latin typeface="Calibri"/>
+              </a:rPr>
+              <a:t>Two passes per app: prefetch pass for reads, base pass for writes</a:t>
+            </a:r>
+          </a:p>
+          <a:p>
+            <a:pPr>
+              <a:spcAft>
+                <a:spcPts val="600"/>
+              </a:spcAft>
+            </a:pPr>
+            <a:r>
+              <a:rPr sz="1050">
+                <a:solidFill>
+                  <a:srgbClr val="202124"/>
+                </a:solidFill>
+                <a:latin typeface="Calibri"/>
+              </a:rPr>
+              <a:t>Counts are per-run and frequency-free</a:t>
             </a:r>
           </a:p>
         </p:txBody>
@@ -9693,7 +9749,7 @@
         <p:spPr>
           <a:xfrm>
             <a:off x="6263640" y="1444752"/>
-            <a:ext cx="5394960" cy="2514600"/>
+            <a:ext cx="5394960" cy="2240280"/>
           </a:xfrm>
           <a:prstGeom prst="roundRect">
             <a:avLst/>
@@ -9737,8 +9793,8 @@
         </p:nvSpPr>
         <p:spPr>
           <a:xfrm>
-            <a:off x="6492240" y="1572768"/>
-            <a:ext cx="4937760" cy="320040"/>
+            <a:off x="6492240" y="1536192"/>
+            <a:ext cx="4937760" cy="292608"/>
           </a:xfrm>
           <a:prstGeom prst="rect">
             <a:avLst/>
@@ -9753,7 +9809,7 @@
           <a:p>
             <a:pPr algn="l"/>
             <a:r>
-              <a:rPr sz="1500" b="1">
+              <a:rPr sz="1400" b="1">
                 <a:solidFill>
                   <a:srgbClr val="1A53A0"/>
                 </a:solidFill>
@@ -9772,8 +9828,8 @@
         </p:nvSpPr>
         <p:spPr>
           <a:xfrm>
-            <a:off x="6492240" y="1965960"/>
-            <a:ext cx="5029200" cy="1737360"/>
+            <a:off x="6492240" y="1847088"/>
+            <a:ext cx="4983480" cy="1828800"/>
           </a:xfrm>
           <a:prstGeom prst="rect">
             <a:avLst/>
@@ -9786,9 +9842,13 @@
           </a:bodyPr>
           <a:lstStyle/>
           <a:p>
-            <a:pPr algn="l"/>
-            <a:r>
-              <a:rPr sz="1100" b="0">
+            <a:pPr algn="l">
+              <a:spcAft>
+                <a:spcPts val="600"/>
+              </a:spcAft>
+            </a:pPr>
+            <a:r>
+              <a:rPr sz="1050" b="0">
                 <a:solidFill>
                   <a:srgbClr val="202124"/>
                 </a:solidFill>
@@ -9798,19 +9858,29 @@
             </a:r>
           </a:p>
           <a:p>
-            <a:r>
-              <a:rPr sz="1100">
+            <a:pPr>
+              <a:spcAft>
+                <a:spcPts val="600"/>
+              </a:spcAft>
+            </a:pPr>
+            <a:r>
+              <a:rPr sz="1050">
                 <a:solidFill>
                   <a:srgbClr val="202124"/>
                 </a:solidFill>
                 <a:latin typeface="Calibri"/>
               </a:rPr>
-              <a:t>Core PMU: instructions, cycles, L1/L2/L3 refills</a:t>
-            </a:r>
-          </a:p>
-          <a:p>
-            <a:r>
-              <a:rPr sz="1100">
+              <a:t>Core PMU: instructions, cycles, L1/L2/L3 refill events</a:t>
+            </a:r>
+          </a:p>
+          <a:p>
+            <a:pPr>
+              <a:spcAft>
+                <a:spcPts val="600"/>
+              </a:spcAft>
+            </a:pPr>
+            <a:r>
+              <a:rPr sz="1050">
                 <a:solidFill>
                   <a:srgbClr val="202124"/>
                 </a:solidFill>
@@ -9820,8 +9890,13 @@
             </a:r>
           </a:p>
           <a:p>
-            <a:r>
-              <a:rPr sz="1100">
+            <a:pPr>
+              <a:spcAft>
+                <a:spcPts val="600"/>
+              </a:spcAft>
+            </a:pPr>
+            <a:r>
+              <a:rPr sz="1050">
                 <a:solidFill>
                   <a:srgbClr val="202124"/>
                 </a:solidFill>
@@ -9831,8 +9906,13 @@
             </a:r>
           </a:p>
           <a:p>
-            <a:r>
-              <a:rPr sz="1100">
+            <a:pPr>
+              <a:spcAft>
+                <a:spcPts val="600"/>
+              </a:spcAft>
+            </a:pPr>
+            <a:r>
+              <a:rPr sz="1050">
                 <a:solidFill>
                   <a:srgbClr val="202124"/>
                 </a:solidFill>
@@ -9841,18 +9921,95 @@
               <a:t>The DDR controller sees prefetch traffic the core PMU cannot</a:t>
             </a:r>
           </a:p>
-        </p:txBody>
-      </p:sp>
-      <p:sp>
-        <p:nvSpPr>
-          <p:cNvPr id="14" name="TextBox 13"/>
+          <a:p>
+            <a:pPr>
+              <a:spcAft>
+                <a:spcPts val="600"/>
+              </a:spcAft>
+            </a:pPr>
+            <a:r>
+              <a:rPr sz="1050">
+                <a:solidFill>
+                  <a:srgbClr val="202124"/>
+                </a:solidFill>
+                <a:latin typeface="Calibri"/>
+              </a:rPr>
+              <a:t>Medians of repeated runs, spreads recorded</a:t>
+            </a:r>
+          </a:p>
+          <a:p>
+            <a:pPr>
+              <a:spcAft>
+                <a:spcPts val="600"/>
+              </a:spcAft>
+            </a:pPr>
+            <a:r>
+              <a:rPr sz="1050">
+                <a:solidFill>
+                  <a:srgbClr val="202124"/>
+                </a:solidFill>
+                <a:latin typeface="Calibri"/>
+              </a:rPr>
+              <a:t>The same static binary is copied over, never rebuilt</a:t>
+            </a:r>
+          </a:p>
+        </p:txBody>
+      </p:sp>
+      <p:sp>
+        <p:nvSpPr>
+          <p:cNvPr id="14" name="Rounded Rectangle 13"/>
+          <p:cNvSpPr/>
+          <p:nvPr/>
+        </p:nvSpPr>
+        <p:spPr>
+          <a:xfrm>
+            <a:off x="548640" y="3858768"/>
+            <a:ext cx="5394960" cy="2267712"/>
+          </a:xfrm>
+          <a:prstGeom prst="roundRect">
+            <a:avLst/>
+          </a:prstGeom>
+          <a:solidFill>
+            <a:srgbClr val="FFFFFF"/>
+          </a:solidFill>
+          <a:ln w="12700">
+            <a:solidFill>
+              <a:srgbClr val="C4CEDB"/>
+            </a:solidFill>
+          </a:ln>
+        </p:spPr>
+        <p:style>
+          <a:lnRef idx="1">
+            <a:schemeClr val="accent1"/>
+          </a:lnRef>
+          <a:fillRef idx="3">
+            <a:schemeClr val="accent1"/>
+          </a:fillRef>
+          <a:effectRef idx="2">
+            <a:schemeClr val="accent1"/>
+          </a:effectRef>
+          <a:fontRef idx="minor">
+            <a:schemeClr val="lt1"/>
+          </a:fontRef>
+        </p:style>
+        <p:txBody>
+          <a:bodyPr rtlCol="0" anchor="ctr"/>
+          <a:lstStyle/>
+          <a:p>
+            <a:pPr algn="ctr"/>
+          </a:p>
+        </p:txBody>
+      </p:sp>
+      <p:sp>
+        <p:nvSpPr>
+          <p:cNvPr id="15" name="TextBox 14"/>
           <p:cNvSpPr txBox="1"/>
           <p:nvPr/>
         </p:nvSpPr>
         <p:spPr>
           <a:xfrm>
-            <a:off x="548640" y="4187952"/>
-            <a:ext cx="11064240" cy="292608"/>
+            <a:off x="777240" y="3950208"/>
+            <a:ext cx="4937760" cy="274320"/>
           </a:xfrm>
           <a:prstGeom prst="rect">
             <a:avLst/>
@@ -9880,14 +10037,14 @@
       </p:sp>
       <p:sp>
         <p:nvSpPr>
-          <p:cNvPr id="15" name="TextBox 14"/>
+          <p:cNvPr id="16" name="TextBox 15"/>
           <p:cNvSpPr txBox="1"/>
           <p:nvPr/>
         </p:nvSpPr>
         <p:spPr>
           <a:xfrm>
-            <a:off x="548640" y="4498848"/>
-            <a:ext cx="11064240" cy="822960"/>
+            <a:off x="777240" y="4261104"/>
+            <a:ext cx="4983480" cy="1783080"/>
           </a:xfrm>
           <a:prstGeom prst="rect">
             <a:avLst/>
@@ -9900,30 +10057,158 @@
           </a:bodyPr>
           <a:lstStyle/>
           <a:p>
-            <a:pPr algn="l"/>
-            <a:r>
-              <a:rPr sz="1200" b="0">
+            <a:pPr algn="l">
+              <a:spcAft>
+                <a:spcPts val="700"/>
+              </a:spcAft>
+            </a:pPr>
+            <a:r>
+              <a:rPr sz="1050" b="0">
                 <a:solidFill>
                   <a:srgbClr val="202124"/>
                 </a:solidFill>
                 <a:latin typeface="Calibri"/>
               </a:rPr>
-              <a:t>14 development apps: five microbench corners (ALU, streaming, pointer-chase, matmul, sort) plus stereo vision, two compressors, an interpreter, SHA-256, a JSON codec, SQLite, a game-AI trainer, an HTTP client.
-36 held-out apps, never seen by the model: busybox applets, crypto kernels, software renderers, bignum, hashing, parsers, sockets.</a:t>
-            </a:r>
-          </a:p>
-        </p:txBody>
-      </p:sp>
-      <p:sp>
-        <p:nvSpPr>
-          <p:cNvPr id="16" name="TextBox 15"/>
+              <a:t>14 development apps — five microbench corners (ALU, streaming,</a:t>
+            </a:r>
+          </a:p>
+          <a:p>
+            <a:pPr>
+              <a:spcAft>
+                <a:spcPts val="700"/>
+              </a:spcAft>
+            </a:pPr>
+            <a:r>
+              <a:rPr sz="1050">
+                <a:solidFill>
+                  <a:srgbClr val="202124"/>
+                </a:solidFill>
+                <a:latin typeface="Calibri"/>
+              </a:rPr>
+              <a:t>pointer-chase, matmul, sort) plus stereo vision, two compressors,</a:t>
+            </a:r>
+          </a:p>
+          <a:p>
+            <a:pPr>
+              <a:spcAft>
+                <a:spcPts val="700"/>
+              </a:spcAft>
+            </a:pPr>
+            <a:r>
+              <a:rPr sz="1050">
+                <a:solidFill>
+                  <a:srgbClr val="202124"/>
+                </a:solidFill>
+                <a:latin typeface="Calibri"/>
+              </a:rPr>
+              <a:t>an interpreter, SHA-256, a JSON codec, SQLite, a game-AI trainer</a:t>
+            </a:r>
+          </a:p>
+          <a:p>
+            <a:pPr>
+              <a:spcAft>
+                <a:spcPts val="700"/>
+              </a:spcAft>
+            </a:pPr>
+            <a:r>
+              <a:rPr sz="1050">
+                <a:solidFill>
+                  <a:srgbClr val="202124"/>
+                </a:solidFill>
+                <a:latin typeface="Calibri"/>
+              </a:rPr>
+              <a:t>and an HTTP client.</a:t>
+            </a:r>
+          </a:p>
+          <a:p>
+            <a:pPr>
+              <a:spcAft>
+                <a:spcPts val="700"/>
+              </a:spcAft>
+            </a:pPr>
+            <a:r>
+              <a:rPr sz="1050">
+                <a:solidFill>
+                  <a:srgbClr val="202124"/>
+                </a:solidFill>
+                <a:latin typeface="Calibri"/>
+              </a:rPr>
+              <a:t>36 held-out apps, never seen by the model — busybox applets,</a:t>
+            </a:r>
+          </a:p>
+          <a:p>
+            <a:pPr>
+              <a:spcAft>
+                <a:spcPts val="700"/>
+              </a:spcAft>
+            </a:pPr>
+            <a:r>
+              <a:rPr sz="1050">
+                <a:solidFill>
+                  <a:srgbClr val="202124"/>
+                </a:solidFill>
+                <a:latin typeface="Calibri"/>
+              </a:rPr>
+              <a:t>crypto kernels, software renderers, bignum, hashing, parsers, sockets.</a:t>
+            </a:r>
+          </a:p>
+        </p:txBody>
+      </p:sp>
+      <p:sp>
+        <p:nvSpPr>
+          <p:cNvPr id="17" name="Rounded Rectangle 16"/>
+          <p:cNvSpPr/>
+          <p:nvPr/>
+        </p:nvSpPr>
+        <p:spPr>
+          <a:xfrm>
+            <a:off x="6263640" y="3858768"/>
+            <a:ext cx="5394960" cy="2267712"/>
+          </a:xfrm>
+          <a:prstGeom prst="roundRect">
+            <a:avLst/>
+          </a:prstGeom>
+          <a:solidFill>
+            <a:srgbClr val="FFFFFF"/>
+          </a:solidFill>
+          <a:ln w="12700">
+            <a:solidFill>
+              <a:srgbClr val="C4CEDB"/>
+            </a:solidFill>
+          </a:ln>
+        </p:spPr>
+        <p:style>
+          <a:lnRef idx="1">
+            <a:schemeClr val="accent1"/>
+          </a:lnRef>
+          <a:fillRef idx="3">
+            <a:schemeClr val="accent1"/>
+          </a:fillRef>
+          <a:effectRef idx="2">
+            <a:schemeClr val="accent1"/>
+          </a:effectRef>
+          <a:fontRef idx="minor">
+            <a:schemeClr val="lt1"/>
+          </a:fontRef>
+        </p:style>
+        <p:txBody>
+          <a:bodyPr rtlCol="0" anchor="ctr"/>
+          <a:lstStyle/>
+          <a:p>
+            <a:pPr algn="ctr"/>
+          </a:p>
+        </p:txBody>
+      </p:sp>
+      <p:sp>
+        <p:nvSpPr>
+          <p:cNvPr id="18" name="TextBox 17"/>
           <p:cNvSpPr txBox="1"/>
           <p:nvPr/>
         </p:nvSpPr>
         <p:spPr>
           <a:xfrm>
-            <a:off x="548640" y="5989320"/>
-            <a:ext cx="11064240" cy="365760"/>
+            <a:off x="6492240" y="3950208"/>
+            <a:ext cx="4937760" cy="274320"/>
           </a:xfrm>
           <a:prstGeom prst="rect">
             <a:avLst/>
@@ -9938,13 +10223,132 @@
           <a:p>
             <a:pPr algn="l"/>
             <a:r>
-              <a:rPr sz="1150" b="0">
+              <a:rPr sz="1200" b="1">
                 <a:solidFill>
-                  <a:srgbClr val="5F6368"/>
+                  <a:srgbClr val="1A53A0"/>
                 </a:solidFill>
                 <a:latin typeface="Calibri"/>
               </a:rPr>
-              <a:t>Every app prints a checksum so dead-code elimination cannot fake a result; the vision app is hash-gated bit-exact against its published golden.</a:t>
+              <a:t>HOW A RUN IS ACCEPTED</a:t>
+            </a:r>
+          </a:p>
+        </p:txBody>
+      </p:sp>
+      <p:sp>
+        <p:nvSpPr>
+          <p:cNvPr id="19" name="TextBox 18"/>
+          <p:cNvSpPr txBox="1"/>
+          <p:nvPr/>
+        </p:nvSpPr>
+        <p:spPr>
+          <a:xfrm>
+            <a:off x="6492240" y="4261104"/>
+            <a:ext cx="4983480" cy="1783080"/>
+          </a:xfrm>
+          <a:prstGeom prst="rect">
+            <a:avLst/>
+          </a:prstGeom>
+          <a:noFill/>
+        </p:spPr>
+        <p:txBody>
+          <a:bodyPr wrap="square">
+            <a:spAutoFit/>
+          </a:bodyPr>
+          <a:lstStyle/>
+          <a:p>
+            <a:pPr algn="l">
+              <a:spcAft>
+                <a:spcPts val="700"/>
+              </a:spcAft>
+            </a:pPr>
+            <a:r>
+              <a:rPr sz="1050" b="0">
+                <a:solidFill>
+                  <a:srgbClr val="202124"/>
+                </a:solidFill>
+                <a:latin typeface="Calibri"/>
+              </a:rPr>
+              <a:t>Every app prints a checksum, so dead-code elimination cannot</a:t>
+            </a:r>
+          </a:p>
+          <a:p>
+            <a:pPr>
+              <a:spcAft>
+                <a:spcPts val="700"/>
+              </a:spcAft>
+            </a:pPr>
+            <a:r>
+              <a:rPr sz="1050">
+                <a:solidFill>
+                  <a:srgbClr val="202124"/>
+                </a:solidFill>
+                <a:latin typeface="Calibri"/>
+              </a:rPr>
+              <a:t>fake a result by optimising the work away.</a:t>
+            </a:r>
+          </a:p>
+          <a:p>
+            <a:pPr>
+              <a:spcAft>
+                <a:spcPts val="700"/>
+              </a:spcAft>
+            </a:pPr>
+            <a:r>
+              <a:rPr sz="1050">
+                <a:solidFill>
+                  <a:srgbClr val="202124"/>
+                </a:solidFill>
+                <a:latin typeface="Calibri"/>
+              </a:rPr>
+              <a:t>The vision app is hash-gated bit-exact against its published golden.</a:t>
+            </a:r>
+          </a:p>
+          <a:p>
+            <a:pPr>
+              <a:spcAft>
+                <a:spcPts val="700"/>
+              </a:spcAft>
+            </a:pPr>
+            <a:r>
+              <a:rPr sz="1050">
+                <a:solidFill>
+                  <a:srgbClr val="202124"/>
+                </a:solidFill>
+                <a:latin typeface="Calibri"/>
+              </a:rPr>
+              <a:t>Instruction agreement must pass before any cache-level number</a:t>
+            </a:r>
+          </a:p>
+          <a:p>
+            <a:pPr>
+              <a:spcAft>
+                <a:spcPts val="700"/>
+              </a:spcAft>
+            </a:pPr>
+            <a:r>
+              <a:rPr sz="1050">
+                <a:solidFill>
+                  <a:srgbClr val="202124"/>
+                </a:solidFill>
+                <a:latin typeface="Calibri"/>
+              </a:rPr>
+              <a:t>is read — a wrong instruction count invalidates everything downstream.</a:t>
+            </a:r>
+          </a:p>
+          <a:p>
+            <a:pPr>
+              <a:spcAft>
+                <a:spcPts val="700"/>
+              </a:spcAft>
+            </a:pPr>
+            <a:r>
+              <a:rPr sz="1050">
+                <a:solidFill>
+                  <a:srgbClr val="202124"/>
+                </a:solidFill>
+                <a:latin typeface="Calibri"/>
+              </a:rPr>
+              <a:t>DDR counts are idle-corrected over an equal-duration window.</a:t>
             </a:r>
           </a:p>
         </p:txBody>
@@ -10118,7 +10522,7 @@
                 </a:solidFill>
                 <a:latin typeface="Calibri"/>
               </a:rPr>
-              <a:t>wattson xcheck rev 2 · QEMU counts DERIVED, PMU/DDR counts MEASURED · 2026-08-30</a:t>
+              <a:t>wattson xcheck · QEMU counts DERIVED, PMU/DDR counts MEASURED · 2026-08-31</a:t>
             </a:r>
           </a:p>
         </p:txBody>
@@ -11841,7 +12245,7 @@
                 </a:solidFill>
                 <a:latin typeface="Calibri"/>
               </a:rPr>
-              <a:t>wattson xcheck rev 2 · QEMU counts DERIVED, PMU/DDR counts MEASURED · 2026-08-30</a:t>
+              <a:t>wattson xcheck · QEMU counts DERIVED, PMU/DDR counts MEASURED · 2026-08-31</a:t>
             </a:r>
           </a:p>
         </p:txBody>
@@ -12144,7 +12548,7 @@
                 </a:solidFill>
                 <a:latin typeface="Calibri"/>
               </a:rPr>
-              <a:t>wattson xcheck rev 2 · QEMU counts DERIVED, PMU/DDR counts MEASURED · 2026-08-30</a:t>
+              <a:t>wattson xcheck · QEMU counts DERIVED, PMU/DDR counts MEASURED · 2026-08-31</a:t>
             </a:r>
           </a:p>
         </p:txBody>

</xml_diff>